<commit_message>
feat: atualiza PPTs com cor #070F26 e bookmark colado à esquerda
- Corrige cor de fundo dark de #0E1B3E para #070F26 em todos os 8 módulos
- Posiciona bookmark_large_outline sem margem esquerda (x=0) nos slides de seção
- Atualiza asset bookmark_large_outline.png com nova versão de referência

Co-Authored-By: Claude Sonnet 4.6 <noreply@anthropic.com>
</commit_message>
<xml_diff>
--- a/modulos/01-sql-fundamentals/sessao-ao-vivo-sql-fundamentals.pptx
+++ b/modulos/01-sql-fundamentals/sessao-ao-vivo-sql-fundamentals.pptx
@@ -2,30 +2,30 @@
 <file path=ppt/presentation.xml><?xml version="1.0" encoding="utf-8"?>
 <p:presentation xmlns:p="http://schemas.openxmlformats.org/presentationml/2006/main">
   <p:sldMasterIdLst>
-    <p:sldMasterId xmlns:r="http://schemas.openxmlformats.org/officeDocument/2006/relationships" id="2147483648" r:id="Rc3c37cd2444f4a28"/>
+    <p:sldMasterId xmlns:r="http://schemas.openxmlformats.org/officeDocument/2006/relationships" id="2147483648" r:id="Rfcf803d83c26465a"/>
   </p:sldMasterIdLst>
   <p:notesMasterIdLst>
-    <p:notesMasterId xmlns:r="http://schemas.openxmlformats.org/officeDocument/2006/relationships" r:id="Rf1298e7f5e5449cf"/>
+    <p:notesMasterId xmlns:r="http://schemas.openxmlformats.org/officeDocument/2006/relationships" r:id="Rcce9e0072ee347bc"/>
   </p:notesMasterIdLst>
   <p:sldIdLst>
-    <p:sldId xmlns:r="http://schemas.openxmlformats.org/officeDocument/2006/relationships" id="256" r:id="R3da06fa3f4e04be0"/>
-    <p:sldId xmlns:r="http://schemas.openxmlformats.org/officeDocument/2006/relationships" id="257" r:id="R95499960768e48e7"/>
-    <p:sldId xmlns:r="http://schemas.openxmlformats.org/officeDocument/2006/relationships" id="258" r:id="Rf5bb7b1a1b8b434e"/>
-    <p:sldId xmlns:r="http://schemas.openxmlformats.org/officeDocument/2006/relationships" id="259" r:id="Rc363881b46834532"/>
-    <p:sldId xmlns:r="http://schemas.openxmlformats.org/officeDocument/2006/relationships" id="260" r:id="Rdc4ba1b4b80e4697"/>
-    <p:sldId xmlns:r="http://schemas.openxmlformats.org/officeDocument/2006/relationships" id="261" r:id="R93150aa10e754c37"/>
-    <p:sldId xmlns:r="http://schemas.openxmlformats.org/officeDocument/2006/relationships" id="262" r:id="Red7b51c7aaaf4c5f"/>
-    <p:sldId xmlns:r="http://schemas.openxmlformats.org/officeDocument/2006/relationships" id="263" r:id="Raf5ed46e81b24861"/>
-    <p:sldId xmlns:r="http://schemas.openxmlformats.org/officeDocument/2006/relationships" id="264" r:id="R298ed362f0174ada"/>
-    <p:sldId xmlns:r="http://schemas.openxmlformats.org/officeDocument/2006/relationships" id="265" r:id="Rf82f0162962143f2"/>
-    <p:sldId xmlns:r="http://schemas.openxmlformats.org/officeDocument/2006/relationships" id="266" r:id="Rd5c772613cc84988"/>
-    <p:sldId xmlns:r="http://schemas.openxmlformats.org/officeDocument/2006/relationships" id="267" r:id="Rddbffce9241a4ea5"/>
-    <p:sldId xmlns:r="http://schemas.openxmlformats.org/officeDocument/2006/relationships" id="268" r:id="R1d99f8e3f38e4ba6"/>
-    <p:sldId xmlns:r="http://schemas.openxmlformats.org/officeDocument/2006/relationships" id="269" r:id="R798f392237b34fcd"/>
-    <p:sldId xmlns:r="http://schemas.openxmlformats.org/officeDocument/2006/relationships" id="270" r:id="R768c302e71c44ee8"/>
-    <p:sldId xmlns:r="http://schemas.openxmlformats.org/officeDocument/2006/relationships" id="271" r:id="R0080a933432a4ecb"/>
-    <p:sldId xmlns:r="http://schemas.openxmlformats.org/officeDocument/2006/relationships" id="272" r:id="Rc249593a5f1e43c7"/>
-    <p:sldId xmlns:r="http://schemas.openxmlformats.org/officeDocument/2006/relationships" id="273" r:id="R8db292d283cd4112"/>
+    <p:sldId xmlns:r="http://schemas.openxmlformats.org/officeDocument/2006/relationships" id="256" r:id="R64696d4e72664470"/>
+    <p:sldId xmlns:r="http://schemas.openxmlformats.org/officeDocument/2006/relationships" id="257" r:id="R7ef691cffc634e4a"/>
+    <p:sldId xmlns:r="http://schemas.openxmlformats.org/officeDocument/2006/relationships" id="258" r:id="R30ea854cd00f4342"/>
+    <p:sldId xmlns:r="http://schemas.openxmlformats.org/officeDocument/2006/relationships" id="259" r:id="R544b1d1e61e94b06"/>
+    <p:sldId xmlns:r="http://schemas.openxmlformats.org/officeDocument/2006/relationships" id="260" r:id="Refe2973a0f654686"/>
+    <p:sldId xmlns:r="http://schemas.openxmlformats.org/officeDocument/2006/relationships" id="261" r:id="Rc5cdeb4db0db4d8a"/>
+    <p:sldId xmlns:r="http://schemas.openxmlformats.org/officeDocument/2006/relationships" id="262" r:id="R55c4afd6473e4c01"/>
+    <p:sldId xmlns:r="http://schemas.openxmlformats.org/officeDocument/2006/relationships" id="263" r:id="Rb90bd2b440dd42ae"/>
+    <p:sldId xmlns:r="http://schemas.openxmlformats.org/officeDocument/2006/relationships" id="264" r:id="R32884b9189014776"/>
+    <p:sldId xmlns:r="http://schemas.openxmlformats.org/officeDocument/2006/relationships" id="265" r:id="Reea44269d0f94257"/>
+    <p:sldId xmlns:r="http://schemas.openxmlformats.org/officeDocument/2006/relationships" id="266" r:id="R2f89bc5ccf714712"/>
+    <p:sldId xmlns:r="http://schemas.openxmlformats.org/officeDocument/2006/relationships" id="267" r:id="R4500783721b44b29"/>
+    <p:sldId xmlns:r="http://schemas.openxmlformats.org/officeDocument/2006/relationships" id="268" r:id="R1ae0cc39977b4bee"/>
+    <p:sldId xmlns:r="http://schemas.openxmlformats.org/officeDocument/2006/relationships" id="269" r:id="R39ff7890fedf4ca9"/>
+    <p:sldId xmlns:r="http://schemas.openxmlformats.org/officeDocument/2006/relationships" id="270" r:id="Rdebe418667a2494e"/>
+    <p:sldId xmlns:r="http://schemas.openxmlformats.org/officeDocument/2006/relationships" id="271" r:id="R8ae7ba75b20c4464"/>
+    <p:sldId xmlns:r="http://schemas.openxmlformats.org/officeDocument/2006/relationships" id="272" r:id="Rdb587615920c474b"/>
+    <p:sldId xmlns:r="http://schemas.openxmlformats.org/officeDocument/2006/relationships" id="273" r:id="Rb2e928a5daf24ba9"/>
   </p:sldIdLst>
   <p:sldSz cx="12192000" cy="6858000"/>
   <p:notesSz cx="6858000" cy="9144000"/>
@@ -1694,7 +1694,7 @@
   </p:cSld>
   <p:clrMap bg1="lt1" tx1="dk1" bg2="lt2" tx2="dk2" accent1="accent1" accent2="accent2" accent3="accent3" accent4="accent4" accent5="accent5" accent6="accent6" hlink="hlink" folHlink="folHlink"/>
   <p:sldLayoutIdLst>
-    <p:sldLayoutId xmlns:r="http://schemas.openxmlformats.org/officeDocument/2006/relationships" id="2147483649" r:id="R405865bc78e54a91"/>
+    <p:sldLayoutId xmlns:r="http://schemas.openxmlformats.org/officeDocument/2006/relationships" id="2147483649" r:id="Rc4a4a929127e4159"/>
   </p:sldLayoutIdLst>
   <p:txStyles>
     <p:titleStyle>
@@ -1982,7 +1982,7 @@
     <p:bg>
       <p:bgPr>
         <a:solidFill xmlns:a="http://schemas.openxmlformats.org/drawingml/2006/main">
-          <a:srgbClr val="0E1B3E"/>
+          <a:srgbClr val="070F26"/>
         </a:solidFill>
       </p:bgPr>
     </p:bg>
@@ -2000,7 +2000,7 @@
           <p:cNvPr id="1" name="">
             <a:extLst xmlns:a="http://schemas.openxmlformats.org/drawingml/2006/main">
               <a:ext uri="{FF2B5EF4-FFF2-40B4-BE49-F238E27FC236}">
-                <a16:creationId xmlns:a16="http://schemas.microsoft.com/office/drawing/2014/main" id="{1849E217-9979-4F40-9E56-107B301D730F}"/>
+                <a16:creationId xmlns:a16="http://schemas.microsoft.com/office/drawing/2014/main" id="{8B93CB7E-4571-4602-9E4A-807D1EDA9715}"/>
               </a:ext>
             </a:extLst>
           </p:cNvPr>
@@ -2018,7 +2018,7 @@
             <a:avLst/>
           </a:prstGeom>
           <a:solidFill xmlns:a="http://schemas.openxmlformats.org/drawingml/2006/main">
-            <a:srgbClr val="0E1B3E"/>
+            <a:srgbClr val="070F26"/>
           </a:solidFill>
           <a:ln xmlns:a="http://schemas.openxmlformats.org/drawingml/2006/main" w="0">
             <a:solidFill>
@@ -2039,7 +2039,7 @@
           <p:nvPr/>
         </p:nvPicPr>
         <p:blipFill>
-          <a:blip xmlns:r="http://schemas.openxmlformats.org/officeDocument/2006/relationships" xmlns:a="http://schemas.openxmlformats.org/drawingml/2006/main" r:embed="R060303e1f34c4100"/>
+          <a:blip xmlns:r="http://schemas.openxmlformats.org/officeDocument/2006/relationships" xmlns:a="http://schemas.openxmlformats.org/drawingml/2006/main" r:embed="Rfa5d3378292f48db"/>
           <a:stretch xmlns:a="http://schemas.openxmlformats.org/drawingml/2006/main"/>
         </p:blipFill>
         <p:spPr>
@@ -2057,7 +2057,7 @@
           <p:cNvPr id="3" name="">
             <a:extLst xmlns:a="http://schemas.openxmlformats.org/drawingml/2006/main">
               <a:ext uri="{FF2B5EF4-FFF2-40B4-BE49-F238E27FC236}">
-                <a16:creationId xmlns:a16="http://schemas.microsoft.com/office/drawing/2014/main" id="{D9411F26-D2EF-48B1-9585-50D8A9CF7A06}"/>
+                <a16:creationId xmlns:a16="http://schemas.microsoft.com/office/drawing/2014/main" id="{5FC21AB1-7D69-405D-BFF7-9F6713106F58}"/>
               </a:ext>
             </a:extLst>
           </p:cNvPr>
@@ -2115,7 +2115,7 @@
           <p:cNvPr id="4" name="">
             <a:extLst xmlns:a="http://schemas.openxmlformats.org/drawingml/2006/main">
               <a:ext uri="{FF2B5EF4-FFF2-40B4-BE49-F238E27FC236}">
-                <a16:creationId xmlns:a16="http://schemas.microsoft.com/office/drawing/2014/main" id="{2FF89BF1-0ECB-46D5-AEAD-C483E1188DA8}"/>
+                <a16:creationId xmlns:a16="http://schemas.microsoft.com/office/drawing/2014/main" id="{67F25E7E-5031-4690-915A-2C7AA1BD3B14}"/>
               </a:ext>
             </a:extLst>
           </p:cNvPr>
@@ -2173,7 +2173,7 @@
           <p:cNvPr id="5" name="">
             <a:extLst xmlns:a="http://schemas.openxmlformats.org/drawingml/2006/main">
               <a:ext uri="{FF2B5EF4-FFF2-40B4-BE49-F238E27FC236}">
-                <a16:creationId xmlns:a16="http://schemas.microsoft.com/office/drawing/2014/main" id="{A4C1AA69-2F54-478D-9EFA-324DE6E24B60}"/>
+                <a16:creationId xmlns:a16="http://schemas.microsoft.com/office/drawing/2014/main" id="{E013DCCF-3E87-4C9A-AEC8-A35D4A966FAF}"/>
               </a:ext>
             </a:extLst>
           </p:cNvPr>
@@ -2235,7 +2235,7 @@
           <p:nvPr/>
         </p:nvPicPr>
         <p:blipFill>
-          <a:blip xmlns:r="http://schemas.openxmlformats.org/officeDocument/2006/relationships" xmlns:a="http://schemas.openxmlformats.org/drawingml/2006/main" r:embed="R9aee2344f24b4bdd"/>
+          <a:blip xmlns:r="http://schemas.openxmlformats.org/officeDocument/2006/relationships" xmlns:a="http://schemas.openxmlformats.org/drawingml/2006/main" r:embed="Rae0daddb8aad4c42"/>
           <a:stretch xmlns:a="http://schemas.openxmlformats.org/drawingml/2006/main"/>
         </p:blipFill>
         <p:spPr>
@@ -2253,7 +2253,7 @@
           <p:cNvPr id="7" name="">
             <a:extLst xmlns:a="http://schemas.openxmlformats.org/drawingml/2006/main">
               <a:ext uri="{FF2B5EF4-FFF2-40B4-BE49-F238E27FC236}">
-                <a16:creationId xmlns:a16="http://schemas.microsoft.com/office/drawing/2014/main" id="{652C95CB-8B76-4E37-B509-FA8C6FD7EACF}"/>
+                <a16:creationId xmlns:a16="http://schemas.microsoft.com/office/drawing/2014/main" id="{F81056C0-FD5D-4CD4-9AC9-9E52961A53B4}"/>
               </a:ext>
             </a:extLst>
           </p:cNvPr>
@@ -2311,7 +2311,7 @@
           <p:cNvPr id="8" name="">
             <a:extLst xmlns:a="http://schemas.openxmlformats.org/drawingml/2006/main">
               <a:ext uri="{FF2B5EF4-FFF2-40B4-BE49-F238E27FC236}">
-                <a16:creationId xmlns:a16="http://schemas.microsoft.com/office/drawing/2014/main" id="{DA1A3654-9E21-442F-8D85-817A33DA1668}"/>
+                <a16:creationId xmlns:a16="http://schemas.microsoft.com/office/drawing/2014/main" id="{733B8F2C-C378-4FB4-8169-048E7671F4F2}"/>
               </a:ext>
             </a:extLst>
           </p:cNvPr>
@@ -2369,7 +2369,7 @@
           <p:cNvPr id="9" name="">
             <a:extLst xmlns:a="http://schemas.openxmlformats.org/drawingml/2006/main">
               <a:ext uri="{FF2B5EF4-FFF2-40B4-BE49-F238E27FC236}">
-                <a16:creationId xmlns:a16="http://schemas.microsoft.com/office/drawing/2014/main" id="{FF2D702C-3910-4FE8-B9B8-4A376108B87A}"/>
+                <a16:creationId xmlns:a16="http://schemas.microsoft.com/office/drawing/2014/main" id="{3412DEEB-78E7-4E61-B0C2-A5A058C147DE}"/>
               </a:ext>
             </a:extLst>
           </p:cNvPr>
@@ -2427,7 +2427,7 @@
           <p:cNvPr id="10" name="">
             <a:extLst xmlns:a="http://schemas.openxmlformats.org/drawingml/2006/main">
               <a:ext uri="{FF2B5EF4-FFF2-40B4-BE49-F238E27FC236}">
-                <a16:creationId xmlns:a16="http://schemas.microsoft.com/office/drawing/2014/main" id="{65434B8B-C8BE-490D-AED5-694FC8465749}"/>
+                <a16:creationId xmlns:a16="http://schemas.microsoft.com/office/drawing/2014/main" id="{7BEDEE91-8E5B-42B4-AD3D-FA0C4D6B1CFB}"/>
               </a:ext>
             </a:extLst>
           </p:cNvPr>
@@ -2462,7 +2462,7 @@
           <p:cNvPr id="11" name="">
             <a:extLst xmlns:a="http://schemas.openxmlformats.org/drawingml/2006/main">
               <a:ext uri="{FF2B5EF4-FFF2-40B4-BE49-F238E27FC236}">
-                <a16:creationId xmlns:a16="http://schemas.microsoft.com/office/drawing/2014/main" id="{E4ADADC9-7047-4AEC-8AA1-CE49BFDBBDD3}"/>
+                <a16:creationId xmlns:a16="http://schemas.microsoft.com/office/drawing/2014/main" id="{73F8DF63-F8A1-49BA-8C34-A4705D6DE5D5}"/>
               </a:ext>
             </a:extLst>
           </p:cNvPr>
@@ -2518,7 +2518,7 @@
     </p:spTree>
     <p:extLst>
       <p:ext uri="{BB962C8B-B14F-4D97-AF65-F5344CB8AC3E}">
-        <p14:creationId xmlns:p14="http://schemas.microsoft.com/office/powerpoint/2010/main" val="6114347"/>
+        <p14:creationId xmlns:p14="http://schemas.microsoft.com/office/powerpoint/2010/main" val="866044546"/>
       </p:ext>
     </p:extLst>
   </p:cSld>
@@ -2531,7 +2531,7 @@
     <p:bg>
       <p:bgPr>
         <a:solidFill xmlns:a="http://schemas.openxmlformats.org/drawingml/2006/main">
-          <a:srgbClr val="0E1B3E"/>
+          <a:srgbClr val="070F26"/>
         </a:solidFill>
       </p:bgPr>
     </p:bg>
@@ -2549,7 +2549,7 @@
           <p:cNvPr id="1" name="">
             <a:extLst xmlns:a="http://schemas.openxmlformats.org/drawingml/2006/main">
               <a:ext uri="{FF2B5EF4-FFF2-40B4-BE49-F238E27FC236}">
-                <a16:creationId xmlns:a16="http://schemas.microsoft.com/office/drawing/2014/main" id="{D03E8D0C-928E-455F-A120-65B52B9CDC8E}"/>
+                <a16:creationId xmlns:a16="http://schemas.microsoft.com/office/drawing/2014/main" id="{B2A07B5F-390F-4BB4-B0FA-C1411992D96B}"/>
               </a:ext>
             </a:extLst>
           </p:cNvPr>
@@ -2567,7 +2567,7 @@
             <a:avLst/>
           </a:prstGeom>
           <a:solidFill xmlns:a="http://schemas.openxmlformats.org/drawingml/2006/main">
-            <a:srgbClr val="0E1B3E"/>
+            <a:srgbClr val="070F26"/>
           </a:solidFill>
           <a:ln xmlns:a="http://schemas.openxmlformats.org/drawingml/2006/main" w="0">
             <a:solidFill>
@@ -2588,7 +2588,7 @@
           <p:nvPr/>
         </p:nvPicPr>
         <p:blipFill>
-          <a:blip xmlns:r="http://schemas.openxmlformats.org/officeDocument/2006/relationships" xmlns:a="http://schemas.openxmlformats.org/drawingml/2006/main" r:embed="Rbe0ff1b3dc654990"/>
+          <a:blip xmlns:r="http://schemas.openxmlformats.org/officeDocument/2006/relationships" xmlns:a="http://schemas.openxmlformats.org/drawingml/2006/main" r:embed="Rb35fb2fbe5cc4371"/>
           <a:stretch xmlns:a="http://schemas.openxmlformats.org/drawingml/2006/main"/>
         </p:blipFill>
         <p:spPr>
@@ -2606,7 +2606,7 @@
           <p:cNvPr id="3" name="">
             <a:extLst xmlns:a="http://schemas.openxmlformats.org/drawingml/2006/main">
               <a:ext uri="{FF2B5EF4-FFF2-40B4-BE49-F238E27FC236}">
-                <a16:creationId xmlns:a16="http://schemas.microsoft.com/office/drawing/2014/main" id="{A219E09E-6A6B-4E56-A993-9E20DE418CAF}"/>
+                <a16:creationId xmlns:a16="http://schemas.microsoft.com/office/drawing/2014/main" id="{1B360650-6667-4171-9410-E31BB468C27F}"/>
               </a:ext>
             </a:extLst>
           </p:cNvPr>
@@ -2664,7 +2664,7 @@
           <p:cNvPr id="4" name="">
             <a:extLst xmlns:a="http://schemas.openxmlformats.org/drawingml/2006/main">
               <a:ext uri="{FF2B5EF4-FFF2-40B4-BE49-F238E27FC236}">
-                <a16:creationId xmlns:a16="http://schemas.microsoft.com/office/drawing/2014/main" id="{BB1566EC-FAA6-45E2-8882-0933E97FF031}"/>
+                <a16:creationId xmlns:a16="http://schemas.microsoft.com/office/drawing/2014/main" id="{54652390-80EE-42DA-B655-3F4AFDA708FB}"/>
               </a:ext>
             </a:extLst>
           </p:cNvPr>
@@ -2722,7 +2722,7 @@
           <p:cNvPr id="5" name="">
             <a:extLst xmlns:a="http://schemas.openxmlformats.org/drawingml/2006/main">
               <a:ext uri="{FF2B5EF4-FFF2-40B4-BE49-F238E27FC236}">
-                <a16:creationId xmlns:a16="http://schemas.microsoft.com/office/drawing/2014/main" id="{9C29D47D-B540-45B7-9A2F-2D7B646DDE17}"/>
+                <a16:creationId xmlns:a16="http://schemas.microsoft.com/office/drawing/2014/main" id="{FD687D90-3A36-494F-B697-73A7AA238D0D}"/>
               </a:ext>
             </a:extLst>
           </p:cNvPr>
@@ -2780,7 +2780,7 @@
           <p:cNvPr id="6" name="">
             <a:extLst xmlns:a="http://schemas.openxmlformats.org/drawingml/2006/main">
               <a:ext uri="{FF2B5EF4-FFF2-40B4-BE49-F238E27FC236}">
-                <a16:creationId xmlns:a16="http://schemas.microsoft.com/office/drawing/2014/main" id="{11D43FC7-3182-45EE-B2F0-C6F75135D0F6}"/>
+                <a16:creationId xmlns:a16="http://schemas.microsoft.com/office/drawing/2014/main" id="{95D55003-3630-408A-8532-687FC244B7EE}"/>
               </a:ext>
             </a:extLst>
           </p:cNvPr>
@@ -2842,13 +2842,13 @@
           <p:nvPr/>
         </p:nvPicPr>
         <p:blipFill>
-          <a:blip xmlns:r="http://schemas.openxmlformats.org/officeDocument/2006/relationships" xmlns:a="http://schemas.openxmlformats.org/drawingml/2006/main" r:embed="R1bf83a158f314f23"/>
+          <a:blip xmlns:r="http://schemas.openxmlformats.org/officeDocument/2006/relationships" xmlns:a="http://schemas.openxmlformats.org/drawingml/2006/main" r:embed="Rf789bdc737764eb0"/>
           <a:stretch xmlns:a="http://schemas.openxmlformats.org/drawingml/2006/main"/>
         </p:blipFill>
         <p:spPr>
           <a:xfrm xmlns:a="http://schemas.openxmlformats.org/drawingml/2006/main">
-            <a:off x="476250" y="1257300"/>
-            <a:ext cx="2667000" cy="4533900"/>
+            <a:off x="0" y="1746250"/>
+            <a:ext cx="2667000" cy="3556000"/>
           </a:xfrm>
           <a:prstGeom xmlns:a="http://schemas.openxmlformats.org/drawingml/2006/main" prst="rect">
             <a:avLst/>
@@ -2860,7 +2860,7 @@
           <p:cNvPr id="8" name="">
             <a:extLst xmlns:a="http://schemas.openxmlformats.org/drawingml/2006/main">
               <a:ext uri="{FF2B5EF4-FFF2-40B4-BE49-F238E27FC236}">
-                <a16:creationId xmlns:a16="http://schemas.microsoft.com/office/drawing/2014/main" id="{B18924E2-9464-4363-B9DB-2E0C06E99CCA}"/>
+                <a16:creationId xmlns:a16="http://schemas.microsoft.com/office/drawing/2014/main" id="{5BADC664-A31B-42CF-B817-C74FA27B706F}"/>
               </a:ext>
             </a:extLst>
           </p:cNvPr>
@@ -2918,7 +2918,7 @@
           <p:cNvPr id="9" name="">
             <a:extLst xmlns:a="http://schemas.openxmlformats.org/drawingml/2006/main">
               <a:ext uri="{FF2B5EF4-FFF2-40B4-BE49-F238E27FC236}">
-                <a16:creationId xmlns:a16="http://schemas.microsoft.com/office/drawing/2014/main" id="{579E53CD-43D0-4221-8B1C-D27A3C2C04CA}"/>
+                <a16:creationId xmlns:a16="http://schemas.microsoft.com/office/drawing/2014/main" id="{C4892A66-975C-437E-A2D2-139DA0EC625A}"/>
               </a:ext>
             </a:extLst>
           </p:cNvPr>
@@ -2976,7 +2976,7 @@
           <p:cNvPr id="10" name="">
             <a:extLst xmlns:a="http://schemas.openxmlformats.org/drawingml/2006/main">
               <a:ext uri="{FF2B5EF4-FFF2-40B4-BE49-F238E27FC236}">
-                <a16:creationId xmlns:a16="http://schemas.microsoft.com/office/drawing/2014/main" id="{9C3F79CB-936A-4F46-B679-A46E6E98A7A0}"/>
+                <a16:creationId xmlns:a16="http://schemas.microsoft.com/office/drawing/2014/main" id="{9F2C2D6C-ABB7-4F7D-8DC4-9E0F0DC467C1}"/>
               </a:ext>
             </a:extLst>
           </p:cNvPr>
@@ -3032,7 +3032,7 @@
     </p:spTree>
     <p:extLst>
       <p:ext uri="{BB962C8B-B14F-4D97-AF65-F5344CB8AC3E}">
-        <p14:creationId xmlns:p14="http://schemas.microsoft.com/office/powerpoint/2010/main" val="2260073"/>
+        <p14:creationId xmlns:p14="http://schemas.microsoft.com/office/powerpoint/2010/main" val="1668029329"/>
       </p:ext>
     </p:extLst>
   </p:cSld>
@@ -3063,7 +3063,7 @@
           <p:cNvPr id="1" name="">
             <a:extLst xmlns:a="http://schemas.openxmlformats.org/drawingml/2006/main">
               <a:ext uri="{FF2B5EF4-FFF2-40B4-BE49-F238E27FC236}">
-                <a16:creationId xmlns:a16="http://schemas.microsoft.com/office/drawing/2014/main" id="{B540E1B6-2C69-4295-9C17-FE2A0253C7C0}"/>
+                <a16:creationId xmlns:a16="http://schemas.microsoft.com/office/drawing/2014/main" id="{162219F7-B190-44E1-9DB5-FBAB3522D340}"/>
               </a:ext>
             </a:extLst>
           </p:cNvPr>
@@ -3102,7 +3102,7 @@
           <p:nvPr/>
         </p:nvPicPr>
         <p:blipFill>
-          <a:blip xmlns:r="http://schemas.openxmlformats.org/officeDocument/2006/relationships" xmlns:a="http://schemas.openxmlformats.org/drawingml/2006/main" r:embed="R1b6669d3e4ce40c3"/>
+          <a:blip xmlns:r="http://schemas.openxmlformats.org/officeDocument/2006/relationships" xmlns:a="http://schemas.openxmlformats.org/drawingml/2006/main" r:embed="R42d46dbf5813432a"/>
           <a:stretch xmlns:a="http://schemas.openxmlformats.org/drawingml/2006/main"/>
         </p:blipFill>
         <p:spPr>
@@ -3120,7 +3120,7 @@
           <p:cNvPr id="3" name="">
             <a:extLst xmlns:a="http://schemas.openxmlformats.org/drawingml/2006/main">
               <a:ext uri="{FF2B5EF4-FFF2-40B4-BE49-F238E27FC236}">
-                <a16:creationId xmlns:a16="http://schemas.microsoft.com/office/drawing/2014/main" id="{691B2A7D-BFDD-4B7D-A45C-04840625E7C5}"/>
+                <a16:creationId xmlns:a16="http://schemas.microsoft.com/office/drawing/2014/main" id="{5AC2A2EF-F4BC-405B-A8A4-D89291792D71}"/>
               </a:ext>
             </a:extLst>
           </p:cNvPr>
@@ -3158,14 +3158,14 @@
             <a:pPr algn="r">
               <a:defRPr sz="825" b="1">
                 <a:solidFill>
-                  <a:srgbClr val="0E1B3E"/>
+                  <a:srgbClr val="070F26"/>
                 </a:solidFill>
               </a:defRPr>
             </a:pPr>
             <a:r>
               <a:rPr sz="825" b="1">
                 <a:solidFill>
-                  <a:srgbClr val="0E1B3E"/>
+                  <a:srgbClr val="070F26"/>
                 </a:solidFill>
               </a:rPr>
               <a:t>NTT DATA UNIVERSITY</a:t>
@@ -3178,7 +3178,7 @@
           <p:cNvPr id="4" name="">
             <a:extLst xmlns:a="http://schemas.openxmlformats.org/drawingml/2006/main">
               <a:ext uri="{FF2B5EF4-FFF2-40B4-BE49-F238E27FC236}">
-                <a16:creationId xmlns:a16="http://schemas.microsoft.com/office/drawing/2014/main" id="{3F59FAEB-84C6-4663-89D2-347A501617CF}"/>
+                <a16:creationId xmlns:a16="http://schemas.microsoft.com/office/drawing/2014/main" id="{12A9782D-7113-417F-B532-7B5CBE84F0F6}"/>
               </a:ext>
             </a:extLst>
           </p:cNvPr>
@@ -3236,7 +3236,7 @@
           <p:cNvPr id="5" name="">
             <a:extLst xmlns:a="http://schemas.openxmlformats.org/drawingml/2006/main">
               <a:ext uri="{FF2B5EF4-FFF2-40B4-BE49-F238E27FC236}">
-                <a16:creationId xmlns:a16="http://schemas.microsoft.com/office/drawing/2014/main" id="{50545936-F40E-4447-A0C9-9D18FF3701B7}"/>
+                <a16:creationId xmlns:a16="http://schemas.microsoft.com/office/drawing/2014/main" id="{E4E198F9-052C-4BB5-9D76-8FA2D9A6EFA4}"/>
               </a:ext>
             </a:extLst>
           </p:cNvPr>
@@ -3294,7 +3294,7 @@
           <p:cNvPr id="6" name="">
             <a:extLst xmlns:a="http://schemas.openxmlformats.org/drawingml/2006/main">
               <a:ext uri="{FF2B5EF4-FFF2-40B4-BE49-F238E27FC236}">
-                <a16:creationId xmlns:a16="http://schemas.microsoft.com/office/drawing/2014/main" id="{7FA4C9B6-B3D3-43EC-BED6-23364A8E7530}"/>
+                <a16:creationId xmlns:a16="http://schemas.microsoft.com/office/drawing/2014/main" id="{DDF6A85C-65D1-4E74-BF6F-FDC98EA4CE79}"/>
               </a:ext>
             </a:extLst>
           </p:cNvPr>
@@ -3332,14 +3332,14 @@
             <a:pPr algn="r">
               <a:defRPr sz="675" b="1">
                 <a:solidFill>
-                  <a:srgbClr val="0E1B3E"/>
+                  <a:srgbClr val="070F26"/>
                 </a:solidFill>
               </a:defRPr>
             </a:pPr>
             <a:r>
               <a:rPr sz="675" b="1">
                 <a:solidFill>
-                  <a:srgbClr val="0E1B3E"/>
+                  <a:srgbClr val="070F26"/>
                 </a:solidFill>
               </a:rPr>
               <a:t>NTT DATA UNIVERSITY</a:t>
@@ -3352,7 +3352,7 @@
           <p:cNvPr id="7" name="">
             <a:extLst xmlns:a="http://schemas.openxmlformats.org/drawingml/2006/main">
               <a:ext uri="{FF2B5EF4-FFF2-40B4-BE49-F238E27FC236}">
-                <a16:creationId xmlns:a16="http://schemas.microsoft.com/office/drawing/2014/main" id="{C5ED0403-057D-427B-9B15-644D33DB3E24}"/>
+                <a16:creationId xmlns:a16="http://schemas.microsoft.com/office/drawing/2014/main" id="{045022B8-66CB-4588-88A3-1071E4E75940}"/>
               </a:ext>
             </a:extLst>
           </p:cNvPr>
@@ -3410,7 +3410,7 @@
           <p:cNvPr id="8" name="">
             <a:extLst xmlns:a="http://schemas.openxmlformats.org/drawingml/2006/main">
               <a:ext uri="{FF2B5EF4-FFF2-40B4-BE49-F238E27FC236}">
-                <a16:creationId xmlns:a16="http://schemas.microsoft.com/office/drawing/2014/main" id="{AECA386A-BDE2-4FF8-9EE9-C4B3E0C190F1}"/>
+                <a16:creationId xmlns:a16="http://schemas.microsoft.com/office/drawing/2014/main" id="{4975B01A-5A01-448D-9199-BFC418C3A531}"/>
               </a:ext>
             </a:extLst>
           </p:cNvPr>
@@ -3448,14 +3448,14 @@
             <a:pPr algn="l">
               <a:defRPr sz="2400" b="0">
                 <a:solidFill>
-                  <a:srgbClr val="0E1B3E"/>
+                  <a:srgbClr val="070F26"/>
                 </a:solidFill>
               </a:defRPr>
             </a:pPr>
             <a:r>
               <a:rPr sz="2400" b="0">
                 <a:solidFill>
-                  <a:srgbClr val="0E1B3E"/>
+                  <a:srgbClr val="070F26"/>
                 </a:solidFill>
               </a:rPr>
               <a:t>A query original — o que ela faz?</a:t>
@@ -3468,7 +3468,7 @@
           <p:cNvPr id="9" name="">
             <a:extLst xmlns:a="http://schemas.openxmlformats.org/drawingml/2006/main">
               <a:ext uri="{FF2B5EF4-FFF2-40B4-BE49-F238E27FC236}">
-                <a16:creationId xmlns:a16="http://schemas.microsoft.com/office/drawing/2014/main" id="{1DD19137-55AE-47BA-8D47-9E49936C32C3}"/>
+                <a16:creationId xmlns:a16="http://schemas.microsoft.com/office/drawing/2014/main" id="{1849D5C6-14D0-4171-A887-F1C9C63A42A8}"/>
               </a:ext>
             </a:extLst>
           </p:cNvPr>
@@ -3526,7 +3526,7 @@
           <p:cNvPr id="10" name="">
             <a:extLst xmlns:a="http://schemas.openxmlformats.org/drawingml/2006/main">
               <a:ext uri="{FF2B5EF4-FFF2-40B4-BE49-F238E27FC236}">
-                <a16:creationId xmlns:a16="http://schemas.microsoft.com/office/drawing/2014/main" id="{F316F1C1-29E6-420E-9692-BF52C12CEC9A}"/>
+                <a16:creationId xmlns:a16="http://schemas.microsoft.com/office/drawing/2014/main" id="{33607824-8DA6-4570-A704-2CB1564141B7}"/>
               </a:ext>
             </a:extLst>
           </p:cNvPr>
@@ -3559,7 +3559,7 @@
           <p:cNvPr id="11" name="">
             <a:extLst xmlns:a="http://schemas.openxmlformats.org/drawingml/2006/main">
               <a:ext uri="{FF2B5EF4-FFF2-40B4-BE49-F238E27FC236}">
-                <a16:creationId xmlns:a16="http://schemas.microsoft.com/office/drawing/2014/main" id="{F6968A90-CFBC-47F9-9796-550A0CAE9D91}"/>
+                <a16:creationId xmlns:a16="http://schemas.microsoft.com/office/drawing/2014/main" id="{2F5069BE-674C-4C04-A976-1E0543D5E33E}"/>
               </a:ext>
             </a:extLst>
           </p:cNvPr>
@@ -3594,7 +3594,7 @@
           <p:cNvPr id="12" name="">
             <a:extLst xmlns:a="http://schemas.openxmlformats.org/drawingml/2006/main">
               <a:ext uri="{FF2B5EF4-FFF2-40B4-BE49-F238E27FC236}">
-                <a16:creationId xmlns:a16="http://schemas.microsoft.com/office/drawing/2014/main" id="{516066C0-F82D-4B1D-A295-9A85742C714B}"/>
+                <a16:creationId xmlns:a16="http://schemas.microsoft.com/office/drawing/2014/main" id="{37175562-FB13-457D-BBC1-E9EB8FFB0626}"/>
               </a:ext>
             </a:extLst>
           </p:cNvPr>
@@ -3652,7 +3652,7 @@
           <p:cNvPr id="13" name="">
             <a:extLst xmlns:a="http://schemas.openxmlformats.org/drawingml/2006/main">
               <a:ext uri="{FF2B5EF4-FFF2-40B4-BE49-F238E27FC236}">
-                <a16:creationId xmlns:a16="http://schemas.microsoft.com/office/drawing/2014/main" id="{B3F3981F-67DF-4274-A30E-50C772096F81}"/>
+                <a16:creationId xmlns:a16="http://schemas.microsoft.com/office/drawing/2014/main" id="{01CF1B15-85B0-4C42-82B9-522EF8A5272B}"/>
               </a:ext>
             </a:extLst>
           </p:cNvPr>
@@ -3965,7 +3965,7 @@
           <p:cNvPr id="14" name="">
             <a:extLst xmlns:a="http://schemas.openxmlformats.org/drawingml/2006/main">
               <a:ext uri="{FF2B5EF4-FFF2-40B4-BE49-F238E27FC236}">
-                <a16:creationId xmlns:a16="http://schemas.microsoft.com/office/drawing/2014/main" id="{60559A84-C577-4CD4-8ED9-7E0B9849D337}"/>
+                <a16:creationId xmlns:a16="http://schemas.microsoft.com/office/drawing/2014/main" id="{CCF74A2F-6358-47ED-8892-043BB9963E3B}"/>
               </a:ext>
             </a:extLst>
           </p:cNvPr>
@@ -3998,7 +3998,7 @@
           <p:cNvPr id="15" name="">
             <a:extLst xmlns:a="http://schemas.openxmlformats.org/drawingml/2006/main">
               <a:ext uri="{FF2B5EF4-FFF2-40B4-BE49-F238E27FC236}">
-                <a16:creationId xmlns:a16="http://schemas.microsoft.com/office/drawing/2014/main" id="{C2CB37D8-346F-47CA-82C0-7DC96389ADEE}"/>
+                <a16:creationId xmlns:a16="http://schemas.microsoft.com/office/drawing/2014/main" id="{369B2266-2BE9-4732-93C5-21BB4707A68F}"/>
               </a:ext>
             </a:extLst>
           </p:cNvPr>
@@ -4033,7 +4033,7 @@
           <p:cNvPr id="16" name="">
             <a:extLst xmlns:a="http://schemas.openxmlformats.org/drawingml/2006/main">
               <a:ext uri="{FF2B5EF4-FFF2-40B4-BE49-F238E27FC236}">
-                <a16:creationId xmlns:a16="http://schemas.microsoft.com/office/drawing/2014/main" id="{73346EAD-5673-4DCE-82E3-D9CA62DBD4AA}"/>
+                <a16:creationId xmlns:a16="http://schemas.microsoft.com/office/drawing/2014/main" id="{F0732DF3-4377-4459-844B-5EBB462479D8}"/>
               </a:ext>
             </a:extLst>
           </p:cNvPr>
@@ -4091,7 +4091,7 @@
           <p:cNvPr id="17" name="">
             <a:extLst xmlns:a="http://schemas.openxmlformats.org/drawingml/2006/main">
               <a:ext uri="{FF2B5EF4-FFF2-40B4-BE49-F238E27FC236}">
-                <a16:creationId xmlns:a16="http://schemas.microsoft.com/office/drawing/2014/main" id="{FB5C3DE7-11D1-4204-95DC-0D0D46F5726B}"/>
+                <a16:creationId xmlns:a16="http://schemas.microsoft.com/office/drawing/2014/main" id="{008D91AD-8356-4AF4-B4C2-44C2ADFFC3D0}"/>
               </a:ext>
             </a:extLst>
           </p:cNvPr>
@@ -4264,7 +4264,7 @@
     </p:spTree>
     <p:extLst>
       <p:ext uri="{BB962C8B-B14F-4D97-AF65-F5344CB8AC3E}">
-        <p14:creationId xmlns:p14="http://schemas.microsoft.com/office/powerpoint/2010/main" val="32267772"/>
+        <p14:creationId xmlns:p14="http://schemas.microsoft.com/office/powerpoint/2010/main" val="1087967751"/>
       </p:ext>
     </p:extLst>
   </p:cSld>
@@ -4295,7 +4295,7 @@
           <p:cNvPr id="1" name="">
             <a:extLst xmlns:a="http://schemas.openxmlformats.org/drawingml/2006/main">
               <a:ext uri="{FF2B5EF4-FFF2-40B4-BE49-F238E27FC236}">
-                <a16:creationId xmlns:a16="http://schemas.microsoft.com/office/drawing/2014/main" id="{58AFA3B5-1F7C-4385-9FB9-F8457E80A585}"/>
+                <a16:creationId xmlns:a16="http://schemas.microsoft.com/office/drawing/2014/main" id="{88812B0C-6D47-48A1-BEF0-561AE8078AF6}"/>
               </a:ext>
             </a:extLst>
           </p:cNvPr>
@@ -4334,7 +4334,7 @@
           <p:nvPr/>
         </p:nvPicPr>
         <p:blipFill>
-          <a:blip xmlns:r="http://schemas.openxmlformats.org/officeDocument/2006/relationships" xmlns:a="http://schemas.openxmlformats.org/drawingml/2006/main" r:embed="R36eecc23e49549ec"/>
+          <a:blip xmlns:r="http://schemas.openxmlformats.org/officeDocument/2006/relationships" xmlns:a="http://schemas.openxmlformats.org/drawingml/2006/main" r:embed="R5115d63d7ab9417f"/>
           <a:stretch xmlns:a="http://schemas.openxmlformats.org/drawingml/2006/main"/>
         </p:blipFill>
         <p:spPr>
@@ -4352,7 +4352,7 @@
           <p:cNvPr id="3" name="">
             <a:extLst xmlns:a="http://schemas.openxmlformats.org/drawingml/2006/main">
               <a:ext uri="{FF2B5EF4-FFF2-40B4-BE49-F238E27FC236}">
-                <a16:creationId xmlns:a16="http://schemas.microsoft.com/office/drawing/2014/main" id="{A7B22298-318E-4E01-83C4-D49314D223AB}"/>
+                <a16:creationId xmlns:a16="http://schemas.microsoft.com/office/drawing/2014/main" id="{8A4BC62C-494C-4577-A88E-3446EE8B5DFB}"/>
               </a:ext>
             </a:extLst>
           </p:cNvPr>
@@ -4390,14 +4390,14 @@
             <a:pPr algn="r">
               <a:defRPr sz="825" b="1">
                 <a:solidFill>
-                  <a:srgbClr val="0E1B3E"/>
+                  <a:srgbClr val="070F26"/>
                 </a:solidFill>
               </a:defRPr>
             </a:pPr>
             <a:r>
               <a:rPr sz="825" b="1">
                 <a:solidFill>
-                  <a:srgbClr val="0E1B3E"/>
+                  <a:srgbClr val="070F26"/>
                 </a:solidFill>
               </a:rPr>
               <a:t>NTT DATA UNIVERSITY</a:t>
@@ -4410,7 +4410,7 @@
           <p:cNvPr id="4" name="">
             <a:extLst xmlns:a="http://schemas.openxmlformats.org/drawingml/2006/main">
               <a:ext uri="{FF2B5EF4-FFF2-40B4-BE49-F238E27FC236}">
-                <a16:creationId xmlns:a16="http://schemas.microsoft.com/office/drawing/2014/main" id="{3CA2EE7C-6CC7-4DAD-B6C3-BD3F0357D406}"/>
+                <a16:creationId xmlns:a16="http://schemas.microsoft.com/office/drawing/2014/main" id="{4700DD93-1EA4-408F-8358-DD37D2FB2D76}"/>
               </a:ext>
             </a:extLst>
           </p:cNvPr>
@@ -4468,7 +4468,7 @@
           <p:cNvPr id="5" name="">
             <a:extLst xmlns:a="http://schemas.openxmlformats.org/drawingml/2006/main">
               <a:ext uri="{FF2B5EF4-FFF2-40B4-BE49-F238E27FC236}">
-                <a16:creationId xmlns:a16="http://schemas.microsoft.com/office/drawing/2014/main" id="{B4992CD1-080D-4C0E-BF7F-CA72D3419BC1}"/>
+                <a16:creationId xmlns:a16="http://schemas.microsoft.com/office/drawing/2014/main" id="{5CE03FE5-1329-4631-8E74-7FE980E17D04}"/>
               </a:ext>
             </a:extLst>
           </p:cNvPr>
@@ -4526,7 +4526,7 @@
           <p:cNvPr id="6" name="">
             <a:extLst xmlns:a="http://schemas.openxmlformats.org/drawingml/2006/main">
               <a:ext uri="{FF2B5EF4-FFF2-40B4-BE49-F238E27FC236}">
-                <a16:creationId xmlns:a16="http://schemas.microsoft.com/office/drawing/2014/main" id="{D5AB7DB5-88B3-4BC6-97F2-413228A977A5}"/>
+                <a16:creationId xmlns:a16="http://schemas.microsoft.com/office/drawing/2014/main" id="{9EAE9B73-5132-4220-8413-23B1A00809E9}"/>
               </a:ext>
             </a:extLst>
           </p:cNvPr>
@@ -4564,14 +4564,14 @@
             <a:pPr algn="r">
               <a:defRPr sz="675" b="1">
                 <a:solidFill>
-                  <a:srgbClr val="0E1B3E"/>
+                  <a:srgbClr val="070F26"/>
                 </a:solidFill>
               </a:defRPr>
             </a:pPr>
             <a:r>
               <a:rPr sz="675" b="1">
                 <a:solidFill>
-                  <a:srgbClr val="0E1B3E"/>
+                  <a:srgbClr val="070F26"/>
                 </a:solidFill>
               </a:rPr>
               <a:t>NTT DATA UNIVERSITY</a:t>
@@ -4584,7 +4584,7 @@
           <p:cNvPr id="7" name="">
             <a:extLst xmlns:a="http://schemas.openxmlformats.org/drawingml/2006/main">
               <a:ext uri="{FF2B5EF4-FFF2-40B4-BE49-F238E27FC236}">
-                <a16:creationId xmlns:a16="http://schemas.microsoft.com/office/drawing/2014/main" id="{04521C2C-9D15-4DA4-8F9F-46D08F39A420}"/>
+                <a16:creationId xmlns:a16="http://schemas.microsoft.com/office/drawing/2014/main" id="{23AD466D-3679-49FC-9811-C0DDE680D3CD}"/>
               </a:ext>
             </a:extLst>
           </p:cNvPr>
@@ -4642,7 +4642,7 @@
           <p:cNvPr id="8" name="">
             <a:extLst xmlns:a="http://schemas.openxmlformats.org/drawingml/2006/main">
               <a:ext uri="{FF2B5EF4-FFF2-40B4-BE49-F238E27FC236}">
-                <a16:creationId xmlns:a16="http://schemas.microsoft.com/office/drawing/2014/main" id="{42016288-A015-4C5F-AD6F-CA118E69A5C3}"/>
+                <a16:creationId xmlns:a16="http://schemas.microsoft.com/office/drawing/2014/main" id="{1E36FB95-F0F7-4124-B463-F8AF994D6C2E}"/>
               </a:ext>
             </a:extLst>
           </p:cNvPr>
@@ -4680,14 +4680,14 @@
             <a:pPr algn="l">
               <a:defRPr sz="2400" b="0">
                 <a:solidFill>
-                  <a:srgbClr val="0E1B3E"/>
+                  <a:srgbClr val="070F26"/>
                 </a:solidFill>
               </a:defRPr>
             </a:pPr>
             <a:r>
               <a:rPr sz="2400" b="0">
                 <a:solidFill>
-                  <a:srgbClr val="0E1B3E"/>
+                  <a:srgbClr val="070F26"/>
                 </a:solidFill>
               </a:rPr>
               <a:t>Os quatro problemas — identificar antes de reescrever</a:t>
@@ -4700,7 +4700,7 @@
           <p:cNvPr id="9" name="">
             <a:extLst xmlns:a="http://schemas.openxmlformats.org/drawingml/2006/main">
               <a:ext uri="{FF2B5EF4-FFF2-40B4-BE49-F238E27FC236}">
-                <a16:creationId xmlns:a16="http://schemas.microsoft.com/office/drawing/2014/main" id="{CB2876D2-684B-47F1-ABE8-1ED38E1B491B}"/>
+                <a16:creationId xmlns:a16="http://schemas.microsoft.com/office/drawing/2014/main" id="{D9629C5B-8470-45FF-837F-940925B87B76}"/>
               </a:ext>
             </a:extLst>
           </p:cNvPr>
@@ -4758,7 +4758,7 @@
           <p:cNvPr id="10" name="">
             <a:extLst xmlns:a="http://schemas.openxmlformats.org/drawingml/2006/main">
               <a:ext uri="{FF2B5EF4-FFF2-40B4-BE49-F238E27FC236}">
-                <a16:creationId xmlns:a16="http://schemas.microsoft.com/office/drawing/2014/main" id="{587C2088-DB35-424D-B87F-0C3C13EC9264}"/>
+                <a16:creationId xmlns:a16="http://schemas.microsoft.com/office/drawing/2014/main" id="{BE4609BA-14B5-4CF2-AD75-DC1CFE6A5E69}"/>
               </a:ext>
             </a:extLst>
           </p:cNvPr>
@@ -4791,7 +4791,7 @@
           <p:cNvPr id="11" name="">
             <a:extLst xmlns:a="http://schemas.openxmlformats.org/drawingml/2006/main">
               <a:ext uri="{FF2B5EF4-FFF2-40B4-BE49-F238E27FC236}">
-                <a16:creationId xmlns:a16="http://schemas.microsoft.com/office/drawing/2014/main" id="{2BC208E8-6B1E-49D5-A382-740F40012FDB}"/>
+                <a16:creationId xmlns:a16="http://schemas.microsoft.com/office/drawing/2014/main" id="{2B875D3E-695D-4481-9E48-1B7F664057A4}"/>
               </a:ext>
             </a:extLst>
           </p:cNvPr>
@@ -4826,7 +4826,7 @@
           <p:cNvPr id="12" name="">
             <a:extLst xmlns:a="http://schemas.openxmlformats.org/drawingml/2006/main">
               <a:ext uri="{FF2B5EF4-FFF2-40B4-BE49-F238E27FC236}">
-                <a16:creationId xmlns:a16="http://schemas.microsoft.com/office/drawing/2014/main" id="{D5039A73-945E-411F-8D2F-8DB5388E2415}"/>
+                <a16:creationId xmlns:a16="http://schemas.microsoft.com/office/drawing/2014/main" id="{27F94079-CA26-448E-A86D-03E9FFD46DF0}"/>
               </a:ext>
             </a:extLst>
           </p:cNvPr>
@@ -4884,7 +4884,7 @@
           <p:cNvPr id="13" name="">
             <a:extLst xmlns:a="http://schemas.openxmlformats.org/drawingml/2006/main">
               <a:ext uri="{FF2B5EF4-FFF2-40B4-BE49-F238E27FC236}">
-                <a16:creationId xmlns:a16="http://schemas.microsoft.com/office/drawing/2014/main" id="{55BC3F90-D6F8-41D1-93EC-4A019F801ED0}"/>
+                <a16:creationId xmlns:a16="http://schemas.microsoft.com/office/drawing/2014/main" id="{EBEB2501-E62E-4313-BC77-04C6E765B831}"/>
               </a:ext>
             </a:extLst>
           </p:cNvPr>
@@ -4922,14 +4922,14 @@
             <a:pPr algn="l">
               <a:defRPr sz="1050" b="1">
                 <a:solidFill>
-                  <a:srgbClr val="0E1B3E"/>
+                  <a:srgbClr val="070F26"/>
                 </a:solidFill>
               </a:defRPr>
             </a:pPr>
             <a:r>
               <a:rPr sz="1050" b="1">
                 <a:solidFill>
-                  <a:srgbClr val="0E1B3E"/>
+                  <a:srgbClr val="070F26"/>
                 </a:solidFill>
               </a:rPr>
               <a:t>SELECT *</a:t>
@@ -4942,7 +4942,7 @@
           <p:cNvPr id="14" name="">
             <a:extLst xmlns:a="http://schemas.openxmlformats.org/drawingml/2006/main">
               <a:ext uri="{FF2B5EF4-FFF2-40B4-BE49-F238E27FC236}">
-                <a16:creationId xmlns:a16="http://schemas.microsoft.com/office/drawing/2014/main" id="{4668CE21-3596-4BF1-BC02-392DDE4BF071}"/>
+                <a16:creationId xmlns:a16="http://schemas.microsoft.com/office/drawing/2014/main" id="{4A5FF025-AC54-4F17-AFB3-64D66EB94C92}"/>
               </a:ext>
             </a:extLst>
           </p:cNvPr>
@@ -5051,7 +5051,7 @@
           <p:cNvPr id="15" name="">
             <a:extLst xmlns:a="http://schemas.openxmlformats.org/drawingml/2006/main">
               <a:ext uri="{FF2B5EF4-FFF2-40B4-BE49-F238E27FC236}">
-                <a16:creationId xmlns:a16="http://schemas.microsoft.com/office/drawing/2014/main" id="{52569896-DD6E-4EC1-9599-0C1A50E0EBD6}"/>
+                <a16:creationId xmlns:a16="http://schemas.microsoft.com/office/drawing/2014/main" id="{110B3A92-23AA-4C70-8E6F-5C4B04E1DE2A}"/>
               </a:ext>
             </a:extLst>
           </p:cNvPr>
@@ -5084,7 +5084,7 @@
           <p:cNvPr id="16" name="">
             <a:extLst xmlns:a="http://schemas.openxmlformats.org/drawingml/2006/main">
               <a:ext uri="{FF2B5EF4-FFF2-40B4-BE49-F238E27FC236}">
-                <a16:creationId xmlns:a16="http://schemas.microsoft.com/office/drawing/2014/main" id="{0E072638-CFD2-4F92-964A-D18FF43D1899}"/>
+                <a16:creationId xmlns:a16="http://schemas.microsoft.com/office/drawing/2014/main" id="{7821049A-7D39-4694-B420-0E5A48803869}"/>
               </a:ext>
             </a:extLst>
           </p:cNvPr>
@@ -5119,7 +5119,7 @@
           <p:cNvPr id="17" name="">
             <a:extLst xmlns:a="http://schemas.openxmlformats.org/drawingml/2006/main">
               <a:ext uri="{FF2B5EF4-FFF2-40B4-BE49-F238E27FC236}">
-                <a16:creationId xmlns:a16="http://schemas.microsoft.com/office/drawing/2014/main" id="{1762742F-D863-4E33-9D8A-9E1DB54EAF62}"/>
+                <a16:creationId xmlns:a16="http://schemas.microsoft.com/office/drawing/2014/main" id="{8EB687AD-81E2-49FE-93A6-40D9BDB06467}"/>
               </a:ext>
             </a:extLst>
           </p:cNvPr>
@@ -5177,7 +5177,7 @@
           <p:cNvPr id="18" name="">
             <a:extLst xmlns:a="http://schemas.openxmlformats.org/drawingml/2006/main">
               <a:ext uri="{FF2B5EF4-FFF2-40B4-BE49-F238E27FC236}">
-                <a16:creationId xmlns:a16="http://schemas.microsoft.com/office/drawing/2014/main" id="{8718E558-9D3B-48DF-9F04-3F498130CBF8}"/>
+                <a16:creationId xmlns:a16="http://schemas.microsoft.com/office/drawing/2014/main" id="{89097547-6BE7-4933-BDCF-9A5144C90609}"/>
               </a:ext>
             </a:extLst>
           </p:cNvPr>
@@ -5215,14 +5215,14 @@
             <a:pPr algn="l">
               <a:defRPr sz="1050" b="1">
                 <a:solidFill>
-                  <a:srgbClr val="0E1B3E"/>
+                  <a:srgbClr val="070F26"/>
                 </a:solidFill>
               </a:defRPr>
             </a:pPr>
             <a:r>
               <a:rPr sz="1050" b="1">
                 <a:solidFill>
-                  <a:srgbClr val="0E1B3E"/>
+                  <a:srgbClr val="070F26"/>
                 </a:solidFill>
               </a:rPr>
               <a:t>Subquery inútil</a:t>
@@ -5235,7 +5235,7 @@
           <p:cNvPr id="19" name="">
             <a:extLst xmlns:a="http://schemas.openxmlformats.org/drawingml/2006/main">
               <a:ext uri="{FF2B5EF4-FFF2-40B4-BE49-F238E27FC236}">
-                <a16:creationId xmlns:a16="http://schemas.microsoft.com/office/drawing/2014/main" id="{1B4E510C-D37B-45ED-8BC4-52C0ECEA7943}"/>
+                <a16:creationId xmlns:a16="http://schemas.microsoft.com/office/drawing/2014/main" id="{A0227F6F-3EA7-4BEB-9336-E1A4E11C1B38}"/>
               </a:ext>
             </a:extLst>
           </p:cNvPr>
@@ -5327,7 +5327,7 @@
           <p:cNvPr id="20" name="">
             <a:extLst xmlns:a="http://schemas.openxmlformats.org/drawingml/2006/main">
               <a:ext uri="{FF2B5EF4-FFF2-40B4-BE49-F238E27FC236}">
-                <a16:creationId xmlns:a16="http://schemas.microsoft.com/office/drawing/2014/main" id="{2BA998D7-A0C4-4BDF-BEA5-A494BBE5D7BB}"/>
+                <a16:creationId xmlns:a16="http://schemas.microsoft.com/office/drawing/2014/main" id="{2A7E7E95-C5C6-4F37-92FC-FA640EC4655F}"/>
               </a:ext>
             </a:extLst>
           </p:cNvPr>
@@ -5360,7 +5360,7 @@
           <p:cNvPr id="21" name="">
             <a:extLst xmlns:a="http://schemas.openxmlformats.org/drawingml/2006/main">
               <a:ext uri="{FF2B5EF4-FFF2-40B4-BE49-F238E27FC236}">
-                <a16:creationId xmlns:a16="http://schemas.microsoft.com/office/drawing/2014/main" id="{E6AC8780-F842-48E2-9617-C2727BB761B1}"/>
+                <a16:creationId xmlns:a16="http://schemas.microsoft.com/office/drawing/2014/main" id="{5CAC134D-149F-4DFD-BAAA-A0C51D4A5106}"/>
               </a:ext>
             </a:extLst>
           </p:cNvPr>
@@ -5395,7 +5395,7 @@
           <p:cNvPr id="22" name="">
             <a:extLst xmlns:a="http://schemas.openxmlformats.org/drawingml/2006/main">
               <a:ext uri="{FF2B5EF4-FFF2-40B4-BE49-F238E27FC236}">
-                <a16:creationId xmlns:a16="http://schemas.microsoft.com/office/drawing/2014/main" id="{58EE5610-BD80-469E-9E0B-16BEF156C164}"/>
+                <a16:creationId xmlns:a16="http://schemas.microsoft.com/office/drawing/2014/main" id="{6B81F9CB-5400-49B9-AD44-B15E34DEE495}"/>
               </a:ext>
             </a:extLst>
           </p:cNvPr>
@@ -5453,7 +5453,7 @@
           <p:cNvPr id="23" name="">
             <a:extLst xmlns:a="http://schemas.openxmlformats.org/drawingml/2006/main">
               <a:ext uri="{FF2B5EF4-FFF2-40B4-BE49-F238E27FC236}">
-                <a16:creationId xmlns:a16="http://schemas.microsoft.com/office/drawing/2014/main" id="{07FCC40A-78C1-4985-9051-9683FE89FD53}"/>
+                <a16:creationId xmlns:a16="http://schemas.microsoft.com/office/drawing/2014/main" id="{FFBCB607-A15E-4659-AFF1-14C55C03CBC9}"/>
               </a:ext>
             </a:extLst>
           </p:cNvPr>
@@ -5491,14 +5491,14 @@
             <a:pPr algn="l">
               <a:defRPr sz="1050" b="1">
                 <a:solidFill>
-                  <a:srgbClr val="0E1B3E"/>
+                  <a:srgbClr val="070F26"/>
                 </a:solidFill>
               </a:defRPr>
             </a:pPr>
             <a:r>
               <a:rPr sz="1050" b="1">
                 <a:solidFill>
-                  <a:srgbClr val="0E1B3E"/>
+                  <a:srgbClr val="070F26"/>
                 </a:solidFill>
               </a:rPr>
               <a:t>FK redundante</a:t>
@@ -5511,7 +5511,7 @@
           <p:cNvPr id="24" name="">
             <a:extLst xmlns:a="http://schemas.openxmlformats.org/drawingml/2006/main">
               <a:ext uri="{FF2B5EF4-FFF2-40B4-BE49-F238E27FC236}">
-                <a16:creationId xmlns:a16="http://schemas.microsoft.com/office/drawing/2014/main" id="{802F41A9-FFEA-480E-8F5F-BFE1BC46BC9C}"/>
+                <a16:creationId xmlns:a16="http://schemas.microsoft.com/office/drawing/2014/main" id="{19615457-A42C-4036-A353-BA88D705C598}"/>
               </a:ext>
             </a:extLst>
           </p:cNvPr>
@@ -5603,7 +5603,7 @@
           <p:cNvPr id="25" name="">
             <a:extLst xmlns:a="http://schemas.openxmlformats.org/drawingml/2006/main">
               <a:ext uri="{FF2B5EF4-FFF2-40B4-BE49-F238E27FC236}">
-                <a16:creationId xmlns:a16="http://schemas.microsoft.com/office/drawing/2014/main" id="{54461DD6-7C12-4996-9E62-13EA0DB6AC1E}"/>
+                <a16:creationId xmlns:a16="http://schemas.microsoft.com/office/drawing/2014/main" id="{8AFD5AE8-B00D-4F92-A6E6-A0011BE84CDB}"/>
               </a:ext>
             </a:extLst>
           </p:cNvPr>
@@ -5636,7 +5636,7 @@
           <p:cNvPr id="26" name="">
             <a:extLst xmlns:a="http://schemas.openxmlformats.org/drawingml/2006/main">
               <a:ext uri="{FF2B5EF4-FFF2-40B4-BE49-F238E27FC236}">
-                <a16:creationId xmlns:a16="http://schemas.microsoft.com/office/drawing/2014/main" id="{E4BDF3D8-10AA-4F58-B3E7-3A4D74866FAF}"/>
+                <a16:creationId xmlns:a16="http://schemas.microsoft.com/office/drawing/2014/main" id="{02248773-8CA1-43F0-9D12-9D46E7396644}"/>
               </a:ext>
             </a:extLst>
           </p:cNvPr>
@@ -5671,7 +5671,7 @@
           <p:cNvPr id="27" name="">
             <a:extLst xmlns:a="http://schemas.openxmlformats.org/drawingml/2006/main">
               <a:ext uri="{FF2B5EF4-FFF2-40B4-BE49-F238E27FC236}">
-                <a16:creationId xmlns:a16="http://schemas.microsoft.com/office/drawing/2014/main" id="{622C2CC5-2368-4280-A33E-0DB9AB82977C}"/>
+                <a16:creationId xmlns:a16="http://schemas.microsoft.com/office/drawing/2014/main" id="{231D27F3-3A60-46B6-AAE3-E5DC3EA39F7F}"/>
               </a:ext>
             </a:extLst>
           </p:cNvPr>
@@ -5729,7 +5729,7 @@
           <p:cNvPr id="28" name="">
             <a:extLst xmlns:a="http://schemas.openxmlformats.org/drawingml/2006/main">
               <a:ext uri="{FF2B5EF4-FFF2-40B4-BE49-F238E27FC236}">
-                <a16:creationId xmlns:a16="http://schemas.microsoft.com/office/drawing/2014/main" id="{5DE3B501-7F17-4414-8619-F4BB04C647C0}"/>
+                <a16:creationId xmlns:a16="http://schemas.microsoft.com/office/drawing/2014/main" id="{0AD91574-02A5-4DBB-8BA8-0535AA12E301}"/>
               </a:ext>
             </a:extLst>
           </p:cNvPr>
@@ -5767,14 +5767,14 @@
             <a:pPr algn="l">
               <a:defRPr sz="1050" b="1">
                 <a:solidFill>
-                  <a:srgbClr val="0E1B3E"/>
+                  <a:srgbClr val="070F26"/>
                 </a:solidFill>
               </a:defRPr>
             </a:pPr>
             <a:r>
               <a:rPr sz="1050" b="1">
                 <a:solidFill>
-                  <a:srgbClr val="0E1B3E"/>
+                  <a:srgbClr val="070F26"/>
                 </a:solidFill>
               </a:rPr>
               <a:t>AVG repetido</a:t>
@@ -5787,7 +5787,7 @@
           <p:cNvPr id="29" name="">
             <a:extLst xmlns:a="http://schemas.openxmlformats.org/drawingml/2006/main">
               <a:ext uri="{FF2B5EF4-FFF2-40B4-BE49-F238E27FC236}">
-                <a16:creationId xmlns:a16="http://schemas.microsoft.com/office/drawing/2014/main" id="{FB13E618-84DF-4BC3-9444-77777670D010}"/>
+                <a16:creationId xmlns:a16="http://schemas.microsoft.com/office/drawing/2014/main" id="{C905CE44-0178-4627-8A5A-6265937C0353}"/>
               </a:ext>
             </a:extLst>
           </p:cNvPr>
@@ -5877,7 +5877,7 @@
     </p:spTree>
     <p:extLst>
       <p:ext uri="{BB962C8B-B14F-4D97-AF65-F5344CB8AC3E}">
-        <p14:creationId xmlns:p14="http://schemas.microsoft.com/office/powerpoint/2010/main" val="971723375"/>
+        <p14:creationId xmlns:p14="http://schemas.microsoft.com/office/powerpoint/2010/main" val="508721275"/>
       </p:ext>
     </p:extLst>
   </p:cSld>
@@ -5908,7 +5908,7 @@
           <p:cNvPr id="1" name="">
             <a:extLst xmlns:a="http://schemas.openxmlformats.org/drawingml/2006/main">
               <a:ext uri="{FF2B5EF4-FFF2-40B4-BE49-F238E27FC236}">
-                <a16:creationId xmlns:a16="http://schemas.microsoft.com/office/drawing/2014/main" id="{98D3A4FD-C10A-401C-BF3C-CB70C556DBC4}"/>
+                <a16:creationId xmlns:a16="http://schemas.microsoft.com/office/drawing/2014/main" id="{8CB296D4-7B7B-4674-87E1-BA3FB1CA4BE5}"/>
               </a:ext>
             </a:extLst>
           </p:cNvPr>
@@ -5947,7 +5947,7 @@
           <p:nvPr/>
         </p:nvPicPr>
         <p:blipFill>
-          <a:blip xmlns:r="http://schemas.openxmlformats.org/officeDocument/2006/relationships" xmlns:a="http://schemas.openxmlformats.org/drawingml/2006/main" r:embed="Re9e94c5425b74b1a"/>
+          <a:blip xmlns:r="http://schemas.openxmlformats.org/officeDocument/2006/relationships" xmlns:a="http://schemas.openxmlformats.org/drawingml/2006/main" r:embed="Rffdc322973544280"/>
           <a:stretch xmlns:a="http://schemas.openxmlformats.org/drawingml/2006/main"/>
         </p:blipFill>
         <p:spPr>
@@ -5965,7 +5965,7 @@
           <p:cNvPr id="3" name="">
             <a:extLst xmlns:a="http://schemas.openxmlformats.org/drawingml/2006/main">
               <a:ext uri="{FF2B5EF4-FFF2-40B4-BE49-F238E27FC236}">
-                <a16:creationId xmlns:a16="http://schemas.microsoft.com/office/drawing/2014/main" id="{B82C3962-77FB-431E-B454-C9E54C7E998A}"/>
+                <a16:creationId xmlns:a16="http://schemas.microsoft.com/office/drawing/2014/main" id="{B164DB56-1A4C-41A7-9F7D-0DD86421CCC6}"/>
               </a:ext>
             </a:extLst>
           </p:cNvPr>
@@ -6003,14 +6003,14 @@
             <a:pPr algn="r">
               <a:defRPr sz="825" b="1">
                 <a:solidFill>
-                  <a:srgbClr val="0E1B3E"/>
+                  <a:srgbClr val="070F26"/>
                 </a:solidFill>
               </a:defRPr>
             </a:pPr>
             <a:r>
               <a:rPr sz="825" b="1">
                 <a:solidFill>
-                  <a:srgbClr val="0E1B3E"/>
+                  <a:srgbClr val="070F26"/>
                 </a:solidFill>
               </a:rPr>
               <a:t>NTT DATA UNIVERSITY</a:t>
@@ -6023,7 +6023,7 @@
           <p:cNvPr id="4" name="">
             <a:extLst xmlns:a="http://schemas.openxmlformats.org/drawingml/2006/main">
               <a:ext uri="{FF2B5EF4-FFF2-40B4-BE49-F238E27FC236}">
-                <a16:creationId xmlns:a16="http://schemas.microsoft.com/office/drawing/2014/main" id="{F4153B28-A3BB-48E7-9636-C0AD6249C3D0}"/>
+                <a16:creationId xmlns:a16="http://schemas.microsoft.com/office/drawing/2014/main" id="{23019523-5EE3-42D9-ABC9-A2323EFC4AC2}"/>
               </a:ext>
             </a:extLst>
           </p:cNvPr>
@@ -6081,7 +6081,7 @@
           <p:cNvPr id="5" name="">
             <a:extLst xmlns:a="http://schemas.openxmlformats.org/drawingml/2006/main">
               <a:ext uri="{FF2B5EF4-FFF2-40B4-BE49-F238E27FC236}">
-                <a16:creationId xmlns:a16="http://schemas.microsoft.com/office/drawing/2014/main" id="{DBACAF5B-ABBD-463A-9F75-FAF18C4B78D8}"/>
+                <a16:creationId xmlns:a16="http://schemas.microsoft.com/office/drawing/2014/main" id="{941B8BD3-6CCE-4CBD-B989-A8419AE31753}"/>
               </a:ext>
             </a:extLst>
           </p:cNvPr>
@@ -6139,7 +6139,7 @@
           <p:cNvPr id="6" name="">
             <a:extLst xmlns:a="http://schemas.openxmlformats.org/drawingml/2006/main">
               <a:ext uri="{FF2B5EF4-FFF2-40B4-BE49-F238E27FC236}">
-                <a16:creationId xmlns:a16="http://schemas.microsoft.com/office/drawing/2014/main" id="{140F043E-3A5E-4634-B213-0B7785D7170A}"/>
+                <a16:creationId xmlns:a16="http://schemas.microsoft.com/office/drawing/2014/main" id="{A17E46B4-9740-41B9-9FDD-4B791FA73AFF}"/>
               </a:ext>
             </a:extLst>
           </p:cNvPr>
@@ -6177,14 +6177,14 @@
             <a:pPr algn="r">
               <a:defRPr sz="675" b="1">
                 <a:solidFill>
-                  <a:srgbClr val="0E1B3E"/>
+                  <a:srgbClr val="070F26"/>
                 </a:solidFill>
               </a:defRPr>
             </a:pPr>
             <a:r>
               <a:rPr sz="675" b="1">
                 <a:solidFill>
-                  <a:srgbClr val="0E1B3E"/>
+                  <a:srgbClr val="070F26"/>
                 </a:solidFill>
               </a:rPr>
               <a:t>NTT DATA UNIVERSITY</a:t>
@@ -6197,7 +6197,7 @@
           <p:cNvPr id="7" name="">
             <a:extLst xmlns:a="http://schemas.openxmlformats.org/drawingml/2006/main">
               <a:ext uri="{FF2B5EF4-FFF2-40B4-BE49-F238E27FC236}">
-                <a16:creationId xmlns:a16="http://schemas.microsoft.com/office/drawing/2014/main" id="{89F98462-11B1-4C2D-AEBE-C9ECC22F07F0}"/>
+                <a16:creationId xmlns:a16="http://schemas.microsoft.com/office/drawing/2014/main" id="{7846EC84-4F5F-4A95-8215-22E6ECE50A41}"/>
               </a:ext>
             </a:extLst>
           </p:cNvPr>
@@ -6255,7 +6255,7 @@
           <p:cNvPr id="8" name="">
             <a:extLst xmlns:a="http://schemas.openxmlformats.org/drawingml/2006/main">
               <a:ext uri="{FF2B5EF4-FFF2-40B4-BE49-F238E27FC236}">
-                <a16:creationId xmlns:a16="http://schemas.microsoft.com/office/drawing/2014/main" id="{40F3B46C-EDD3-4992-981D-480576DB2A31}"/>
+                <a16:creationId xmlns:a16="http://schemas.microsoft.com/office/drawing/2014/main" id="{1C512301-DDD6-43D9-8A15-DAE580DC3BD7}"/>
               </a:ext>
             </a:extLst>
           </p:cNvPr>
@@ -6293,14 +6293,14 @@
             <a:pPr algn="l">
               <a:defRPr sz="2400" b="0">
                 <a:solidFill>
-                  <a:srgbClr val="0E1B3E"/>
+                  <a:srgbClr val="070F26"/>
                 </a:solidFill>
               </a:defRPr>
             </a:pPr>
             <a:r>
               <a:rPr sz="2400" b="0">
                 <a:solidFill>
-                  <a:srgbClr val="0E1B3E"/>
+                  <a:srgbClr val="070F26"/>
                 </a:solidFill>
               </a:rPr>
               <a:t>Query refatorada — construída coletivamente</a:t>
@@ -6313,7 +6313,7 @@
           <p:cNvPr id="9" name="">
             <a:extLst xmlns:a="http://schemas.openxmlformats.org/drawingml/2006/main">
               <a:ext uri="{FF2B5EF4-FFF2-40B4-BE49-F238E27FC236}">
-                <a16:creationId xmlns:a16="http://schemas.microsoft.com/office/drawing/2014/main" id="{49FDB4C9-802B-47C5-A511-487388B3C451}"/>
+                <a16:creationId xmlns:a16="http://schemas.microsoft.com/office/drawing/2014/main" id="{D7CCC96D-A9B3-4F4B-8B8F-60AFFA35F4A2}"/>
               </a:ext>
             </a:extLst>
           </p:cNvPr>
@@ -6371,7 +6371,7 @@
           <p:cNvPr id="10" name="">
             <a:extLst xmlns:a="http://schemas.openxmlformats.org/drawingml/2006/main">
               <a:ext uri="{FF2B5EF4-FFF2-40B4-BE49-F238E27FC236}">
-                <a16:creationId xmlns:a16="http://schemas.microsoft.com/office/drawing/2014/main" id="{4B71CB3B-BD46-4A8F-B72B-0AEE884AB610}"/>
+                <a16:creationId xmlns:a16="http://schemas.microsoft.com/office/drawing/2014/main" id="{25CDCDCB-07EA-4745-8AAB-9E622469D008}"/>
               </a:ext>
             </a:extLst>
           </p:cNvPr>
@@ -6404,7 +6404,7 @@
           <p:cNvPr id="11" name="">
             <a:extLst xmlns:a="http://schemas.openxmlformats.org/drawingml/2006/main">
               <a:ext uri="{FF2B5EF4-FFF2-40B4-BE49-F238E27FC236}">
-                <a16:creationId xmlns:a16="http://schemas.microsoft.com/office/drawing/2014/main" id="{F7731C25-95FC-4D5D-9476-E47EAD1A39E5}"/>
+                <a16:creationId xmlns:a16="http://schemas.microsoft.com/office/drawing/2014/main" id="{A706BD37-C235-4D2D-80B6-68AA38E6AB1F}"/>
               </a:ext>
             </a:extLst>
           </p:cNvPr>
@@ -6439,7 +6439,7 @@
           <p:cNvPr id="12" name="">
             <a:extLst xmlns:a="http://schemas.openxmlformats.org/drawingml/2006/main">
               <a:ext uri="{FF2B5EF4-FFF2-40B4-BE49-F238E27FC236}">
-                <a16:creationId xmlns:a16="http://schemas.microsoft.com/office/drawing/2014/main" id="{55C0D811-0377-4E6F-AA84-4A244833CC9A}"/>
+                <a16:creationId xmlns:a16="http://schemas.microsoft.com/office/drawing/2014/main" id="{1C3DCB05-056A-4802-8A4F-1C74FB778F57}"/>
               </a:ext>
             </a:extLst>
           </p:cNvPr>
@@ -6497,7 +6497,7 @@
           <p:cNvPr id="13" name="">
             <a:extLst xmlns:a="http://schemas.openxmlformats.org/drawingml/2006/main">
               <a:ext uri="{FF2B5EF4-FFF2-40B4-BE49-F238E27FC236}">
-                <a16:creationId xmlns:a16="http://schemas.microsoft.com/office/drawing/2014/main" id="{492AC95C-2102-43E4-BF8E-30D5D83C5118}"/>
+                <a16:creationId xmlns:a16="http://schemas.microsoft.com/office/drawing/2014/main" id="{CDDCECAC-E64D-49C7-8301-94644E61CEDA}"/>
               </a:ext>
             </a:extLst>
           </p:cNvPr>
@@ -6691,7 +6691,7 @@
           <p:cNvPr id="14" name="">
             <a:extLst xmlns:a="http://schemas.openxmlformats.org/drawingml/2006/main">
               <a:ext uri="{FF2B5EF4-FFF2-40B4-BE49-F238E27FC236}">
-                <a16:creationId xmlns:a16="http://schemas.microsoft.com/office/drawing/2014/main" id="{8266DE9D-1477-4F65-8E47-B9C1C4507CA4}"/>
+                <a16:creationId xmlns:a16="http://schemas.microsoft.com/office/drawing/2014/main" id="{86E1DF2D-C9BB-4809-AFD3-8947F7BBC210}"/>
               </a:ext>
             </a:extLst>
           </p:cNvPr>
@@ -6724,7 +6724,7 @@
           <p:cNvPr id="15" name="">
             <a:extLst xmlns:a="http://schemas.openxmlformats.org/drawingml/2006/main">
               <a:ext uri="{FF2B5EF4-FFF2-40B4-BE49-F238E27FC236}">
-                <a16:creationId xmlns:a16="http://schemas.microsoft.com/office/drawing/2014/main" id="{B64574B7-1C50-4865-B1E2-ECC597C47B7E}"/>
+                <a16:creationId xmlns:a16="http://schemas.microsoft.com/office/drawing/2014/main" id="{E089CFE1-0804-42A0-BE27-12C6C977912A}"/>
               </a:ext>
             </a:extLst>
           </p:cNvPr>
@@ -6759,7 +6759,7 @@
           <p:cNvPr id="16" name="">
             <a:extLst xmlns:a="http://schemas.openxmlformats.org/drawingml/2006/main">
               <a:ext uri="{FF2B5EF4-FFF2-40B4-BE49-F238E27FC236}">
-                <a16:creationId xmlns:a16="http://schemas.microsoft.com/office/drawing/2014/main" id="{6378C84D-BA15-46EC-92B3-E791B4DB2E3C}"/>
+                <a16:creationId xmlns:a16="http://schemas.microsoft.com/office/drawing/2014/main" id="{5C5367F7-EDBC-40C6-B968-312029678DCF}"/>
               </a:ext>
             </a:extLst>
           </p:cNvPr>
@@ -6817,7 +6817,7 @@
           <p:cNvPr id="17" name="">
             <a:extLst xmlns:a="http://schemas.openxmlformats.org/drawingml/2006/main">
               <a:ext uri="{FF2B5EF4-FFF2-40B4-BE49-F238E27FC236}">
-                <a16:creationId xmlns:a16="http://schemas.microsoft.com/office/drawing/2014/main" id="{56C856F3-43DA-4739-80D3-2171AC550E35}"/>
+                <a16:creationId xmlns:a16="http://schemas.microsoft.com/office/drawing/2014/main" id="{78D999DA-B5A9-490C-AA56-99B4DAADA628}"/>
               </a:ext>
             </a:extLst>
           </p:cNvPr>
@@ -6992,7 +6992,7 @@
     </p:spTree>
     <p:extLst>
       <p:ext uri="{BB962C8B-B14F-4D97-AF65-F5344CB8AC3E}">
-        <p14:creationId xmlns:p14="http://schemas.microsoft.com/office/powerpoint/2010/main" val="1967287193"/>
+        <p14:creationId xmlns:p14="http://schemas.microsoft.com/office/powerpoint/2010/main" val="572754937"/>
       </p:ext>
     </p:extLst>
   </p:cSld>
@@ -7023,7 +7023,7 @@
           <p:cNvPr id="1" name="">
             <a:extLst xmlns:a="http://schemas.openxmlformats.org/drawingml/2006/main">
               <a:ext uri="{FF2B5EF4-FFF2-40B4-BE49-F238E27FC236}">
-                <a16:creationId xmlns:a16="http://schemas.microsoft.com/office/drawing/2014/main" id="{57AFC5B0-02FE-4E6F-AEEA-F4F57CDA9576}"/>
+                <a16:creationId xmlns:a16="http://schemas.microsoft.com/office/drawing/2014/main" id="{02C0AA4C-6D76-4DA9-8AC1-60B58B8B4C3C}"/>
               </a:ext>
             </a:extLst>
           </p:cNvPr>
@@ -7062,7 +7062,7 @@
           <p:nvPr/>
         </p:nvPicPr>
         <p:blipFill>
-          <a:blip xmlns:r="http://schemas.openxmlformats.org/officeDocument/2006/relationships" xmlns:a="http://schemas.openxmlformats.org/drawingml/2006/main" r:embed="R9b959091bb934a97"/>
+          <a:blip xmlns:r="http://schemas.openxmlformats.org/officeDocument/2006/relationships" xmlns:a="http://schemas.openxmlformats.org/drawingml/2006/main" r:embed="Ra75765041da548b3"/>
           <a:stretch xmlns:a="http://schemas.openxmlformats.org/drawingml/2006/main"/>
         </p:blipFill>
         <p:spPr>
@@ -7080,7 +7080,7 @@
           <p:cNvPr id="3" name="">
             <a:extLst xmlns:a="http://schemas.openxmlformats.org/drawingml/2006/main">
               <a:ext uri="{FF2B5EF4-FFF2-40B4-BE49-F238E27FC236}">
-                <a16:creationId xmlns:a16="http://schemas.microsoft.com/office/drawing/2014/main" id="{8D132FD7-A43E-4A56-A519-4AB012D8AB48}"/>
+                <a16:creationId xmlns:a16="http://schemas.microsoft.com/office/drawing/2014/main" id="{98E6159E-8962-4B3F-8858-ADF19BB59035}"/>
               </a:ext>
             </a:extLst>
           </p:cNvPr>
@@ -7118,14 +7118,14 @@
             <a:pPr algn="r">
               <a:defRPr sz="825" b="1">
                 <a:solidFill>
-                  <a:srgbClr val="0E1B3E"/>
+                  <a:srgbClr val="070F26"/>
                 </a:solidFill>
               </a:defRPr>
             </a:pPr>
             <a:r>
               <a:rPr sz="825" b="1">
                 <a:solidFill>
-                  <a:srgbClr val="0E1B3E"/>
+                  <a:srgbClr val="070F26"/>
                 </a:solidFill>
               </a:rPr>
               <a:t>NTT DATA UNIVERSITY</a:t>
@@ -7138,7 +7138,7 @@
           <p:cNvPr id="4" name="">
             <a:extLst xmlns:a="http://schemas.openxmlformats.org/drawingml/2006/main">
               <a:ext uri="{FF2B5EF4-FFF2-40B4-BE49-F238E27FC236}">
-                <a16:creationId xmlns:a16="http://schemas.microsoft.com/office/drawing/2014/main" id="{30E867B3-0F92-4AFD-B588-55CB48AB9D59}"/>
+                <a16:creationId xmlns:a16="http://schemas.microsoft.com/office/drawing/2014/main" id="{F813A578-7137-4BEE-AFB9-674A3E82D856}"/>
               </a:ext>
             </a:extLst>
           </p:cNvPr>
@@ -7196,7 +7196,7 @@
           <p:cNvPr id="5" name="">
             <a:extLst xmlns:a="http://schemas.openxmlformats.org/drawingml/2006/main">
               <a:ext uri="{FF2B5EF4-FFF2-40B4-BE49-F238E27FC236}">
-                <a16:creationId xmlns:a16="http://schemas.microsoft.com/office/drawing/2014/main" id="{A1DA9146-3443-414E-A4B7-EBB414964AAE}"/>
+                <a16:creationId xmlns:a16="http://schemas.microsoft.com/office/drawing/2014/main" id="{6D38C874-E4A7-41CC-A416-5DB5FF954810}"/>
               </a:ext>
             </a:extLst>
           </p:cNvPr>
@@ -7254,7 +7254,7 @@
           <p:cNvPr id="6" name="">
             <a:extLst xmlns:a="http://schemas.openxmlformats.org/drawingml/2006/main">
               <a:ext uri="{FF2B5EF4-FFF2-40B4-BE49-F238E27FC236}">
-                <a16:creationId xmlns:a16="http://schemas.microsoft.com/office/drawing/2014/main" id="{38E98038-98F3-457A-B715-980D90F60C75}"/>
+                <a16:creationId xmlns:a16="http://schemas.microsoft.com/office/drawing/2014/main" id="{1AAFCF87-05C6-4895-8D54-46C284AB051D}"/>
               </a:ext>
             </a:extLst>
           </p:cNvPr>
@@ -7292,14 +7292,14 @@
             <a:pPr algn="r">
               <a:defRPr sz="675" b="1">
                 <a:solidFill>
-                  <a:srgbClr val="0E1B3E"/>
+                  <a:srgbClr val="070F26"/>
                 </a:solidFill>
               </a:defRPr>
             </a:pPr>
             <a:r>
               <a:rPr sz="675" b="1">
                 <a:solidFill>
-                  <a:srgbClr val="0E1B3E"/>
+                  <a:srgbClr val="070F26"/>
                 </a:solidFill>
               </a:rPr>
               <a:t>NTT DATA UNIVERSITY</a:t>
@@ -7312,7 +7312,7 @@
           <p:cNvPr id="7" name="">
             <a:extLst xmlns:a="http://schemas.openxmlformats.org/drawingml/2006/main">
               <a:ext uri="{FF2B5EF4-FFF2-40B4-BE49-F238E27FC236}">
-                <a16:creationId xmlns:a16="http://schemas.microsoft.com/office/drawing/2014/main" id="{39CFC5F2-7393-4173-8719-687AFF241F55}"/>
+                <a16:creationId xmlns:a16="http://schemas.microsoft.com/office/drawing/2014/main" id="{C59A6B1D-4624-49AE-87A3-2CDDC3394378}"/>
               </a:ext>
             </a:extLst>
           </p:cNvPr>
@@ -7370,7 +7370,7 @@
           <p:cNvPr id="8" name="">
             <a:extLst xmlns:a="http://schemas.openxmlformats.org/drawingml/2006/main">
               <a:ext uri="{FF2B5EF4-FFF2-40B4-BE49-F238E27FC236}">
-                <a16:creationId xmlns:a16="http://schemas.microsoft.com/office/drawing/2014/main" id="{69F4F627-2663-462B-97D2-1092246DC9E0}"/>
+                <a16:creationId xmlns:a16="http://schemas.microsoft.com/office/drawing/2014/main" id="{917E7294-54F7-4E15-863D-6DB33F37EF9E}"/>
               </a:ext>
             </a:extLst>
           </p:cNvPr>
@@ -7408,14 +7408,14 @@
             <a:pPr algn="l">
               <a:defRPr sz="2400" b="0">
                 <a:solidFill>
-                  <a:srgbClr val="0E1B3E"/>
+                  <a:srgbClr val="070F26"/>
                 </a:solidFill>
               </a:defRPr>
             </a:pPr>
             <a:r>
               <a:rPr sz="2400" b="0">
                 <a:solidFill>
-                  <a:srgbClr val="0E1B3E"/>
+                  <a:srgbClr val="070F26"/>
                 </a:solidFill>
               </a:rPr>
               <a:t>EXPLAIN QUERY PLAN — o que observar</a:t>
@@ -7428,7 +7428,7 @@
           <p:cNvPr id="9" name="">
             <a:extLst xmlns:a="http://schemas.openxmlformats.org/drawingml/2006/main">
               <a:ext uri="{FF2B5EF4-FFF2-40B4-BE49-F238E27FC236}">
-                <a16:creationId xmlns:a16="http://schemas.microsoft.com/office/drawing/2014/main" id="{692214F9-8A3D-4EC1-AFB1-5D3410CD967A}"/>
+                <a16:creationId xmlns:a16="http://schemas.microsoft.com/office/drawing/2014/main" id="{5251BAAB-A89A-4C37-A1C1-29425FC82B08}"/>
               </a:ext>
             </a:extLst>
           </p:cNvPr>
@@ -7486,7 +7486,7 @@
           <p:cNvPr id="10" name="">
             <a:extLst xmlns:a="http://schemas.openxmlformats.org/drawingml/2006/main">
               <a:ext uri="{FF2B5EF4-FFF2-40B4-BE49-F238E27FC236}">
-                <a16:creationId xmlns:a16="http://schemas.microsoft.com/office/drawing/2014/main" id="{4E95B9C8-6333-4D8D-A565-C95525C901B1}"/>
+                <a16:creationId xmlns:a16="http://schemas.microsoft.com/office/drawing/2014/main" id="{A7B9B1CA-95E5-42B5-91A5-CD06DE4B0577}"/>
               </a:ext>
             </a:extLst>
           </p:cNvPr>
@@ -7519,7 +7519,7 @@
           <p:cNvPr id="11" name="">
             <a:extLst xmlns:a="http://schemas.openxmlformats.org/drawingml/2006/main">
               <a:ext uri="{FF2B5EF4-FFF2-40B4-BE49-F238E27FC236}">
-                <a16:creationId xmlns:a16="http://schemas.microsoft.com/office/drawing/2014/main" id="{641B2F2F-D6DF-45F9-BB53-D038703524AB}"/>
+                <a16:creationId xmlns:a16="http://schemas.microsoft.com/office/drawing/2014/main" id="{86547230-C073-466E-860B-A685518D6E3B}"/>
               </a:ext>
             </a:extLst>
           </p:cNvPr>
@@ -7554,7 +7554,7 @@
           <p:cNvPr id="12" name="">
             <a:extLst xmlns:a="http://schemas.openxmlformats.org/drawingml/2006/main">
               <a:ext uri="{FF2B5EF4-FFF2-40B4-BE49-F238E27FC236}">
-                <a16:creationId xmlns:a16="http://schemas.microsoft.com/office/drawing/2014/main" id="{7C4D96EA-D09F-447B-8BB5-ADED3F26804F}"/>
+                <a16:creationId xmlns:a16="http://schemas.microsoft.com/office/drawing/2014/main" id="{26A94C88-0293-4F89-A9C3-1C36B70BBD42}"/>
               </a:ext>
             </a:extLst>
           </p:cNvPr>
@@ -7612,7 +7612,7 @@
           <p:cNvPr id="13" name="">
             <a:extLst xmlns:a="http://schemas.openxmlformats.org/drawingml/2006/main">
               <a:ext uri="{FF2B5EF4-FFF2-40B4-BE49-F238E27FC236}">
-                <a16:creationId xmlns:a16="http://schemas.microsoft.com/office/drawing/2014/main" id="{4585D3CB-CE87-4BBF-B5EA-46B703E77326}"/>
+                <a16:creationId xmlns:a16="http://schemas.microsoft.com/office/drawing/2014/main" id="{A0294D10-4E08-454D-8AD6-260BCF5E44B5}"/>
               </a:ext>
             </a:extLst>
           </p:cNvPr>
@@ -7704,7 +7704,7 @@
           <p:cNvPr id="14" name="">
             <a:extLst xmlns:a="http://schemas.openxmlformats.org/drawingml/2006/main">
               <a:ext uri="{FF2B5EF4-FFF2-40B4-BE49-F238E27FC236}">
-                <a16:creationId xmlns:a16="http://schemas.microsoft.com/office/drawing/2014/main" id="{E1EE0FDA-AE6C-43C1-8C1D-D45B98116558}"/>
+                <a16:creationId xmlns:a16="http://schemas.microsoft.com/office/drawing/2014/main" id="{40A0AB7F-5C04-4414-923F-72701C6FD20E}"/>
               </a:ext>
             </a:extLst>
           </p:cNvPr>
@@ -7737,7 +7737,7 @@
           <p:cNvPr id="15" name="">
             <a:extLst xmlns:a="http://schemas.openxmlformats.org/drawingml/2006/main">
               <a:ext uri="{FF2B5EF4-FFF2-40B4-BE49-F238E27FC236}">
-                <a16:creationId xmlns:a16="http://schemas.microsoft.com/office/drawing/2014/main" id="{875074AD-5672-4EC3-9A32-35D9B426AE58}"/>
+                <a16:creationId xmlns:a16="http://schemas.microsoft.com/office/drawing/2014/main" id="{FA08322B-8A26-4A1C-B6A4-A31FC5AEC098}"/>
               </a:ext>
             </a:extLst>
           </p:cNvPr>
@@ -7772,7 +7772,7 @@
           <p:cNvPr id="16" name="">
             <a:extLst xmlns:a="http://schemas.openxmlformats.org/drawingml/2006/main">
               <a:ext uri="{FF2B5EF4-FFF2-40B4-BE49-F238E27FC236}">
-                <a16:creationId xmlns:a16="http://schemas.microsoft.com/office/drawing/2014/main" id="{6F3B0421-1BDA-4DC2-9CB1-2565BBA3B5F0}"/>
+                <a16:creationId xmlns:a16="http://schemas.microsoft.com/office/drawing/2014/main" id="{AADC83A3-4A5D-4C49-BE7F-118AD58D5B60}"/>
               </a:ext>
             </a:extLst>
           </p:cNvPr>
@@ -7830,7 +7830,7 @@
           <p:cNvPr id="17" name="">
             <a:extLst xmlns:a="http://schemas.openxmlformats.org/drawingml/2006/main">
               <a:ext uri="{FF2B5EF4-FFF2-40B4-BE49-F238E27FC236}">
-                <a16:creationId xmlns:a16="http://schemas.microsoft.com/office/drawing/2014/main" id="{DD6EE887-C613-4B63-AD4D-49AF852AE9B7}"/>
+                <a16:creationId xmlns:a16="http://schemas.microsoft.com/office/drawing/2014/main" id="{F3D40258-68C4-4071-9C0D-4404E7EBC362}"/>
               </a:ext>
             </a:extLst>
           </p:cNvPr>
@@ -7922,7 +7922,7 @@
           <p:cNvPr id="18" name="">
             <a:extLst xmlns:a="http://schemas.openxmlformats.org/drawingml/2006/main">
               <a:ext uri="{FF2B5EF4-FFF2-40B4-BE49-F238E27FC236}">
-                <a16:creationId xmlns:a16="http://schemas.microsoft.com/office/drawing/2014/main" id="{C05EEA08-D041-4DED-A679-118101E4844B}"/>
+                <a16:creationId xmlns:a16="http://schemas.microsoft.com/office/drawing/2014/main" id="{239F6AEC-E713-49A4-9377-B041C57F346B}"/>
               </a:ext>
             </a:extLst>
           </p:cNvPr>
@@ -7955,7 +7955,7 @@
           <p:cNvPr id="19" name="">
             <a:extLst xmlns:a="http://schemas.openxmlformats.org/drawingml/2006/main">
               <a:ext uri="{FF2B5EF4-FFF2-40B4-BE49-F238E27FC236}">
-                <a16:creationId xmlns:a16="http://schemas.microsoft.com/office/drawing/2014/main" id="{C861669D-3908-461F-AEF5-DD6547AD1A66}"/>
+                <a16:creationId xmlns:a16="http://schemas.microsoft.com/office/drawing/2014/main" id="{6D1A6F41-486E-42CA-9C38-AE21E832965E}"/>
               </a:ext>
             </a:extLst>
           </p:cNvPr>
@@ -7990,7 +7990,7 @@
           <p:cNvPr id="20" name="">
             <a:extLst xmlns:a="http://schemas.openxmlformats.org/drawingml/2006/main">
               <a:ext uri="{FF2B5EF4-FFF2-40B4-BE49-F238E27FC236}">
-                <a16:creationId xmlns:a16="http://schemas.microsoft.com/office/drawing/2014/main" id="{6BE321D2-A4B8-4075-9477-B0DF7F35633A}"/>
+                <a16:creationId xmlns:a16="http://schemas.microsoft.com/office/drawing/2014/main" id="{2A302ABA-F433-4948-818F-B437DA3FE48F}"/>
               </a:ext>
             </a:extLst>
           </p:cNvPr>
@@ -8048,7 +8048,7 @@
           <p:cNvPr id="21" name="">
             <a:extLst xmlns:a="http://schemas.openxmlformats.org/drawingml/2006/main">
               <a:ext uri="{FF2B5EF4-FFF2-40B4-BE49-F238E27FC236}">
-                <a16:creationId xmlns:a16="http://schemas.microsoft.com/office/drawing/2014/main" id="{F7EBFDB1-4280-43D2-8B4A-9C64ABD92166}"/>
+                <a16:creationId xmlns:a16="http://schemas.microsoft.com/office/drawing/2014/main" id="{F611AB89-08B9-4E65-95E8-2141395D3B52}"/>
               </a:ext>
             </a:extLst>
           </p:cNvPr>
@@ -8138,7 +8138,7 @@
     </p:spTree>
     <p:extLst>
       <p:ext uri="{BB962C8B-B14F-4D97-AF65-F5344CB8AC3E}">
-        <p14:creationId xmlns:p14="http://schemas.microsoft.com/office/powerpoint/2010/main" val="1272230158"/>
+        <p14:creationId xmlns:p14="http://schemas.microsoft.com/office/powerpoint/2010/main" val="2004770453"/>
       </p:ext>
     </p:extLst>
   </p:cSld>
@@ -8151,7 +8151,7 @@
     <p:bg>
       <p:bgPr>
         <a:solidFill xmlns:a="http://schemas.openxmlformats.org/drawingml/2006/main">
-          <a:srgbClr val="0E1B3E"/>
+          <a:srgbClr val="070F26"/>
         </a:solidFill>
       </p:bgPr>
     </p:bg>
@@ -8169,7 +8169,7 @@
           <p:cNvPr id="1" name="">
             <a:extLst xmlns:a="http://schemas.openxmlformats.org/drawingml/2006/main">
               <a:ext uri="{FF2B5EF4-FFF2-40B4-BE49-F238E27FC236}">
-                <a16:creationId xmlns:a16="http://schemas.microsoft.com/office/drawing/2014/main" id="{C256B351-84E5-4021-A057-2F4D4E0CBB95}"/>
+                <a16:creationId xmlns:a16="http://schemas.microsoft.com/office/drawing/2014/main" id="{1AECA7EE-B012-4C21-A1CC-7CB218EBC9D0}"/>
               </a:ext>
             </a:extLst>
           </p:cNvPr>
@@ -8187,7 +8187,7 @@
             <a:avLst/>
           </a:prstGeom>
           <a:solidFill xmlns:a="http://schemas.openxmlformats.org/drawingml/2006/main">
-            <a:srgbClr val="0E1B3E"/>
+            <a:srgbClr val="070F26"/>
           </a:solidFill>
           <a:ln xmlns:a="http://schemas.openxmlformats.org/drawingml/2006/main" w="0">
             <a:solidFill>
@@ -8208,7 +8208,7 @@
           <p:nvPr/>
         </p:nvPicPr>
         <p:blipFill>
-          <a:blip xmlns:r="http://schemas.openxmlformats.org/officeDocument/2006/relationships" xmlns:a="http://schemas.openxmlformats.org/drawingml/2006/main" r:embed="Rc8e077b87aff4580"/>
+          <a:blip xmlns:r="http://schemas.openxmlformats.org/officeDocument/2006/relationships" xmlns:a="http://schemas.openxmlformats.org/drawingml/2006/main" r:embed="R9784d536dbef4acd"/>
           <a:stretch xmlns:a="http://schemas.openxmlformats.org/drawingml/2006/main"/>
         </p:blipFill>
         <p:spPr>
@@ -8226,7 +8226,7 @@
           <p:cNvPr id="3" name="">
             <a:extLst xmlns:a="http://schemas.openxmlformats.org/drawingml/2006/main">
               <a:ext uri="{FF2B5EF4-FFF2-40B4-BE49-F238E27FC236}">
-                <a16:creationId xmlns:a16="http://schemas.microsoft.com/office/drawing/2014/main" id="{17005B59-0F9D-487F-BACF-E8D06443643B}"/>
+                <a16:creationId xmlns:a16="http://schemas.microsoft.com/office/drawing/2014/main" id="{F10D2189-B3F7-45BC-8034-9E730A449CBB}"/>
               </a:ext>
             </a:extLst>
           </p:cNvPr>
@@ -8284,7 +8284,7 @@
           <p:cNvPr id="4" name="">
             <a:extLst xmlns:a="http://schemas.openxmlformats.org/drawingml/2006/main">
               <a:ext uri="{FF2B5EF4-FFF2-40B4-BE49-F238E27FC236}">
-                <a16:creationId xmlns:a16="http://schemas.microsoft.com/office/drawing/2014/main" id="{546C0F1D-CDDF-4D63-8E02-3EA9B0B9D36A}"/>
+                <a16:creationId xmlns:a16="http://schemas.microsoft.com/office/drawing/2014/main" id="{B417C09C-5BDE-4374-B095-018D87695C5B}"/>
               </a:ext>
             </a:extLst>
           </p:cNvPr>
@@ -8342,7 +8342,7 @@
           <p:cNvPr id="5" name="">
             <a:extLst xmlns:a="http://schemas.openxmlformats.org/drawingml/2006/main">
               <a:ext uri="{FF2B5EF4-FFF2-40B4-BE49-F238E27FC236}">
-                <a16:creationId xmlns:a16="http://schemas.microsoft.com/office/drawing/2014/main" id="{9A2F0D68-C714-4ECA-A344-75BCA1E540A5}"/>
+                <a16:creationId xmlns:a16="http://schemas.microsoft.com/office/drawing/2014/main" id="{7A165182-2B1E-4958-BEB8-46E183D6B6E5}"/>
               </a:ext>
             </a:extLst>
           </p:cNvPr>
@@ -8400,7 +8400,7 @@
           <p:cNvPr id="6" name="">
             <a:extLst xmlns:a="http://schemas.openxmlformats.org/drawingml/2006/main">
               <a:ext uri="{FF2B5EF4-FFF2-40B4-BE49-F238E27FC236}">
-                <a16:creationId xmlns:a16="http://schemas.microsoft.com/office/drawing/2014/main" id="{FDDED273-368D-4F43-9534-856CA7EF9198}"/>
+                <a16:creationId xmlns:a16="http://schemas.microsoft.com/office/drawing/2014/main" id="{670F4D96-3DD2-4B66-80C4-D159F9211A21}"/>
               </a:ext>
             </a:extLst>
           </p:cNvPr>
@@ -8462,13 +8462,13 @@
           <p:nvPr/>
         </p:nvPicPr>
         <p:blipFill>
-          <a:blip xmlns:r="http://schemas.openxmlformats.org/officeDocument/2006/relationships" xmlns:a="http://schemas.openxmlformats.org/drawingml/2006/main" r:embed="R14a495a5147c41e9"/>
+          <a:blip xmlns:r="http://schemas.openxmlformats.org/officeDocument/2006/relationships" xmlns:a="http://schemas.openxmlformats.org/drawingml/2006/main" r:embed="Rf48a4fde32d54d98"/>
           <a:stretch xmlns:a="http://schemas.openxmlformats.org/drawingml/2006/main"/>
         </p:blipFill>
         <p:spPr>
           <a:xfrm xmlns:a="http://schemas.openxmlformats.org/drawingml/2006/main">
-            <a:off x="476250" y="1257300"/>
-            <a:ext cx="2667000" cy="4533900"/>
+            <a:off x="0" y="1746250"/>
+            <a:ext cx="2667000" cy="3556000"/>
           </a:xfrm>
           <a:prstGeom xmlns:a="http://schemas.openxmlformats.org/drawingml/2006/main" prst="rect">
             <a:avLst/>
@@ -8480,7 +8480,7 @@
           <p:cNvPr id="8" name="">
             <a:extLst xmlns:a="http://schemas.openxmlformats.org/drawingml/2006/main">
               <a:ext uri="{FF2B5EF4-FFF2-40B4-BE49-F238E27FC236}">
-                <a16:creationId xmlns:a16="http://schemas.microsoft.com/office/drawing/2014/main" id="{DA9A21AF-A025-4020-8AAF-4A62E6C0AB3C}"/>
+                <a16:creationId xmlns:a16="http://schemas.microsoft.com/office/drawing/2014/main" id="{31F08606-912E-44F1-AD5F-FC80202B9E13}"/>
               </a:ext>
             </a:extLst>
           </p:cNvPr>
@@ -8538,7 +8538,7 @@
           <p:cNvPr id="9" name="">
             <a:extLst xmlns:a="http://schemas.openxmlformats.org/drawingml/2006/main">
               <a:ext uri="{FF2B5EF4-FFF2-40B4-BE49-F238E27FC236}">
-                <a16:creationId xmlns:a16="http://schemas.microsoft.com/office/drawing/2014/main" id="{B9BDD1EA-3A35-48F4-AE9C-E6FCC01E9FF2}"/>
+                <a16:creationId xmlns:a16="http://schemas.microsoft.com/office/drawing/2014/main" id="{B21DC7F0-8FEC-4088-8E92-61AEB45593AE}"/>
               </a:ext>
             </a:extLst>
           </p:cNvPr>
@@ -8596,7 +8596,7 @@
           <p:cNvPr id="10" name="">
             <a:extLst xmlns:a="http://schemas.openxmlformats.org/drawingml/2006/main">
               <a:ext uri="{FF2B5EF4-FFF2-40B4-BE49-F238E27FC236}">
-                <a16:creationId xmlns:a16="http://schemas.microsoft.com/office/drawing/2014/main" id="{71F0582A-A867-46F9-93A3-F49879DD00FE}"/>
+                <a16:creationId xmlns:a16="http://schemas.microsoft.com/office/drawing/2014/main" id="{E3DD786C-25BB-4CFC-84D5-BCAE59A56C34}"/>
               </a:ext>
             </a:extLst>
           </p:cNvPr>
@@ -8652,7 +8652,7 @@
     </p:spTree>
     <p:extLst>
       <p:ext uri="{BB962C8B-B14F-4D97-AF65-F5344CB8AC3E}">
-        <p14:creationId xmlns:p14="http://schemas.microsoft.com/office/powerpoint/2010/main" val="791664163"/>
+        <p14:creationId xmlns:p14="http://schemas.microsoft.com/office/powerpoint/2010/main" val="701349624"/>
       </p:ext>
     </p:extLst>
   </p:cSld>
@@ -8683,7 +8683,7 @@
           <p:cNvPr id="1" name="">
             <a:extLst xmlns:a="http://schemas.openxmlformats.org/drawingml/2006/main">
               <a:ext uri="{FF2B5EF4-FFF2-40B4-BE49-F238E27FC236}">
-                <a16:creationId xmlns:a16="http://schemas.microsoft.com/office/drawing/2014/main" id="{6DA1FB76-3B1A-477D-A6FE-9B0B14C2FD6A}"/>
+                <a16:creationId xmlns:a16="http://schemas.microsoft.com/office/drawing/2014/main" id="{0F5FBE37-6DEA-4A54-9576-5D32639781CD}"/>
               </a:ext>
             </a:extLst>
           </p:cNvPr>
@@ -8722,7 +8722,7 @@
           <p:nvPr/>
         </p:nvPicPr>
         <p:blipFill>
-          <a:blip xmlns:r="http://schemas.openxmlformats.org/officeDocument/2006/relationships" xmlns:a="http://schemas.openxmlformats.org/drawingml/2006/main" r:embed="Rd7bfc18750854ce8"/>
+          <a:blip xmlns:r="http://schemas.openxmlformats.org/officeDocument/2006/relationships" xmlns:a="http://schemas.openxmlformats.org/drawingml/2006/main" r:embed="Ra3b9887a070148ca"/>
           <a:stretch xmlns:a="http://schemas.openxmlformats.org/drawingml/2006/main"/>
         </p:blipFill>
         <p:spPr>
@@ -8740,7 +8740,7 @@
           <p:cNvPr id="3" name="">
             <a:extLst xmlns:a="http://schemas.openxmlformats.org/drawingml/2006/main">
               <a:ext uri="{FF2B5EF4-FFF2-40B4-BE49-F238E27FC236}">
-                <a16:creationId xmlns:a16="http://schemas.microsoft.com/office/drawing/2014/main" id="{2AF8BCCD-7917-4B22-80C4-A12C6E35182B}"/>
+                <a16:creationId xmlns:a16="http://schemas.microsoft.com/office/drawing/2014/main" id="{AE0432A6-DC98-4D5C-AF69-ABFE60E76EEA}"/>
               </a:ext>
             </a:extLst>
           </p:cNvPr>
@@ -8778,14 +8778,14 @@
             <a:pPr algn="r">
               <a:defRPr sz="825" b="1">
                 <a:solidFill>
-                  <a:srgbClr val="0E1B3E"/>
+                  <a:srgbClr val="070F26"/>
                 </a:solidFill>
               </a:defRPr>
             </a:pPr>
             <a:r>
               <a:rPr sz="825" b="1">
                 <a:solidFill>
-                  <a:srgbClr val="0E1B3E"/>
+                  <a:srgbClr val="070F26"/>
                 </a:solidFill>
               </a:rPr>
               <a:t>NTT DATA UNIVERSITY</a:t>
@@ -8798,7 +8798,7 @@
           <p:cNvPr id="4" name="">
             <a:extLst xmlns:a="http://schemas.openxmlformats.org/drawingml/2006/main">
               <a:ext uri="{FF2B5EF4-FFF2-40B4-BE49-F238E27FC236}">
-                <a16:creationId xmlns:a16="http://schemas.microsoft.com/office/drawing/2014/main" id="{83324C47-D72D-4139-8F04-2D4DE3214501}"/>
+                <a16:creationId xmlns:a16="http://schemas.microsoft.com/office/drawing/2014/main" id="{0EAE7E94-9810-4343-B2B8-B30FC0FD4E60}"/>
               </a:ext>
             </a:extLst>
           </p:cNvPr>
@@ -8856,7 +8856,7 @@
           <p:cNvPr id="5" name="">
             <a:extLst xmlns:a="http://schemas.openxmlformats.org/drawingml/2006/main">
               <a:ext uri="{FF2B5EF4-FFF2-40B4-BE49-F238E27FC236}">
-                <a16:creationId xmlns:a16="http://schemas.microsoft.com/office/drawing/2014/main" id="{BDA05C7C-68F1-4920-AC7D-CCD79F1E3562}"/>
+                <a16:creationId xmlns:a16="http://schemas.microsoft.com/office/drawing/2014/main" id="{D7EC4298-C537-4DA1-91D6-DD8275E93BE0}"/>
               </a:ext>
             </a:extLst>
           </p:cNvPr>
@@ -8914,7 +8914,7 @@
           <p:cNvPr id="6" name="">
             <a:extLst xmlns:a="http://schemas.openxmlformats.org/drawingml/2006/main">
               <a:ext uri="{FF2B5EF4-FFF2-40B4-BE49-F238E27FC236}">
-                <a16:creationId xmlns:a16="http://schemas.microsoft.com/office/drawing/2014/main" id="{65C5DF83-4363-492D-B099-E54A86A25E19}"/>
+                <a16:creationId xmlns:a16="http://schemas.microsoft.com/office/drawing/2014/main" id="{286A9A1D-D20E-45ED-9C79-58DD7E16E62E}"/>
               </a:ext>
             </a:extLst>
           </p:cNvPr>
@@ -8952,14 +8952,14 @@
             <a:pPr algn="r">
               <a:defRPr sz="675" b="1">
                 <a:solidFill>
-                  <a:srgbClr val="0E1B3E"/>
+                  <a:srgbClr val="070F26"/>
                 </a:solidFill>
               </a:defRPr>
             </a:pPr>
             <a:r>
               <a:rPr sz="675" b="1">
                 <a:solidFill>
-                  <a:srgbClr val="0E1B3E"/>
+                  <a:srgbClr val="070F26"/>
                 </a:solidFill>
               </a:rPr>
               <a:t>NTT DATA UNIVERSITY</a:t>
@@ -8972,7 +8972,7 @@
           <p:cNvPr id="7" name="">
             <a:extLst xmlns:a="http://schemas.openxmlformats.org/drawingml/2006/main">
               <a:ext uri="{FF2B5EF4-FFF2-40B4-BE49-F238E27FC236}">
-                <a16:creationId xmlns:a16="http://schemas.microsoft.com/office/drawing/2014/main" id="{16906CF3-B485-4EA4-9B08-8884216DBF4D}"/>
+                <a16:creationId xmlns:a16="http://schemas.microsoft.com/office/drawing/2014/main" id="{75FFA3EB-CE7C-4365-B89B-776D14275B33}"/>
               </a:ext>
             </a:extLst>
           </p:cNvPr>
@@ -9030,7 +9030,7 @@
           <p:cNvPr id="8" name="">
             <a:extLst xmlns:a="http://schemas.openxmlformats.org/drawingml/2006/main">
               <a:ext uri="{FF2B5EF4-FFF2-40B4-BE49-F238E27FC236}">
-                <a16:creationId xmlns:a16="http://schemas.microsoft.com/office/drawing/2014/main" id="{E4BF0A0D-24F8-4460-BD32-6B211BDCA095}"/>
+                <a16:creationId xmlns:a16="http://schemas.microsoft.com/office/drawing/2014/main" id="{50529D48-43F1-438B-A4CC-67BDADC4C9BC}"/>
               </a:ext>
             </a:extLst>
           </p:cNvPr>
@@ -9068,14 +9068,14 @@
             <a:pPr algn="l">
               <a:defRPr sz="2400" b="0">
                 <a:solidFill>
-                  <a:srgbClr val="0E1B3E"/>
+                  <a:srgbClr val="070F26"/>
                 </a:solidFill>
               </a:defRPr>
             </a:pPr>
             <a:r>
               <a:rPr sz="2400" b="0">
                 <a:solidFill>
-                  <a:srgbClr val="0E1B3E"/>
+                  <a:srgbClr val="070F26"/>
                 </a:solidFill>
               </a:rPr>
               <a:t>O que cobrimos hoje</a:t>
@@ -9088,7 +9088,7 @@
           <p:cNvPr id="9" name="">
             <a:extLst xmlns:a="http://schemas.openxmlformats.org/drawingml/2006/main">
               <a:ext uri="{FF2B5EF4-FFF2-40B4-BE49-F238E27FC236}">
-                <a16:creationId xmlns:a16="http://schemas.microsoft.com/office/drawing/2014/main" id="{E395CE37-414E-41B8-92FB-185CCC0FEBA4}"/>
+                <a16:creationId xmlns:a16="http://schemas.microsoft.com/office/drawing/2014/main" id="{F2A446EC-3932-4D66-AE2E-186D3EFE0524}"/>
               </a:ext>
             </a:extLst>
           </p:cNvPr>
@@ -9146,7 +9146,7 @@
           <p:cNvPr id="10" name="">
             <a:extLst xmlns:a="http://schemas.openxmlformats.org/drawingml/2006/main">
               <a:ext uri="{FF2B5EF4-FFF2-40B4-BE49-F238E27FC236}">
-                <a16:creationId xmlns:a16="http://schemas.microsoft.com/office/drawing/2014/main" id="{9C295E01-0F8C-4F7A-B2A8-824A25C6150C}"/>
+                <a16:creationId xmlns:a16="http://schemas.microsoft.com/office/drawing/2014/main" id="{BB37C3F3-9E16-4176-8F7F-C0B0E05D691B}"/>
               </a:ext>
             </a:extLst>
           </p:cNvPr>
@@ -9179,7 +9179,7 @@
           <p:cNvPr id="11" name="">
             <a:extLst xmlns:a="http://schemas.openxmlformats.org/drawingml/2006/main">
               <a:ext uri="{FF2B5EF4-FFF2-40B4-BE49-F238E27FC236}">
-                <a16:creationId xmlns:a16="http://schemas.microsoft.com/office/drawing/2014/main" id="{F16D9E54-B86D-48DF-B5B6-E472B641493A}"/>
+                <a16:creationId xmlns:a16="http://schemas.microsoft.com/office/drawing/2014/main" id="{1E3C69B4-DADD-4F78-8EA0-A0315F4181E2}"/>
               </a:ext>
             </a:extLst>
           </p:cNvPr>
@@ -9214,7 +9214,7 @@
           <p:cNvPr id="12" name="">
             <a:extLst xmlns:a="http://schemas.openxmlformats.org/drawingml/2006/main">
               <a:ext uri="{FF2B5EF4-FFF2-40B4-BE49-F238E27FC236}">
-                <a16:creationId xmlns:a16="http://schemas.microsoft.com/office/drawing/2014/main" id="{D2B2702E-ED75-46C6-838B-AC8204892C5C}"/>
+                <a16:creationId xmlns:a16="http://schemas.microsoft.com/office/drawing/2014/main" id="{08EB86C0-2821-4564-865D-E3AE0E260D4B}"/>
               </a:ext>
             </a:extLst>
           </p:cNvPr>
@@ -9272,7 +9272,7 @@
           <p:cNvPr id="13" name="">
             <a:extLst xmlns:a="http://schemas.openxmlformats.org/drawingml/2006/main">
               <a:ext uri="{FF2B5EF4-FFF2-40B4-BE49-F238E27FC236}">
-                <a16:creationId xmlns:a16="http://schemas.microsoft.com/office/drawing/2014/main" id="{F8F86F5B-E18A-485F-AF24-2DB153BEE8E9}"/>
+                <a16:creationId xmlns:a16="http://schemas.microsoft.com/office/drawing/2014/main" id="{92AD5D93-00EA-438C-AAFB-90A0C4549773}"/>
               </a:ext>
             </a:extLst>
           </p:cNvPr>
@@ -9330,7 +9330,7 @@
           <p:cNvPr id="14" name="">
             <a:extLst xmlns:a="http://schemas.openxmlformats.org/drawingml/2006/main">
               <a:ext uri="{FF2B5EF4-FFF2-40B4-BE49-F238E27FC236}">
-                <a16:creationId xmlns:a16="http://schemas.microsoft.com/office/drawing/2014/main" id="{DB10248F-0A4A-4A2D-8E02-A2F35B609A26}"/>
+                <a16:creationId xmlns:a16="http://schemas.microsoft.com/office/drawing/2014/main" id="{A4407045-FA42-49A5-AA83-67A735E99B57}"/>
               </a:ext>
             </a:extLst>
           </p:cNvPr>
@@ -9363,7 +9363,7 @@
           <p:cNvPr id="15" name="">
             <a:extLst xmlns:a="http://schemas.openxmlformats.org/drawingml/2006/main">
               <a:ext uri="{FF2B5EF4-FFF2-40B4-BE49-F238E27FC236}">
-                <a16:creationId xmlns:a16="http://schemas.microsoft.com/office/drawing/2014/main" id="{E0444952-9C06-4221-BC7D-5595FB6B635C}"/>
+                <a16:creationId xmlns:a16="http://schemas.microsoft.com/office/drawing/2014/main" id="{0BC800DD-2007-4783-B4DF-43F8F5F2AD32}"/>
               </a:ext>
             </a:extLst>
           </p:cNvPr>
@@ -9398,7 +9398,7 @@
           <p:cNvPr id="16" name="">
             <a:extLst xmlns:a="http://schemas.openxmlformats.org/drawingml/2006/main">
               <a:ext uri="{FF2B5EF4-FFF2-40B4-BE49-F238E27FC236}">
-                <a16:creationId xmlns:a16="http://schemas.microsoft.com/office/drawing/2014/main" id="{186BBBD8-AF06-47D5-B68B-162ED48A2BC5}"/>
+                <a16:creationId xmlns:a16="http://schemas.microsoft.com/office/drawing/2014/main" id="{A1A47F71-FF7C-440F-A82C-6A1D886A68AE}"/>
               </a:ext>
             </a:extLst>
           </p:cNvPr>
@@ -9456,7 +9456,7 @@
           <p:cNvPr id="17" name="">
             <a:extLst xmlns:a="http://schemas.openxmlformats.org/drawingml/2006/main">
               <a:ext uri="{FF2B5EF4-FFF2-40B4-BE49-F238E27FC236}">
-                <a16:creationId xmlns:a16="http://schemas.microsoft.com/office/drawing/2014/main" id="{53C7895F-5B82-426C-8BD9-94D62FDD93E3}"/>
+                <a16:creationId xmlns:a16="http://schemas.microsoft.com/office/drawing/2014/main" id="{50829302-3193-4D65-A96E-C5EFCF43E54C}"/>
               </a:ext>
             </a:extLst>
           </p:cNvPr>
@@ -9514,7 +9514,7 @@
           <p:cNvPr id="18" name="">
             <a:extLst xmlns:a="http://schemas.openxmlformats.org/drawingml/2006/main">
               <a:ext uri="{FF2B5EF4-FFF2-40B4-BE49-F238E27FC236}">
-                <a16:creationId xmlns:a16="http://schemas.microsoft.com/office/drawing/2014/main" id="{3B810B46-6FBA-448C-B2BB-821F1E21C2E5}"/>
+                <a16:creationId xmlns:a16="http://schemas.microsoft.com/office/drawing/2014/main" id="{905626C8-20B5-45CA-8ADB-B86A30BF4629}"/>
               </a:ext>
             </a:extLst>
           </p:cNvPr>
@@ -9547,7 +9547,7 @@
           <p:cNvPr id="19" name="">
             <a:extLst xmlns:a="http://schemas.openxmlformats.org/drawingml/2006/main">
               <a:ext uri="{FF2B5EF4-FFF2-40B4-BE49-F238E27FC236}">
-                <a16:creationId xmlns:a16="http://schemas.microsoft.com/office/drawing/2014/main" id="{14604162-02E1-4A03-AEC8-7B2C7BD70956}"/>
+                <a16:creationId xmlns:a16="http://schemas.microsoft.com/office/drawing/2014/main" id="{10DC7A3B-2667-458F-960A-74FA09928ED3}"/>
               </a:ext>
             </a:extLst>
           </p:cNvPr>
@@ -9582,7 +9582,7 @@
           <p:cNvPr id="20" name="">
             <a:extLst xmlns:a="http://schemas.openxmlformats.org/drawingml/2006/main">
               <a:ext uri="{FF2B5EF4-FFF2-40B4-BE49-F238E27FC236}">
-                <a16:creationId xmlns:a16="http://schemas.microsoft.com/office/drawing/2014/main" id="{22449B0B-CC97-40F4-92E8-774DF9255491}"/>
+                <a16:creationId xmlns:a16="http://schemas.microsoft.com/office/drawing/2014/main" id="{2468DE79-E690-4B35-9491-DA636C5DA5FC}"/>
               </a:ext>
             </a:extLst>
           </p:cNvPr>
@@ -9640,7 +9640,7 @@
           <p:cNvPr id="21" name="">
             <a:extLst xmlns:a="http://schemas.openxmlformats.org/drawingml/2006/main">
               <a:ext uri="{FF2B5EF4-FFF2-40B4-BE49-F238E27FC236}">
-                <a16:creationId xmlns:a16="http://schemas.microsoft.com/office/drawing/2014/main" id="{259F2845-798E-4E12-9CF3-59F2B9B3061B}"/>
+                <a16:creationId xmlns:a16="http://schemas.microsoft.com/office/drawing/2014/main" id="{10E7EBC1-0C02-4E0A-96F7-4E81586B32D1}"/>
               </a:ext>
             </a:extLst>
           </p:cNvPr>
@@ -9698,7 +9698,7 @@
           <p:cNvPr id="22" name="">
             <a:extLst xmlns:a="http://schemas.openxmlformats.org/drawingml/2006/main">
               <a:ext uri="{FF2B5EF4-FFF2-40B4-BE49-F238E27FC236}">
-                <a16:creationId xmlns:a16="http://schemas.microsoft.com/office/drawing/2014/main" id="{43758857-9CC7-4A64-A47A-FF455C1F24C5}"/>
+                <a16:creationId xmlns:a16="http://schemas.microsoft.com/office/drawing/2014/main" id="{03D081DF-CE67-4454-A491-72DDAF687C2C}"/>
               </a:ext>
             </a:extLst>
           </p:cNvPr>
@@ -9731,7 +9731,7 @@
           <p:cNvPr id="23" name="">
             <a:extLst xmlns:a="http://schemas.openxmlformats.org/drawingml/2006/main">
               <a:ext uri="{FF2B5EF4-FFF2-40B4-BE49-F238E27FC236}">
-                <a16:creationId xmlns:a16="http://schemas.microsoft.com/office/drawing/2014/main" id="{02EAE4A6-5EA8-4CFD-97B5-654B5B9AB412}"/>
+                <a16:creationId xmlns:a16="http://schemas.microsoft.com/office/drawing/2014/main" id="{2FAE3D98-5EAA-4D96-BC0E-6479C50F0222}"/>
               </a:ext>
             </a:extLst>
           </p:cNvPr>
@@ -9766,7 +9766,7 @@
           <p:cNvPr id="24" name="">
             <a:extLst xmlns:a="http://schemas.openxmlformats.org/drawingml/2006/main">
               <a:ext uri="{FF2B5EF4-FFF2-40B4-BE49-F238E27FC236}">
-                <a16:creationId xmlns:a16="http://schemas.microsoft.com/office/drawing/2014/main" id="{D9C95C3C-E62A-4D1E-A608-61028A3127CA}"/>
+                <a16:creationId xmlns:a16="http://schemas.microsoft.com/office/drawing/2014/main" id="{909F2D61-26D3-4878-9D44-CA83BDB6C0EA}"/>
               </a:ext>
             </a:extLst>
           </p:cNvPr>
@@ -9824,7 +9824,7 @@
           <p:cNvPr id="25" name="">
             <a:extLst xmlns:a="http://schemas.openxmlformats.org/drawingml/2006/main">
               <a:ext uri="{FF2B5EF4-FFF2-40B4-BE49-F238E27FC236}">
-                <a16:creationId xmlns:a16="http://schemas.microsoft.com/office/drawing/2014/main" id="{7DABBBDF-3172-4888-9D74-5A7BBFDA28EE}"/>
+                <a16:creationId xmlns:a16="http://schemas.microsoft.com/office/drawing/2014/main" id="{9894C46F-61FF-4926-9B60-4EF30AD3F2B0}"/>
               </a:ext>
             </a:extLst>
           </p:cNvPr>
@@ -9880,7 +9880,7 @@
     </p:spTree>
     <p:extLst>
       <p:ext uri="{BB962C8B-B14F-4D97-AF65-F5344CB8AC3E}">
-        <p14:creationId xmlns:p14="http://schemas.microsoft.com/office/powerpoint/2010/main" val="1707065730"/>
+        <p14:creationId xmlns:p14="http://schemas.microsoft.com/office/powerpoint/2010/main" val="470255223"/>
       </p:ext>
     </p:extLst>
   </p:cSld>
@@ -9911,7 +9911,7 @@
           <p:cNvPr id="1" name="">
             <a:extLst xmlns:a="http://schemas.openxmlformats.org/drawingml/2006/main">
               <a:ext uri="{FF2B5EF4-FFF2-40B4-BE49-F238E27FC236}">
-                <a16:creationId xmlns:a16="http://schemas.microsoft.com/office/drawing/2014/main" id="{C6A54D43-A130-4CD1-9489-85928C969E69}"/>
+                <a16:creationId xmlns:a16="http://schemas.microsoft.com/office/drawing/2014/main" id="{A683962B-AE2F-449E-8616-413A96F1ACB4}"/>
               </a:ext>
             </a:extLst>
           </p:cNvPr>
@@ -9950,7 +9950,7 @@
           <p:nvPr/>
         </p:nvPicPr>
         <p:blipFill>
-          <a:blip xmlns:r="http://schemas.openxmlformats.org/officeDocument/2006/relationships" xmlns:a="http://schemas.openxmlformats.org/drawingml/2006/main" r:embed="Rdb33be1bb8804c41"/>
+          <a:blip xmlns:r="http://schemas.openxmlformats.org/officeDocument/2006/relationships" xmlns:a="http://schemas.openxmlformats.org/drawingml/2006/main" r:embed="R3bbb17375a81463c"/>
           <a:stretch xmlns:a="http://schemas.openxmlformats.org/drawingml/2006/main"/>
         </p:blipFill>
         <p:spPr>
@@ -9968,7 +9968,7 @@
           <p:cNvPr id="3" name="">
             <a:extLst xmlns:a="http://schemas.openxmlformats.org/drawingml/2006/main">
               <a:ext uri="{FF2B5EF4-FFF2-40B4-BE49-F238E27FC236}">
-                <a16:creationId xmlns:a16="http://schemas.microsoft.com/office/drawing/2014/main" id="{7EC3BEEA-094B-4618-8B6F-669248684C24}"/>
+                <a16:creationId xmlns:a16="http://schemas.microsoft.com/office/drawing/2014/main" id="{03528A1B-EC23-4DB1-A66F-7BDC9B05541B}"/>
               </a:ext>
             </a:extLst>
           </p:cNvPr>
@@ -10006,14 +10006,14 @@
             <a:pPr algn="r">
               <a:defRPr sz="825" b="1">
                 <a:solidFill>
-                  <a:srgbClr val="0E1B3E"/>
+                  <a:srgbClr val="070F26"/>
                 </a:solidFill>
               </a:defRPr>
             </a:pPr>
             <a:r>
               <a:rPr sz="825" b="1">
                 <a:solidFill>
-                  <a:srgbClr val="0E1B3E"/>
+                  <a:srgbClr val="070F26"/>
                 </a:solidFill>
               </a:rPr>
               <a:t>NTT DATA UNIVERSITY</a:t>
@@ -10026,7 +10026,7 @@
           <p:cNvPr id="4" name="">
             <a:extLst xmlns:a="http://schemas.openxmlformats.org/drawingml/2006/main">
               <a:ext uri="{FF2B5EF4-FFF2-40B4-BE49-F238E27FC236}">
-                <a16:creationId xmlns:a16="http://schemas.microsoft.com/office/drawing/2014/main" id="{FFEFFB19-AB13-4D32-B72E-DA847DED4217}"/>
+                <a16:creationId xmlns:a16="http://schemas.microsoft.com/office/drawing/2014/main" id="{E5666238-9901-4CD6-87FE-ED93CD06A003}"/>
               </a:ext>
             </a:extLst>
           </p:cNvPr>
@@ -10084,7 +10084,7 @@
           <p:cNvPr id="5" name="">
             <a:extLst xmlns:a="http://schemas.openxmlformats.org/drawingml/2006/main">
               <a:ext uri="{FF2B5EF4-FFF2-40B4-BE49-F238E27FC236}">
-                <a16:creationId xmlns:a16="http://schemas.microsoft.com/office/drawing/2014/main" id="{64811CDC-5A0C-4023-8BF0-7D973A53296C}"/>
+                <a16:creationId xmlns:a16="http://schemas.microsoft.com/office/drawing/2014/main" id="{C339F4FA-A203-4664-8B0C-42E7DD06E953}"/>
               </a:ext>
             </a:extLst>
           </p:cNvPr>
@@ -10142,7 +10142,7 @@
           <p:cNvPr id="6" name="">
             <a:extLst xmlns:a="http://schemas.openxmlformats.org/drawingml/2006/main">
               <a:ext uri="{FF2B5EF4-FFF2-40B4-BE49-F238E27FC236}">
-                <a16:creationId xmlns:a16="http://schemas.microsoft.com/office/drawing/2014/main" id="{A1573B39-3D73-4B3D-8662-F92BAA8D67EA}"/>
+                <a16:creationId xmlns:a16="http://schemas.microsoft.com/office/drawing/2014/main" id="{3C31B42D-AD88-4EB7-8D8D-84B0E84BD92F}"/>
               </a:ext>
             </a:extLst>
           </p:cNvPr>
@@ -10180,14 +10180,14 @@
             <a:pPr algn="r">
               <a:defRPr sz="675" b="1">
                 <a:solidFill>
-                  <a:srgbClr val="0E1B3E"/>
+                  <a:srgbClr val="070F26"/>
                 </a:solidFill>
               </a:defRPr>
             </a:pPr>
             <a:r>
               <a:rPr sz="675" b="1">
                 <a:solidFill>
-                  <a:srgbClr val="0E1B3E"/>
+                  <a:srgbClr val="070F26"/>
                 </a:solidFill>
               </a:rPr>
               <a:t>NTT DATA UNIVERSITY</a:t>
@@ -10200,7 +10200,7 @@
           <p:cNvPr id="7" name="">
             <a:extLst xmlns:a="http://schemas.openxmlformats.org/drawingml/2006/main">
               <a:ext uri="{FF2B5EF4-FFF2-40B4-BE49-F238E27FC236}">
-                <a16:creationId xmlns:a16="http://schemas.microsoft.com/office/drawing/2014/main" id="{94752790-D973-401D-96DF-44EE724D4ED3}"/>
+                <a16:creationId xmlns:a16="http://schemas.microsoft.com/office/drawing/2014/main" id="{1E79C452-DE3D-424E-8AA0-12ABD880255B}"/>
               </a:ext>
             </a:extLst>
           </p:cNvPr>
@@ -10258,7 +10258,7 @@
           <p:cNvPr id="8" name="">
             <a:extLst xmlns:a="http://schemas.openxmlformats.org/drawingml/2006/main">
               <a:ext uri="{FF2B5EF4-FFF2-40B4-BE49-F238E27FC236}">
-                <a16:creationId xmlns:a16="http://schemas.microsoft.com/office/drawing/2014/main" id="{C2ADD560-4B54-4309-A7EE-FA31874CE0C0}"/>
+                <a16:creationId xmlns:a16="http://schemas.microsoft.com/office/drawing/2014/main" id="{DE99F808-91AF-48C0-AB73-CABE6BBE9D91}"/>
               </a:ext>
             </a:extLst>
           </p:cNvPr>
@@ -10296,14 +10296,14 @@
             <a:pPr algn="l">
               <a:defRPr sz="2400" b="0">
                 <a:solidFill>
-                  <a:srgbClr val="0E1B3E"/>
+                  <a:srgbClr val="070F26"/>
                 </a:solidFill>
               </a:defRPr>
             </a:pPr>
             <a:r>
               <a:rPr sz="2400" b="0">
                 <a:solidFill>
-                  <a:srgbClr val="0E1B3E"/>
+                  <a:srgbClr val="070F26"/>
                 </a:solidFill>
               </a:rPr>
               <a:t>Módulo 2 — Modelagem de Dados</a:t>
@@ -10316,7 +10316,7 @@
           <p:cNvPr id="9" name="">
             <a:extLst xmlns:a="http://schemas.openxmlformats.org/drawingml/2006/main">
               <a:ext uri="{FF2B5EF4-FFF2-40B4-BE49-F238E27FC236}">
-                <a16:creationId xmlns:a16="http://schemas.microsoft.com/office/drawing/2014/main" id="{BCFD6490-1A71-45A0-8721-13443D358E6C}"/>
+                <a16:creationId xmlns:a16="http://schemas.microsoft.com/office/drawing/2014/main" id="{D983E35A-1AD6-48DB-977E-564DD5534FE1}"/>
               </a:ext>
             </a:extLst>
           </p:cNvPr>
@@ -10374,7 +10374,7 @@
           <p:cNvPr id="10" name="">
             <a:extLst xmlns:a="http://schemas.openxmlformats.org/drawingml/2006/main">
               <a:ext uri="{FF2B5EF4-FFF2-40B4-BE49-F238E27FC236}">
-                <a16:creationId xmlns:a16="http://schemas.microsoft.com/office/drawing/2014/main" id="{EB41EEB6-0480-413F-ABD4-DA565DFD5684}"/>
+                <a16:creationId xmlns:a16="http://schemas.microsoft.com/office/drawing/2014/main" id="{7D4459B8-0012-4186-8224-8919CB437BA5}"/>
               </a:ext>
             </a:extLst>
           </p:cNvPr>
@@ -10407,7 +10407,7 @@
           <p:cNvPr id="11" name="">
             <a:extLst xmlns:a="http://schemas.openxmlformats.org/drawingml/2006/main">
               <a:ext uri="{FF2B5EF4-FFF2-40B4-BE49-F238E27FC236}">
-                <a16:creationId xmlns:a16="http://schemas.microsoft.com/office/drawing/2014/main" id="{A7D777C7-9D43-435B-BE1C-A5C7B8A8B4F6}"/>
+                <a16:creationId xmlns:a16="http://schemas.microsoft.com/office/drawing/2014/main" id="{19C8D749-C0B1-447F-B8F3-60D05ABDCAD3}"/>
               </a:ext>
             </a:extLst>
           </p:cNvPr>
@@ -10442,7 +10442,7 @@
           <p:cNvPr id="12" name="">
             <a:extLst xmlns:a="http://schemas.openxmlformats.org/drawingml/2006/main">
               <a:ext uri="{FF2B5EF4-FFF2-40B4-BE49-F238E27FC236}">
-                <a16:creationId xmlns:a16="http://schemas.microsoft.com/office/drawing/2014/main" id="{D799A994-D97D-42DC-8CA7-9BC4E4D1F5AE}"/>
+                <a16:creationId xmlns:a16="http://schemas.microsoft.com/office/drawing/2014/main" id="{4FC3219C-89BD-4C00-A881-BB556700A99D}"/>
               </a:ext>
             </a:extLst>
           </p:cNvPr>
@@ -10500,7 +10500,7 @@
           <p:cNvPr id="13" name="">
             <a:extLst xmlns:a="http://schemas.openxmlformats.org/drawingml/2006/main">
               <a:ext uri="{FF2B5EF4-FFF2-40B4-BE49-F238E27FC236}">
-                <a16:creationId xmlns:a16="http://schemas.microsoft.com/office/drawing/2014/main" id="{1591F9B3-DF7E-45A6-8AAB-8CC2E31F0FFE}"/>
+                <a16:creationId xmlns:a16="http://schemas.microsoft.com/office/drawing/2014/main" id="{FCB3110D-9021-4DD1-854F-DE847256F695}"/>
               </a:ext>
             </a:extLst>
           </p:cNvPr>
@@ -10592,7 +10592,7 @@
           <p:cNvPr id="14" name="">
             <a:extLst xmlns:a="http://schemas.openxmlformats.org/drawingml/2006/main">
               <a:ext uri="{FF2B5EF4-FFF2-40B4-BE49-F238E27FC236}">
-                <a16:creationId xmlns:a16="http://schemas.microsoft.com/office/drawing/2014/main" id="{F2264972-EB28-4AE0-89EB-2C31DF3D5A3F}"/>
+                <a16:creationId xmlns:a16="http://schemas.microsoft.com/office/drawing/2014/main" id="{002A1A84-CD14-4A13-A698-0CE75EDE55AE}"/>
               </a:ext>
             </a:extLst>
           </p:cNvPr>
@@ -10625,7 +10625,7 @@
           <p:cNvPr id="15" name="">
             <a:extLst xmlns:a="http://schemas.openxmlformats.org/drawingml/2006/main">
               <a:ext uri="{FF2B5EF4-FFF2-40B4-BE49-F238E27FC236}">
-                <a16:creationId xmlns:a16="http://schemas.microsoft.com/office/drawing/2014/main" id="{9B8ADC9B-2DCC-437D-8D5F-6CBD678A5F41}"/>
+                <a16:creationId xmlns:a16="http://schemas.microsoft.com/office/drawing/2014/main" id="{C3BBD5CE-FF1C-4B99-94D7-352ED4318B29}"/>
               </a:ext>
             </a:extLst>
           </p:cNvPr>
@@ -10660,7 +10660,7 @@
           <p:cNvPr id="16" name="">
             <a:extLst xmlns:a="http://schemas.openxmlformats.org/drawingml/2006/main">
               <a:ext uri="{FF2B5EF4-FFF2-40B4-BE49-F238E27FC236}">
-                <a16:creationId xmlns:a16="http://schemas.microsoft.com/office/drawing/2014/main" id="{FA0D291C-62B8-47DF-869C-8F8389B362A1}"/>
+                <a16:creationId xmlns:a16="http://schemas.microsoft.com/office/drawing/2014/main" id="{CF02B9C7-E486-41C6-895F-6959AA713FA8}"/>
               </a:ext>
             </a:extLst>
           </p:cNvPr>
@@ -10718,7 +10718,7 @@
           <p:cNvPr id="17" name="">
             <a:extLst xmlns:a="http://schemas.openxmlformats.org/drawingml/2006/main">
               <a:ext uri="{FF2B5EF4-FFF2-40B4-BE49-F238E27FC236}">
-                <a16:creationId xmlns:a16="http://schemas.microsoft.com/office/drawing/2014/main" id="{2B4ECC6D-B7DF-4678-A992-526C0843EC4F}"/>
+                <a16:creationId xmlns:a16="http://schemas.microsoft.com/office/drawing/2014/main" id="{51E48718-C785-43B9-8BE4-5D517EA0BE66}"/>
               </a:ext>
             </a:extLst>
           </p:cNvPr>
@@ -10793,7 +10793,7 @@
           <p:cNvPr id="18" name="">
             <a:extLst xmlns:a="http://schemas.openxmlformats.org/drawingml/2006/main">
               <a:ext uri="{FF2B5EF4-FFF2-40B4-BE49-F238E27FC236}">
-                <a16:creationId xmlns:a16="http://schemas.microsoft.com/office/drawing/2014/main" id="{0B8C5F87-2BBF-4BC5-9B0D-B83A7CA75FEC}"/>
+                <a16:creationId xmlns:a16="http://schemas.microsoft.com/office/drawing/2014/main" id="{1BF9259F-C06F-419D-838E-2FF6AE5EFA4E}"/>
               </a:ext>
             </a:extLst>
           </p:cNvPr>
@@ -10826,7 +10826,7 @@
           <p:cNvPr id="19" name="">
             <a:extLst xmlns:a="http://schemas.openxmlformats.org/drawingml/2006/main">
               <a:ext uri="{FF2B5EF4-FFF2-40B4-BE49-F238E27FC236}">
-                <a16:creationId xmlns:a16="http://schemas.microsoft.com/office/drawing/2014/main" id="{DE82CA15-0C5A-42BB-AC3F-8B33A98A8757}"/>
+                <a16:creationId xmlns:a16="http://schemas.microsoft.com/office/drawing/2014/main" id="{431015CE-38CE-42C4-BE7B-FBC4FCA10102}"/>
               </a:ext>
             </a:extLst>
           </p:cNvPr>
@@ -10861,7 +10861,7 @@
           <p:cNvPr id="20" name="">
             <a:extLst xmlns:a="http://schemas.openxmlformats.org/drawingml/2006/main">
               <a:ext uri="{FF2B5EF4-FFF2-40B4-BE49-F238E27FC236}">
-                <a16:creationId xmlns:a16="http://schemas.microsoft.com/office/drawing/2014/main" id="{D0AAB415-4AC9-4E14-A863-BBC1EB06922E}"/>
+                <a16:creationId xmlns:a16="http://schemas.microsoft.com/office/drawing/2014/main" id="{8FADE639-4289-4296-AB22-7E7C6AA55A7F}"/>
               </a:ext>
             </a:extLst>
           </p:cNvPr>
@@ -10919,7 +10919,7 @@
           <p:cNvPr id="21" name="">
             <a:extLst xmlns:a="http://schemas.openxmlformats.org/drawingml/2006/main">
               <a:ext uri="{FF2B5EF4-FFF2-40B4-BE49-F238E27FC236}">
-                <a16:creationId xmlns:a16="http://schemas.microsoft.com/office/drawing/2014/main" id="{D71A645E-FC93-4A5C-8AF5-00E42DD5EE49}"/>
+                <a16:creationId xmlns:a16="http://schemas.microsoft.com/office/drawing/2014/main" id="{3E1DC603-B0E0-4808-90A9-789B14B9B341}"/>
               </a:ext>
             </a:extLst>
           </p:cNvPr>
@@ -11009,7 +11009,7 @@
     </p:spTree>
     <p:extLst>
       <p:ext uri="{BB962C8B-B14F-4D97-AF65-F5344CB8AC3E}">
-        <p14:creationId xmlns:p14="http://schemas.microsoft.com/office/powerpoint/2010/main" val="871625602"/>
+        <p14:creationId xmlns:p14="http://schemas.microsoft.com/office/powerpoint/2010/main" val="37058362"/>
       </p:ext>
     </p:extLst>
   </p:cSld>
@@ -11022,7 +11022,7 @@
     <p:bg>
       <p:bgPr>
         <a:solidFill xmlns:a="http://schemas.openxmlformats.org/drawingml/2006/main">
-          <a:srgbClr val="0E1B3E"/>
+          <a:srgbClr val="070F26"/>
         </a:solidFill>
       </p:bgPr>
     </p:bg>
@@ -11040,7 +11040,7 @@
           <p:cNvPr id="1" name="">
             <a:extLst xmlns:a="http://schemas.openxmlformats.org/drawingml/2006/main">
               <a:ext uri="{FF2B5EF4-FFF2-40B4-BE49-F238E27FC236}">
-                <a16:creationId xmlns:a16="http://schemas.microsoft.com/office/drawing/2014/main" id="{3C714F41-EBBB-49C9-AAB0-7873F4DC05C6}"/>
+                <a16:creationId xmlns:a16="http://schemas.microsoft.com/office/drawing/2014/main" id="{25652BC5-5EE5-4874-BC42-FBFDE87F4BB7}"/>
               </a:ext>
             </a:extLst>
           </p:cNvPr>
@@ -11058,7 +11058,7 @@
             <a:avLst/>
           </a:prstGeom>
           <a:solidFill xmlns:a="http://schemas.openxmlformats.org/drawingml/2006/main">
-            <a:srgbClr val="0E1B3E"/>
+            <a:srgbClr val="070F26"/>
           </a:solidFill>
           <a:ln xmlns:a="http://schemas.openxmlformats.org/drawingml/2006/main" w="0">
             <a:solidFill>
@@ -11079,7 +11079,7 @@
           <p:nvPr/>
         </p:nvPicPr>
         <p:blipFill>
-          <a:blip xmlns:r="http://schemas.openxmlformats.org/officeDocument/2006/relationships" xmlns:a="http://schemas.openxmlformats.org/drawingml/2006/main" r:embed="R4857bf1020294887"/>
+          <a:blip xmlns:r="http://schemas.openxmlformats.org/officeDocument/2006/relationships" xmlns:a="http://schemas.openxmlformats.org/drawingml/2006/main" r:embed="Ra6cf82aee4434ef7"/>
           <a:stretch xmlns:a="http://schemas.openxmlformats.org/drawingml/2006/main"/>
         </p:blipFill>
         <p:spPr>
@@ -11097,7 +11097,7 @@
           <p:cNvPr id="3" name="">
             <a:extLst xmlns:a="http://schemas.openxmlformats.org/drawingml/2006/main">
               <a:ext uri="{FF2B5EF4-FFF2-40B4-BE49-F238E27FC236}">
-                <a16:creationId xmlns:a16="http://schemas.microsoft.com/office/drawing/2014/main" id="{D6B7267E-B5A9-48D0-84CA-AE6E633BDBF8}"/>
+                <a16:creationId xmlns:a16="http://schemas.microsoft.com/office/drawing/2014/main" id="{36376F60-C342-40C7-AA84-8ACD243F3CE1}"/>
               </a:ext>
             </a:extLst>
           </p:cNvPr>
@@ -11155,7 +11155,7 @@
           <p:cNvPr id="4" name="">
             <a:extLst xmlns:a="http://schemas.openxmlformats.org/drawingml/2006/main">
               <a:ext uri="{FF2B5EF4-FFF2-40B4-BE49-F238E27FC236}">
-                <a16:creationId xmlns:a16="http://schemas.microsoft.com/office/drawing/2014/main" id="{F65A1295-07B4-4EBF-AF6D-0A1787DDD4CD}"/>
+                <a16:creationId xmlns:a16="http://schemas.microsoft.com/office/drawing/2014/main" id="{5ADF46A1-86E7-4D44-A63E-F2A63DF1C941}"/>
               </a:ext>
             </a:extLst>
           </p:cNvPr>
@@ -11213,7 +11213,7 @@
           <p:cNvPr id="5" name="">
             <a:extLst xmlns:a="http://schemas.openxmlformats.org/drawingml/2006/main">
               <a:ext uri="{FF2B5EF4-FFF2-40B4-BE49-F238E27FC236}">
-                <a16:creationId xmlns:a16="http://schemas.microsoft.com/office/drawing/2014/main" id="{AD86B168-1730-455E-8D70-20CD5896B8A2}"/>
+                <a16:creationId xmlns:a16="http://schemas.microsoft.com/office/drawing/2014/main" id="{69F2DF21-648D-4386-899F-AF2935CCBBE0}"/>
               </a:ext>
             </a:extLst>
           </p:cNvPr>
@@ -11275,7 +11275,7 @@
           <p:nvPr/>
         </p:nvPicPr>
         <p:blipFill>
-          <a:blip xmlns:r="http://schemas.openxmlformats.org/officeDocument/2006/relationships" xmlns:a="http://schemas.openxmlformats.org/drawingml/2006/main" r:embed="R093a7d5baf1149cc"/>
+          <a:blip xmlns:r="http://schemas.openxmlformats.org/officeDocument/2006/relationships" xmlns:a="http://schemas.openxmlformats.org/drawingml/2006/main" r:embed="R8eef573028f148fc"/>
           <a:stretch xmlns:a="http://schemas.openxmlformats.org/drawingml/2006/main"/>
         </p:blipFill>
         <p:spPr>
@@ -11293,7 +11293,7 @@
           <p:cNvPr id="7" name="">
             <a:extLst xmlns:a="http://schemas.openxmlformats.org/drawingml/2006/main">
               <a:ext uri="{FF2B5EF4-FFF2-40B4-BE49-F238E27FC236}">
-                <a16:creationId xmlns:a16="http://schemas.microsoft.com/office/drawing/2014/main" id="{3F9F224A-EED2-4240-9358-5B446E6B4012}"/>
+                <a16:creationId xmlns:a16="http://schemas.microsoft.com/office/drawing/2014/main" id="{7336359C-4FD7-4C65-B70E-F29813138CCD}"/>
               </a:ext>
             </a:extLst>
           </p:cNvPr>
@@ -11351,7 +11351,7 @@
           <p:cNvPr id="8" name="">
             <a:extLst xmlns:a="http://schemas.openxmlformats.org/drawingml/2006/main">
               <a:ext uri="{FF2B5EF4-FFF2-40B4-BE49-F238E27FC236}">
-                <a16:creationId xmlns:a16="http://schemas.microsoft.com/office/drawing/2014/main" id="{F1AECCD7-515A-43C3-9013-F749C21CDD4A}"/>
+                <a16:creationId xmlns:a16="http://schemas.microsoft.com/office/drawing/2014/main" id="{C59F4F1C-0507-4B8E-BDBA-7C5A34588442}"/>
               </a:ext>
             </a:extLst>
           </p:cNvPr>
@@ -11407,7 +11407,7 @@
     </p:spTree>
     <p:extLst>
       <p:ext uri="{BB962C8B-B14F-4D97-AF65-F5344CB8AC3E}">
-        <p14:creationId xmlns:p14="http://schemas.microsoft.com/office/powerpoint/2010/main" val="327010698"/>
+        <p14:creationId xmlns:p14="http://schemas.microsoft.com/office/powerpoint/2010/main" val="654904434"/>
       </p:ext>
     </p:extLst>
   </p:cSld>
@@ -11438,7 +11438,7 @@
           <p:cNvPr id="1" name="">
             <a:extLst xmlns:a="http://schemas.openxmlformats.org/drawingml/2006/main">
               <a:ext uri="{FF2B5EF4-FFF2-40B4-BE49-F238E27FC236}">
-                <a16:creationId xmlns:a16="http://schemas.microsoft.com/office/drawing/2014/main" id="{12B5B9F0-F76F-41AF-85C1-0F847C58B0B7}"/>
+                <a16:creationId xmlns:a16="http://schemas.microsoft.com/office/drawing/2014/main" id="{37E69958-D747-4911-A4BC-BF0B2349E2B8}"/>
               </a:ext>
             </a:extLst>
           </p:cNvPr>
@@ -11477,7 +11477,7 @@
           <p:nvPr/>
         </p:nvPicPr>
         <p:blipFill>
-          <a:blip xmlns:r="http://schemas.openxmlformats.org/officeDocument/2006/relationships" xmlns:a="http://schemas.openxmlformats.org/drawingml/2006/main" r:embed="R7c812f9487f84442"/>
+          <a:blip xmlns:r="http://schemas.openxmlformats.org/officeDocument/2006/relationships" xmlns:a="http://schemas.openxmlformats.org/drawingml/2006/main" r:embed="R244afc4046fd4f53"/>
           <a:stretch xmlns:a="http://schemas.openxmlformats.org/drawingml/2006/main"/>
         </p:blipFill>
         <p:spPr>
@@ -11495,7 +11495,7 @@
           <p:cNvPr id="3" name="">
             <a:extLst xmlns:a="http://schemas.openxmlformats.org/drawingml/2006/main">
               <a:ext uri="{FF2B5EF4-FFF2-40B4-BE49-F238E27FC236}">
-                <a16:creationId xmlns:a16="http://schemas.microsoft.com/office/drawing/2014/main" id="{829223E1-3A7F-4435-B544-77670F683F65}"/>
+                <a16:creationId xmlns:a16="http://schemas.microsoft.com/office/drawing/2014/main" id="{838E5A31-80F4-444F-9624-53DEA5A5A919}"/>
               </a:ext>
             </a:extLst>
           </p:cNvPr>
@@ -11533,14 +11533,14 @@
             <a:pPr algn="r">
               <a:defRPr sz="825" b="1">
                 <a:solidFill>
-                  <a:srgbClr val="0E1B3E"/>
+                  <a:srgbClr val="070F26"/>
                 </a:solidFill>
               </a:defRPr>
             </a:pPr>
             <a:r>
               <a:rPr sz="825" b="1">
                 <a:solidFill>
-                  <a:srgbClr val="0E1B3E"/>
+                  <a:srgbClr val="070F26"/>
                 </a:solidFill>
               </a:rPr>
               <a:t>NTT DATA UNIVERSITY</a:t>
@@ -11553,7 +11553,7 @@
           <p:cNvPr id="4" name="">
             <a:extLst xmlns:a="http://schemas.openxmlformats.org/drawingml/2006/main">
               <a:ext uri="{FF2B5EF4-FFF2-40B4-BE49-F238E27FC236}">
-                <a16:creationId xmlns:a16="http://schemas.microsoft.com/office/drawing/2014/main" id="{32E6E97A-5FC3-4ED1-9275-D8E68C242E50}"/>
+                <a16:creationId xmlns:a16="http://schemas.microsoft.com/office/drawing/2014/main" id="{C94345EE-E57B-4B46-B117-D4C2CF5608D4}"/>
               </a:ext>
             </a:extLst>
           </p:cNvPr>
@@ -11611,7 +11611,7 @@
           <p:cNvPr id="5" name="">
             <a:extLst xmlns:a="http://schemas.openxmlformats.org/drawingml/2006/main">
               <a:ext uri="{FF2B5EF4-FFF2-40B4-BE49-F238E27FC236}">
-                <a16:creationId xmlns:a16="http://schemas.microsoft.com/office/drawing/2014/main" id="{51EB7AC3-27E4-4669-A76D-8B7ED73B8490}"/>
+                <a16:creationId xmlns:a16="http://schemas.microsoft.com/office/drawing/2014/main" id="{675A9459-2E93-43D9-837B-00DB8EE8F15F}"/>
               </a:ext>
             </a:extLst>
           </p:cNvPr>
@@ -11669,7 +11669,7 @@
           <p:cNvPr id="6" name="">
             <a:extLst xmlns:a="http://schemas.openxmlformats.org/drawingml/2006/main">
               <a:ext uri="{FF2B5EF4-FFF2-40B4-BE49-F238E27FC236}">
-                <a16:creationId xmlns:a16="http://schemas.microsoft.com/office/drawing/2014/main" id="{2E1E4757-DFEB-4F6C-8672-013A4F891D4E}"/>
+                <a16:creationId xmlns:a16="http://schemas.microsoft.com/office/drawing/2014/main" id="{225BF7F7-B7A5-4E3A-915A-C49B6894E305}"/>
               </a:ext>
             </a:extLst>
           </p:cNvPr>
@@ -11707,14 +11707,14 @@
             <a:pPr algn="r">
               <a:defRPr sz="675" b="1">
                 <a:solidFill>
-                  <a:srgbClr val="0E1B3E"/>
+                  <a:srgbClr val="070F26"/>
                 </a:solidFill>
               </a:defRPr>
             </a:pPr>
             <a:r>
               <a:rPr sz="675" b="1">
                 <a:solidFill>
-                  <a:srgbClr val="0E1B3E"/>
+                  <a:srgbClr val="070F26"/>
                 </a:solidFill>
               </a:rPr>
               <a:t>NTT DATA UNIVERSITY</a:t>
@@ -11727,7 +11727,7 @@
           <p:cNvPr id="7" name="">
             <a:extLst xmlns:a="http://schemas.openxmlformats.org/drawingml/2006/main">
               <a:ext uri="{FF2B5EF4-FFF2-40B4-BE49-F238E27FC236}">
-                <a16:creationId xmlns:a16="http://schemas.microsoft.com/office/drawing/2014/main" id="{BD352B85-72D6-4032-96E2-BEF485AA9B6C}"/>
+                <a16:creationId xmlns:a16="http://schemas.microsoft.com/office/drawing/2014/main" id="{01BBC4B0-D2D9-4FCC-ADE6-D2E3A91B0434}"/>
               </a:ext>
             </a:extLst>
           </p:cNvPr>
@@ -11785,7 +11785,7 @@
           <p:cNvPr id="8" name="">
             <a:extLst xmlns:a="http://schemas.openxmlformats.org/drawingml/2006/main">
               <a:ext uri="{FF2B5EF4-FFF2-40B4-BE49-F238E27FC236}">
-                <a16:creationId xmlns:a16="http://schemas.microsoft.com/office/drawing/2014/main" id="{7B3F0DC1-B2C7-45E4-8FC6-54E4133B417C}"/>
+                <a16:creationId xmlns:a16="http://schemas.microsoft.com/office/drawing/2014/main" id="{3874C086-87CB-4DD3-9A0B-6F8AC5D0279D}"/>
               </a:ext>
             </a:extLst>
           </p:cNvPr>
@@ -11823,14 +11823,14 @@
             <a:pPr algn="l">
               <a:defRPr sz="2400" b="0">
                 <a:solidFill>
-                  <a:srgbClr val="0E1B3E"/>
+                  <a:srgbClr val="070F26"/>
                 </a:solidFill>
               </a:defRPr>
             </a:pPr>
             <a:r>
               <a:rPr sz="2400" b="0">
                 <a:solidFill>
-                  <a:srgbClr val="0E1B3E"/>
+                  <a:srgbClr val="070F26"/>
                 </a:solidFill>
               </a:rPr>
               <a:t>O que vamos fazer hoje</a:t>
@@ -11843,7 +11843,7 @@
           <p:cNvPr id="9" name="">
             <a:extLst xmlns:a="http://schemas.openxmlformats.org/drawingml/2006/main">
               <a:ext uri="{FF2B5EF4-FFF2-40B4-BE49-F238E27FC236}">
-                <a16:creationId xmlns:a16="http://schemas.microsoft.com/office/drawing/2014/main" id="{E62CF85B-3E0D-40F6-9EE3-EC7C2B8547A1}"/>
+                <a16:creationId xmlns:a16="http://schemas.microsoft.com/office/drawing/2014/main" id="{78127225-CA47-4661-BA6D-28DC5999292E}"/>
               </a:ext>
             </a:extLst>
           </p:cNvPr>
@@ -11901,7 +11901,7 @@
           <p:cNvPr id="10" name="">
             <a:extLst xmlns:a="http://schemas.openxmlformats.org/drawingml/2006/main">
               <a:ext uri="{FF2B5EF4-FFF2-40B4-BE49-F238E27FC236}">
-                <a16:creationId xmlns:a16="http://schemas.microsoft.com/office/drawing/2014/main" id="{BD1A58E0-21DC-45C7-A13B-BE97FDA8FD86}"/>
+                <a16:creationId xmlns:a16="http://schemas.microsoft.com/office/drawing/2014/main" id="{156F5A18-C404-4E20-920D-E9000CCECB7C}"/>
               </a:ext>
             </a:extLst>
           </p:cNvPr>
@@ -11934,7 +11934,7 @@
           <p:cNvPr id="11" name="">
             <a:extLst xmlns:a="http://schemas.openxmlformats.org/drawingml/2006/main">
               <a:ext uri="{FF2B5EF4-FFF2-40B4-BE49-F238E27FC236}">
-                <a16:creationId xmlns:a16="http://schemas.microsoft.com/office/drawing/2014/main" id="{69CD31A0-7012-43CE-9E37-D14C2471C24D}"/>
+                <a16:creationId xmlns:a16="http://schemas.microsoft.com/office/drawing/2014/main" id="{26B5B1D0-6E40-4995-8F5A-3052E286E800}"/>
               </a:ext>
             </a:extLst>
           </p:cNvPr>
@@ -11969,7 +11969,7 @@
           <p:cNvPr id="12" name="">
             <a:extLst xmlns:a="http://schemas.openxmlformats.org/drawingml/2006/main">
               <a:ext uri="{FF2B5EF4-FFF2-40B4-BE49-F238E27FC236}">
-                <a16:creationId xmlns:a16="http://schemas.microsoft.com/office/drawing/2014/main" id="{AFC5E443-BFDE-4BE8-B4C5-B5D6E4CDBE78}"/>
+                <a16:creationId xmlns:a16="http://schemas.microsoft.com/office/drawing/2014/main" id="{309F96B7-F389-47AD-B998-338A47068F00}"/>
               </a:ext>
             </a:extLst>
           </p:cNvPr>
@@ -12027,7 +12027,7 @@
           <p:cNvPr id="13" name="">
             <a:extLst xmlns:a="http://schemas.openxmlformats.org/drawingml/2006/main">
               <a:ext uri="{FF2B5EF4-FFF2-40B4-BE49-F238E27FC236}">
-                <a16:creationId xmlns:a16="http://schemas.microsoft.com/office/drawing/2014/main" id="{9139B229-1331-4903-A1AE-C072C74F76CC}"/>
+                <a16:creationId xmlns:a16="http://schemas.microsoft.com/office/drawing/2014/main" id="{89E0A4A9-54C9-42E7-8AAF-057DCC857B35}"/>
               </a:ext>
             </a:extLst>
           </p:cNvPr>
@@ -12102,7 +12102,7 @@
           <p:cNvPr id="14" name="">
             <a:extLst xmlns:a="http://schemas.openxmlformats.org/drawingml/2006/main">
               <a:ext uri="{FF2B5EF4-FFF2-40B4-BE49-F238E27FC236}">
-                <a16:creationId xmlns:a16="http://schemas.microsoft.com/office/drawing/2014/main" id="{0BE48605-5763-40D9-A9AD-CFE24A344DE5}"/>
+                <a16:creationId xmlns:a16="http://schemas.microsoft.com/office/drawing/2014/main" id="{5FDE4115-B0C8-4C03-8C9C-047120021E3D}"/>
               </a:ext>
             </a:extLst>
           </p:cNvPr>
@@ -12135,7 +12135,7 @@
           <p:cNvPr id="15" name="">
             <a:extLst xmlns:a="http://schemas.openxmlformats.org/drawingml/2006/main">
               <a:ext uri="{FF2B5EF4-FFF2-40B4-BE49-F238E27FC236}">
-                <a16:creationId xmlns:a16="http://schemas.microsoft.com/office/drawing/2014/main" id="{007BC887-1290-4B7D-B372-E5D850194F6D}"/>
+                <a16:creationId xmlns:a16="http://schemas.microsoft.com/office/drawing/2014/main" id="{4BFFC020-569D-4021-B0F6-B3C54639BF8E}"/>
               </a:ext>
             </a:extLst>
           </p:cNvPr>
@@ -12170,7 +12170,7 @@
           <p:cNvPr id="16" name="">
             <a:extLst xmlns:a="http://schemas.openxmlformats.org/drawingml/2006/main">
               <a:ext uri="{FF2B5EF4-FFF2-40B4-BE49-F238E27FC236}">
-                <a16:creationId xmlns:a16="http://schemas.microsoft.com/office/drawing/2014/main" id="{C6C539E3-5829-448A-8673-55F0F853E506}"/>
+                <a16:creationId xmlns:a16="http://schemas.microsoft.com/office/drawing/2014/main" id="{7FE4E205-0E9A-4485-8705-30B5F4411C40}"/>
               </a:ext>
             </a:extLst>
           </p:cNvPr>
@@ -12228,7 +12228,7 @@
           <p:cNvPr id="17" name="">
             <a:extLst xmlns:a="http://schemas.openxmlformats.org/drawingml/2006/main">
               <a:ext uri="{FF2B5EF4-FFF2-40B4-BE49-F238E27FC236}">
-                <a16:creationId xmlns:a16="http://schemas.microsoft.com/office/drawing/2014/main" id="{5A4B7D2A-B0E6-41B9-9AD0-3E95808E23F3}"/>
+                <a16:creationId xmlns:a16="http://schemas.microsoft.com/office/drawing/2014/main" id="{7DF74BAD-1AFF-42CE-A7B6-4AF6C52375C1}"/>
               </a:ext>
             </a:extLst>
           </p:cNvPr>
@@ -12320,7 +12320,7 @@
           <p:cNvPr id="18" name="">
             <a:extLst xmlns:a="http://schemas.openxmlformats.org/drawingml/2006/main">
               <a:ext uri="{FF2B5EF4-FFF2-40B4-BE49-F238E27FC236}">
-                <a16:creationId xmlns:a16="http://schemas.microsoft.com/office/drawing/2014/main" id="{25F23E4B-0777-4503-A2EE-1439EAADEE8F}"/>
+                <a16:creationId xmlns:a16="http://schemas.microsoft.com/office/drawing/2014/main" id="{CE521FA7-2716-43BC-84FF-DDE791FD688A}"/>
               </a:ext>
             </a:extLst>
           </p:cNvPr>
@@ -12353,7 +12353,7 @@
           <p:cNvPr id="19" name="">
             <a:extLst xmlns:a="http://schemas.openxmlformats.org/drawingml/2006/main">
               <a:ext uri="{FF2B5EF4-FFF2-40B4-BE49-F238E27FC236}">
-                <a16:creationId xmlns:a16="http://schemas.microsoft.com/office/drawing/2014/main" id="{7227CFD0-A0D5-4C52-8DDE-C3D8F90856FF}"/>
+                <a16:creationId xmlns:a16="http://schemas.microsoft.com/office/drawing/2014/main" id="{1A0AF5B8-112B-4A7A-85FC-5A709ABA6F7C}"/>
               </a:ext>
             </a:extLst>
           </p:cNvPr>
@@ -12388,7 +12388,7 @@
           <p:cNvPr id="20" name="">
             <a:extLst xmlns:a="http://schemas.openxmlformats.org/drawingml/2006/main">
               <a:ext uri="{FF2B5EF4-FFF2-40B4-BE49-F238E27FC236}">
-                <a16:creationId xmlns:a16="http://schemas.microsoft.com/office/drawing/2014/main" id="{E6590DC1-5212-473A-8B40-F366509BE180}"/>
+                <a16:creationId xmlns:a16="http://schemas.microsoft.com/office/drawing/2014/main" id="{46DE83E9-A1A5-471F-A733-755240E41627}"/>
               </a:ext>
             </a:extLst>
           </p:cNvPr>
@@ -12446,7 +12446,7 @@
           <p:cNvPr id="21" name="">
             <a:extLst xmlns:a="http://schemas.openxmlformats.org/drawingml/2006/main">
               <a:ext uri="{FF2B5EF4-FFF2-40B4-BE49-F238E27FC236}">
-                <a16:creationId xmlns:a16="http://schemas.microsoft.com/office/drawing/2014/main" id="{E9AD9B37-1920-4371-B02A-A8BC59131B70}"/>
+                <a16:creationId xmlns:a16="http://schemas.microsoft.com/office/drawing/2014/main" id="{B6681E79-83FC-4434-86C3-4EA4B5A5168C}"/>
               </a:ext>
             </a:extLst>
           </p:cNvPr>
@@ -12502,7 +12502,7 @@
     </p:spTree>
     <p:extLst>
       <p:ext uri="{BB962C8B-B14F-4D97-AF65-F5344CB8AC3E}">
-        <p14:creationId xmlns:p14="http://schemas.microsoft.com/office/powerpoint/2010/main" val="294683661"/>
+        <p14:creationId xmlns:p14="http://schemas.microsoft.com/office/powerpoint/2010/main" val="204373710"/>
       </p:ext>
     </p:extLst>
   </p:cSld>
@@ -12515,7 +12515,7 @@
     <p:bg>
       <p:bgPr>
         <a:solidFill xmlns:a="http://schemas.openxmlformats.org/drawingml/2006/main">
-          <a:srgbClr val="0E1B3E"/>
+          <a:srgbClr val="070F26"/>
         </a:solidFill>
       </p:bgPr>
     </p:bg>
@@ -12533,7 +12533,7 @@
           <p:cNvPr id="1" name="">
             <a:extLst xmlns:a="http://schemas.openxmlformats.org/drawingml/2006/main">
               <a:ext uri="{FF2B5EF4-FFF2-40B4-BE49-F238E27FC236}">
-                <a16:creationId xmlns:a16="http://schemas.microsoft.com/office/drawing/2014/main" id="{78FE5FB1-272B-449B-B457-F666DF4B9318}"/>
+                <a16:creationId xmlns:a16="http://schemas.microsoft.com/office/drawing/2014/main" id="{A7858D15-CBCE-445D-B9AD-4BDDB60BDD36}"/>
               </a:ext>
             </a:extLst>
           </p:cNvPr>
@@ -12551,7 +12551,7 @@
             <a:avLst/>
           </a:prstGeom>
           <a:solidFill xmlns:a="http://schemas.openxmlformats.org/drawingml/2006/main">
-            <a:srgbClr val="0E1B3E"/>
+            <a:srgbClr val="070F26"/>
           </a:solidFill>
           <a:ln xmlns:a="http://schemas.openxmlformats.org/drawingml/2006/main" w="0">
             <a:solidFill>
@@ -12572,7 +12572,7 @@
           <p:nvPr/>
         </p:nvPicPr>
         <p:blipFill>
-          <a:blip xmlns:r="http://schemas.openxmlformats.org/officeDocument/2006/relationships" xmlns:a="http://schemas.openxmlformats.org/drawingml/2006/main" r:embed="R337e8242111d4a2c"/>
+          <a:blip xmlns:r="http://schemas.openxmlformats.org/officeDocument/2006/relationships" xmlns:a="http://schemas.openxmlformats.org/drawingml/2006/main" r:embed="R6e46ff410a05464f"/>
           <a:stretch xmlns:a="http://schemas.openxmlformats.org/drawingml/2006/main"/>
         </p:blipFill>
         <p:spPr>
@@ -12590,7 +12590,7 @@
           <p:cNvPr id="3" name="">
             <a:extLst xmlns:a="http://schemas.openxmlformats.org/drawingml/2006/main">
               <a:ext uri="{FF2B5EF4-FFF2-40B4-BE49-F238E27FC236}">
-                <a16:creationId xmlns:a16="http://schemas.microsoft.com/office/drawing/2014/main" id="{4FC15F02-4EF6-408D-8E89-B95D1D626CED}"/>
+                <a16:creationId xmlns:a16="http://schemas.microsoft.com/office/drawing/2014/main" id="{7744D61B-6013-474E-86EC-613FF65832E7}"/>
               </a:ext>
             </a:extLst>
           </p:cNvPr>
@@ -12648,7 +12648,7 @@
           <p:cNvPr id="4" name="">
             <a:extLst xmlns:a="http://schemas.openxmlformats.org/drawingml/2006/main">
               <a:ext uri="{FF2B5EF4-FFF2-40B4-BE49-F238E27FC236}">
-                <a16:creationId xmlns:a16="http://schemas.microsoft.com/office/drawing/2014/main" id="{3E4B0342-01CB-4269-B19A-9BA10CAA1B82}"/>
+                <a16:creationId xmlns:a16="http://schemas.microsoft.com/office/drawing/2014/main" id="{249177FE-A04E-48FE-9302-83A0C0D87728}"/>
               </a:ext>
             </a:extLst>
           </p:cNvPr>
@@ -12706,7 +12706,7 @@
           <p:cNvPr id="5" name="">
             <a:extLst xmlns:a="http://schemas.openxmlformats.org/drawingml/2006/main">
               <a:ext uri="{FF2B5EF4-FFF2-40B4-BE49-F238E27FC236}">
-                <a16:creationId xmlns:a16="http://schemas.microsoft.com/office/drawing/2014/main" id="{684852DC-F0C9-44C7-A0F1-A1EF13F55CBC}"/>
+                <a16:creationId xmlns:a16="http://schemas.microsoft.com/office/drawing/2014/main" id="{8929599E-0BBA-48A8-A422-A4AF0F048CE7}"/>
               </a:ext>
             </a:extLst>
           </p:cNvPr>
@@ -12764,7 +12764,7 @@
           <p:cNvPr id="6" name="">
             <a:extLst xmlns:a="http://schemas.openxmlformats.org/drawingml/2006/main">
               <a:ext uri="{FF2B5EF4-FFF2-40B4-BE49-F238E27FC236}">
-                <a16:creationId xmlns:a16="http://schemas.microsoft.com/office/drawing/2014/main" id="{5C07036B-A391-4234-8919-FCE7BAA37A4B}"/>
+                <a16:creationId xmlns:a16="http://schemas.microsoft.com/office/drawing/2014/main" id="{7CE723E1-78EA-420C-81D0-60FA1AD62695}"/>
               </a:ext>
             </a:extLst>
           </p:cNvPr>
@@ -12826,13 +12826,13 @@
           <p:nvPr/>
         </p:nvPicPr>
         <p:blipFill>
-          <a:blip xmlns:r="http://schemas.openxmlformats.org/officeDocument/2006/relationships" xmlns:a="http://schemas.openxmlformats.org/drawingml/2006/main" r:embed="Rc43acf2e3d0f4747"/>
+          <a:blip xmlns:r="http://schemas.openxmlformats.org/officeDocument/2006/relationships" xmlns:a="http://schemas.openxmlformats.org/drawingml/2006/main" r:embed="R6839b0da0e2d4c13"/>
           <a:stretch xmlns:a="http://schemas.openxmlformats.org/drawingml/2006/main"/>
         </p:blipFill>
         <p:spPr>
           <a:xfrm xmlns:a="http://schemas.openxmlformats.org/drawingml/2006/main">
-            <a:off x="476250" y="1257300"/>
-            <a:ext cx="2667000" cy="4533900"/>
+            <a:off x="0" y="1746250"/>
+            <a:ext cx="2667000" cy="3556000"/>
           </a:xfrm>
           <a:prstGeom xmlns:a="http://schemas.openxmlformats.org/drawingml/2006/main" prst="rect">
             <a:avLst/>
@@ -12844,7 +12844,7 @@
           <p:cNvPr id="8" name="">
             <a:extLst xmlns:a="http://schemas.openxmlformats.org/drawingml/2006/main">
               <a:ext uri="{FF2B5EF4-FFF2-40B4-BE49-F238E27FC236}">
-                <a16:creationId xmlns:a16="http://schemas.microsoft.com/office/drawing/2014/main" id="{DF0A69CA-37DF-49FB-8A84-3555002032D2}"/>
+                <a16:creationId xmlns:a16="http://schemas.microsoft.com/office/drawing/2014/main" id="{6D064B2A-6EA0-49CD-B25A-BE9B8C870E25}"/>
               </a:ext>
             </a:extLst>
           </p:cNvPr>
@@ -12902,7 +12902,7 @@
           <p:cNvPr id="9" name="">
             <a:extLst xmlns:a="http://schemas.openxmlformats.org/drawingml/2006/main">
               <a:ext uri="{FF2B5EF4-FFF2-40B4-BE49-F238E27FC236}">
-                <a16:creationId xmlns:a16="http://schemas.microsoft.com/office/drawing/2014/main" id="{DC66E1D9-4676-45FB-92AE-CB0D214C576A}"/>
+                <a16:creationId xmlns:a16="http://schemas.microsoft.com/office/drawing/2014/main" id="{DA942237-E58A-41D1-BD4A-DFBADB195CF4}"/>
               </a:ext>
             </a:extLst>
           </p:cNvPr>
@@ -12960,7 +12960,7 @@
           <p:cNvPr id="10" name="">
             <a:extLst xmlns:a="http://schemas.openxmlformats.org/drawingml/2006/main">
               <a:ext uri="{FF2B5EF4-FFF2-40B4-BE49-F238E27FC236}">
-                <a16:creationId xmlns:a16="http://schemas.microsoft.com/office/drawing/2014/main" id="{FBD0A677-A038-42D0-99A0-4694D1522630}"/>
+                <a16:creationId xmlns:a16="http://schemas.microsoft.com/office/drawing/2014/main" id="{B35F9A9F-E209-4E3E-8D20-9C9884469FD8}"/>
               </a:ext>
             </a:extLst>
           </p:cNvPr>
@@ -13016,7 +13016,7 @@
     </p:spTree>
     <p:extLst>
       <p:ext uri="{BB962C8B-B14F-4D97-AF65-F5344CB8AC3E}">
-        <p14:creationId xmlns:p14="http://schemas.microsoft.com/office/powerpoint/2010/main" val="1838381047"/>
+        <p14:creationId xmlns:p14="http://schemas.microsoft.com/office/powerpoint/2010/main" val="290835037"/>
       </p:ext>
     </p:extLst>
   </p:cSld>
@@ -13047,7 +13047,7 @@
           <p:cNvPr id="1" name="">
             <a:extLst xmlns:a="http://schemas.openxmlformats.org/drawingml/2006/main">
               <a:ext uri="{FF2B5EF4-FFF2-40B4-BE49-F238E27FC236}">
-                <a16:creationId xmlns:a16="http://schemas.microsoft.com/office/drawing/2014/main" id="{8D2D613C-AA9A-4114-A1D6-595D2A8AD9D9}"/>
+                <a16:creationId xmlns:a16="http://schemas.microsoft.com/office/drawing/2014/main" id="{8DCC2FB3-BA0B-47F2-922A-4B314ADB9E56}"/>
               </a:ext>
             </a:extLst>
           </p:cNvPr>
@@ -13086,7 +13086,7 @@
           <p:nvPr/>
         </p:nvPicPr>
         <p:blipFill>
-          <a:blip xmlns:r="http://schemas.openxmlformats.org/officeDocument/2006/relationships" xmlns:a="http://schemas.openxmlformats.org/drawingml/2006/main" r:embed="R7523bd47e2ca4370"/>
+          <a:blip xmlns:r="http://schemas.openxmlformats.org/officeDocument/2006/relationships" xmlns:a="http://schemas.openxmlformats.org/drawingml/2006/main" r:embed="R12746b4c81404ad4"/>
           <a:stretch xmlns:a="http://schemas.openxmlformats.org/drawingml/2006/main"/>
         </p:blipFill>
         <p:spPr>
@@ -13104,7 +13104,7 @@
           <p:cNvPr id="3" name="">
             <a:extLst xmlns:a="http://schemas.openxmlformats.org/drawingml/2006/main">
               <a:ext uri="{FF2B5EF4-FFF2-40B4-BE49-F238E27FC236}">
-                <a16:creationId xmlns:a16="http://schemas.microsoft.com/office/drawing/2014/main" id="{8722FDD4-14CE-402A-8D9D-D89010D43CAC}"/>
+                <a16:creationId xmlns:a16="http://schemas.microsoft.com/office/drawing/2014/main" id="{3E34287C-B050-4457-8ED6-7BF86B43DDFD}"/>
               </a:ext>
             </a:extLst>
           </p:cNvPr>
@@ -13142,14 +13142,14 @@
             <a:pPr algn="r">
               <a:defRPr sz="825" b="1">
                 <a:solidFill>
-                  <a:srgbClr val="0E1B3E"/>
+                  <a:srgbClr val="070F26"/>
                 </a:solidFill>
               </a:defRPr>
             </a:pPr>
             <a:r>
               <a:rPr sz="825" b="1">
                 <a:solidFill>
-                  <a:srgbClr val="0E1B3E"/>
+                  <a:srgbClr val="070F26"/>
                 </a:solidFill>
               </a:rPr>
               <a:t>NTT DATA UNIVERSITY</a:t>
@@ -13162,7 +13162,7 @@
           <p:cNvPr id="4" name="">
             <a:extLst xmlns:a="http://schemas.openxmlformats.org/drawingml/2006/main">
               <a:ext uri="{FF2B5EF4-FFF2-40B4-BE49-F238E27FC236}">
-                <a16:creationId xmlns:a16="http://schemas.microsoft.com/office/drawing/2014/main" id="{59A2FCD7-F4A7-4826-9372-6A64E5028B64}"/>
+                <a16:creationId xmlns:a16="http://schemas.microsoft.com/office/drawing/2014/main" id="{D6B2060F-F867-4AF0-A4B4-E65036BC3C71}"/>
               </a:ext>
             </a:extLst>
           </p:cNvPr>
@@ -13220,7 +13220,7 @@
           <p:cNvPr id="5" name="">
             <a:extLst xmlns:a="http://schemas.openxmlformats.org/drawingml/2006/main">
               <a:ext uri="{FF2B5EF4-FFF2-40B4-BE49-F238E27FC236}">
-                <a16:creationId xmlns:a16="http://schemas.microsoft.com/office/drawing/2014/main" id="{3680C6F9-A58A-4A3E-9797-3EE068EF73CE}"/>
+                <a16:creationId xmlns:a16="http://schemas.microsoft.com/office/drawing/2014/main" id="{DD699A1F-8414-43E6-9F3C-463B643618C2}"/>
               </a:ext>
             </a:extLst>
           </p:cNvPr>
@@ -13278,7 +13278,7 @@
           <p:cNvPr id="6" name="">
             <a:extLst xmlns:a="http://schemas.openxmlformats.org/drawingml/2006/main">
               <a:ext uri="{FF2B5EF4-FFF2-40B4-BE49-F238E27FC236}">
-                <a16:creationId xmlns:a16="http://schemas.microsoft.com/office/drawing/2014/main" id="{59B77823-FC7B-46F7-9A94-C2B66F972584}"/>
+                <a16:creationId xmlns:a16="http://schemas.microsoft.com/office/drawing/2014/main" id="{3E9EB1BA-D811-433F-B4FE-AA88BBA55DE9}"/>
               </a:ext>
             </a:extLst>
           </p:cNvPr>
@@ -13316,14 +13316,14 @@
             <a:pPr algn="r">
               <a:defRPr sz="675" b="1">
                 <a:solidFill>
-                  <a:srgbClr val="0E1B3E"/>
+                  <a:srgbClr val="070F26"/>
                 </a:solidFill>
               </a:defRPr>
             </a:pPr>
             <a:r>
               <a:rPr sz="675" b="1">
                 <a:solidFill>
-                  <a:srgbClr val="0E1B3E"/>
+                  <a:srgbClr val="070F26"/>
                 </a:solidFill>
               </a:rPr>
               <a:t>NTT DATA UNIVERSITY</a:t>
@@ -13336,7 +13336,7 @@
           <p:cNvPr id="7" name="">
             <a:extLst xmlns:a="http://schemas.openxmlformats.org/drawingml/2006/main">
               <a:ext uri="{FF2B5EF4-FFF2-40B4-BE49-F238E27FC236}">
-                <a16:creationId xmlns:a16="http://schemas.microsoft.com/office/drawing/2014/main" id="{C481006F-E084-4EC7-B8B5-C1CAC86D9402}"/>
+                <a16:creationId xmlns:a16="http://schemas.microsoft.com/office/drawing/2014/main" id="{E085F14C-2804-42CF-9D18-3AE474734C40}"/>
               </a:ext>
             </a:extLst>
           </p:cNvPr>
@@ -13394,7 +13394,7 @@
           <p:cNvPr id="8" name="">
             <a:extLst xmlns:a="http://schemas.openxmlformats.org/drawingml/2006/main">
               <a:ext uri="{FF2B5EF4-FFF2-40B4-BE49-F238E27FC236}">
-                <a16:creationId xmlns:a16="http://schemas.microsoft.com/office/drawing/2014/main" id="{E7A7F354-E2E3-4FA8-8EF9-21DE189FD833}"/>
+                <a16:creationId xmlns:a16="http://schemas.microsoft.com/office/drawing/2014/main" id="{DE5C4B65-0B72-4483-AA6B-739FDD937BBA}"/>
               </a:ext>
             </a:extLst>
           </p:cNvPr>
@@ -13432,14 +13432,14 @@
             <a:pPr algn="l">
               <a:defRPr sz="2400" b="0">
                 <a:solidFill>
-                  <a:srgbClr val="0E1B3E"/>
+                  <a:srgbClr val="070F26"/>
                 </a:solidFill>
               </a:defRPr>
             </a:pPr>
             <a:r>
               <a:rPr sz="2400" b="0">
                 <a:solidFill>
-                  <a:srgbClr val="0E1B3E"/>
+                  <a:srgbClr val="070F26"/>
                 </a:solidFill>
               </a:rPr>
               <a:t>Banco funcionando? Rode a query abaixo.</a:t>
@@ -13452,7 +13452,7 @@
           <p:cNvPr id="9" name="">
             <a:extLst xmlns:a="http://schemas.openxmlformats.org/drawingml/2006/main">
               <a:ext uri="{FF2B5EF4-FFF2-40B4-BE49-F238E27FC236}">
-                <a16:creationId xmlns:a16="http://schemas.microsoft.com/office/drawing/2014/main" id="{6F52F5E8-F2D5-4770-8F99-600C2FB1D93C}"/>
+                <a16:creationId xmlns:a16="http://schemas.microsoft.com/office/drawing/2014/main" id="{BBE179C8-7492-4F11-B379-843BD6FC82F5}"/>
               </a:ext>
             </a:extLst>
           </p:cNvPr>
@@ -13510,7 +13510,7 @@
           <p:cNvPr id="10" name="">
             <a:extLst xmlns:a="http://schemas.openxmlformats.org/drawingml/2006/main">
               <a:ext uri="{FF2B5EF4-FFF2-40B4-BE49-F238E27FC236}">
-                <a16:creationId xmlns:a16="http://schemas.microsoft.com/office/drawing/2014/main" id="{241D3E1D-428A-4EE0-B922-0AECB3C7259D}"/>
+                <a16:creationId xmlns:a16="http://schemas.microsoft.com/office/drawing/2014/main" id="{0105AE69-544F-4A06-BDB4-24E78DEAE27C}"/>
               </a:ext>
             </a:extLst>
           </p:cNvPr>
@@ -13543,7 +13543,7 @@
           <p:cNvPr id="11" name="">
             <a:extLst xmlns:a="http://schemas.openxmlformats.org/drawingml/2006/main">
               <a:ext uri="{FF2B5EF4-FFF2-40B4-BE49-F238E27FC236}">
-                <a16:creationId xmlns:a16="http://schemas.microsoft.com/office/drawing/2014/main" id="{5B867DA5-F2BE-4787-87C7-7F817EF3F957}"/>
+                <a16:creationId xmlns:a16="http://schemas.microsoft.com/office/drawing/2014/main" id="{23FDFD5C-A6CC-4C05-B163-6E9FE405C914}"/>
               </a:ext>
             </a:extLst>
           </p:cNvPr>
@@ -13578,7 +13578,7 @@
           <p:cNvPr id="12" name="">
             <a:extLst xmlns:a="http://schemas.openxmlformats.org/drawingml/2006/main">
               <a:ext uri="{FF2B5EF4-FFF2-40B4-BE49-F238E27FC236}">
-                <a16:creationId xmlns:a16="http://schemas.microsoft.com/office/drawing/2014/main" id="{0A6D9B85-0190-4B44-BE58-BEE05657AAC2}"/>
+                <a16:creationId xmlns:a16="http://schemas.microsoft.com/office/drawing/2014/main" id="{115BA3E2-EC52-4D7C-ACF1-C2CAC6047362}"/>
               </a:ext>
             </a:extLst>
           </p:cNvPr>
@@ -13636,7 +13636,7 @@
           <p:cNvPr id="13" name="">
             <a:extLst xmlns:a="http://schemas.openxmlformats.org/drawingml/2006/main">
               <a:ext uri="{FF2B5EF4-FFF2-40B4-BE49-F238E27FC236}">
-                <a16:creationId xmlns:a16="http://schemas.microsoft.com/office/drawing/2014/main" id="{03D11E6B-0669-4F40-9FD4-AED8F0D0EC8B}"/>
+                <a16:creationId xmlns:a16="http://schemas.microsoft.com/office/drawing/2014/main" id="{693947D8-F176-44B3-ABF3-1381BE8E08F9}"/>
               </a:ext>
             </a:extLst>
           </p:cNvPr>
@@ -13777,7 +13777,7 @@
           <p:cNvPr id="14" name="">
             <a:extLst xmlns:a="http://schemas.openxmlformats.org/drawingml/2006/main">
               <a:ext uri="{FF2B5EF4-FFF2-40B4-BE49-F238E27FC236}">
-                <a16:creationId xmlns:a16="http://schemas.microsoft.com/office/drawing/2014/main" id="{23E9BF6A-0936-485A-B29C-90BED77A9AFE}"/>
+                <a16:creationId xmlns:a16="http://schemas.microsoft.com/office/drawing/2014/main" id="{1A815DFA-0FF2-4CA1-BFA5-E2CDE425637D}"/>
               </a:ext>
             </a:extLst>
           </p:cNvPr>
@@ -13810,7 +13810,7 @@
           <p:cNvPr id="15" name="">
             <a:extLst xmlns:a="http://schemas.openxmlformats.org/drawingml/2006/main">
               <a:ext uri="{FF2B5EF4-FFF2-40B4-BE49-F238E27FC236}">
-                <a16:creationId xmlns:a16="http://schemas.microsoft.com/office/drawing/2014/main" id="{BEA1E6CB-93FD-4862-8506-4874B3D36576}"/>
+                <a16:creationId xmlns:a16="http://schemas.microsoft.com/office/drawing/2014/main" id="{1DF22113-02D1-4F50-A2D7-8A532B400E79}"/>
               </a:ext>
             </a:extLst>
           </p:cNvPr>
@@ -13845,7 +13845,7 @@
           <p:cNvPr id="16" name="">
             <a:extLst xmlns:a="http://schemas.openxmlformats.org/drawingml/2006/main">
               <a:ext uri="{FF2B5EF4-FFF2-40B4-BE49-F238E27FC236}">
-                <a16:creationId xmlns:a16="http://schemas.microsoft.com/office/drawing/2014/main" id="{D5166387-2DD9-4907-8692-CE5047FACCB7}"/>
+                <a16:creationId xmlns:a16="http://schemas.microsoft.com/office/drawing/2014/main" id="{B8C5C8AB-0ADE-4FA2-9E66-48F25E07C6F0}"/>
               </a:ext>
             </a:extLst>
           </p:cNvPr>
@@ -13903,7 +13903,7 @@
           <p:cNvPr id="17" name="">
             <a:extLst xmlns:a="http://schemas.openxmlformats.org/drawingml/2006/main">
               <a:ext uri="{FF2B5EF4-FFF2-40B4-BE49-F238E27FC236}">
-                <a16:creationId xmlns:a16="http://schemas.microsoft.com/office/drawing/2014/main" id="{A661BD6F-F44B-459C-8526-7AA5A3BC7B88}"/>
+                <a16:creationId xmlns:a16="http://schemas.microsoft.com/office/drawing/2014/main" id="{78C89CAF-9A5C-4E33-B098-CFC369FD5A32}"/>
               </a:ext>
             </a:extLst>
           </p:cNvPr>
@@ -14105,7 +14105,7 @@
     </p:spTree>
     <p:extLst>
       <p:ext uri="{BB962C8B-B14F-4D97-AF65-F5344CB8AC3E}">
-        <p14:creationId xmlns:p14="http://schemas.microsoft.com/office/powerpoint/2010/main" val="1324322661"/>
+        <p14:creationId xmlns:p14="http://schemas.microsoft.com/office/powerpoint/2010/main" val="268877850"/>
       </p:ext>
     </p:extLst>
   </p:cSld>
@@ -14118,7 +14118,7 @@
     <p:bg>
       <p:bgPr>
         <a:solidFill xmlns:a="http://schemas.openxmlformats.org/drawingml/2006/main">
-          <a:srgbClr val="0E1B3E"/>
+          <a:srgbClr val="070F26"/>
         </a:solidFill>
       </p:bgPr>
     </p:bg>
@@ -14136,7 +14136,7 @@
           <p:cNvPr id="1" name="">
             <a:extLst xmlns:a="http://schemas.openxmlformats.org/drawingml/2006/main">
               <a:ext uri="{FF2B5EF4-FFF2-40B4-BE49-F238E27FC236}">
-                <a16:creationId xmlns:a16="http://schemas.microsoft.com/office/drawing/2014/main" id="{02A8369A-4AAA-4562-8900-65EF2A1B66CF}"/>
+                <a16:creationId xmlns:a16="http://schemas.microsoft.com/office/drawing/2014/main" id="{A353552C-CDB6-4265-923F-05DD795924FE}"/>
               </a:ext>
             </a:extLst>
           </p:cNvPr>
@@ -14154,7 +14154,7 @@
             <a:avLst/>
           </a:prstGeom>
           <a:solidFill xmlns:a="http://schemas.openxmlformats.org/drawingml/2006/main">
-            <a:srgbClr val="0E1B3E"/>
+            <a:srgbClr val="070F26"/>
           </a:solidFill>
           <a:ln xmlns:a="http://schemas.openxmlformats.org/drawingml/2006/main" w="0">
             <a:solidFill>
@@ -14175,7 +14175,7 @@
           <p:nvPr/>
         </p:nvPicPr>
         <p:blipFill>
-          <a:blip xmlns:r="http://schemas.openxmlformats.org/officeDocument/2006/relationships" xmlns:a="http://schemas.openxmlformats.org/drawingml/2006/main" r:embed="R833608c110ba4596"/>
+          <a:blip xmlns:r="http://schemas.openxmlformats.org/officeDocument/2006/relationships" xmlns:a="http://schemas.openxmlformats.org/drawingml/2006/main" r:embed="R7a4565157580478d"/>
           <a:stretch xmlns:a="http://schemas.openxmlformats.org/drawingml/2006/main"/>
         </p:blipFill>
         <p:spPr>
@@ -14193,7 +14193,7 @@
           <p:cNvPr id="3" name="">
             <a:extLst xmlns:a="http://schemas.openxmlformats.org/drawingml/2006/main">
               <a:ext uri="{FF2B5EF4-FFF2-40B4-BE49-F238E27FC236}">
-                <a16:creationId xmlns:a16="http://schemas.microsoft.com/office/drawing/2014/main" id="{E4FC4203-9442-404A-AD37-3C05EB3146D3}"/>
+                <a16:creationId xmlns:a16="http://schemas.microsoft.com/office/drawing/2014/main" id="{77345CEC-B6A1-4D50-A21B-9E7A05328E7F}"/>
               </a:ext>
             </a:extLst>
           </p:cNvPr>
@@ -14251,7 +14251,7 @@
           <p:cNvPr id="4" name="">
             <a:extLst xmlns:a="http://schemas.openxmlformats.org/drawingml/2006/main">
               <a:ext uri="{FF2B5EF4-FFF2-40B4-BE49-F238E27FC236}">
-                <a16:creationId xmlns:a16="http://schemas.microsoft.com/office/drawing/2014/main" id="{5C301F32-F8A5-4ED7-8A58-665E21ACFF8C}"/>
+                <a16:creationId xmlns:a16="http://schemas.microsoft.com/office/drawing/2014/main" id="{F10FE88B-4CD8-42F2-86C1-420866C07AD3}"/>
               </a:ext>
             </a:extLst>
           </p:cNvPr>
@@ -14309,7 +14309,7 @@
           <p:cNvPr id="5" name="">
             <a:extLst xmlns:a="http://schemas.openxmlformats.org/drawingml/2006/main">
               <a:ext uri="{FF2B5EF4-FFF2-40B4-BE49-F238E27FC236}">
-                <a16:creationId xmlns:a16="http://schemas.microsoft.com/office/drawing/2014/main" id="{D68D90D2-E984-4452-813A-EC0D3DEC175B}"/>
+                <a16:creationId xmlns:a16="http://schemas.microsoft.com/office/drawing/2014/main" id="{A3A6DA73-B36D-4D98-9E57-31F4592A9488}"/>
               </a:ext>
             </a:extLst>
           </p:cNvPr>
@@ -14367,7 +14367,7 @@
           <p:cNvPr id="6" name="">
             <a:extLst xmlns:a="http://schemas.openxmlformats.org/drawingml/2006/main">
               <a:ext uri="{FF2B5EF4-FFF2-40B4-BE49-F238E27FC236}">
-                <a16:creationId xmlns:a16="http://schemas.microsoft.com/office/drawing/2014/main" id="{FC723ADE-D0D9-49A2-ACE6-0571845D3DD3}"/>
+                <a16:creationId xmlns:a16="http://schemas.microsoft.com/office/drawing/2014/main" id="{99BE1FDE-D5CA-4840-AC5D-645B7D7AC82E}"/>
               </a:ext>
             </a:extLst>
           </p:cNvPr>
@@ -14429,13 +14429,13 @@
           <p:nvPr/>
         </p:nvPicPr>
         <p:blipFill>
-          <a:blip xmlns:r="http://schemas.openxmlformats.org/officeDocument/2006/relationships" xmlns:a="http://schemas.openxmlformats.org/drawingml/2006/main" r:embed="R0430cac32bd94c84"/>
+          <a:blip xmlns:r="http://schemas.openxmlformats.org/officeDocument/2006/relationships" xmlns:a="http://schemas.openxmlformats.org/drawingml/2006/main" r:embed="R656fa25b52614a82"/>
           <a:stretch xmlns:a="http://schemas.openxmlformats.org/drawingml/2006/main"/>
         </p:blipFill>
         <p:spPr>
           <a:xfrm xmlns:a="http://schemas.openxmlformats.org/drawingml/2006/main">
-            <a:off x="476250" y="1257300"/>
-            <a:ext cx="2667000" cy="4533900"/>
+            <a:off x="0" y="1746250"/>
+            <a:ext cx="2667000" cy="3556000"/>
           </a:xfrm>
           <a:prstGeom xmlns:a="http://schemas.openxmlformats.org/drawingml/2006/main" prst="rect">
             <a:avLst/>
@@ -14447,7 +14447,7 @@
           <p:cNvPr id="8" name="">
             <a:extLst xmlns:a="http://schemas.openxmlformats.org/drawingml/2006/main">
               <a:ext uri="{FF2B5EF4-FFF2-40B4-BE49-F238E27FC236}">
-                <a16:creationId xmlns:a16="http://schemas.microsoft.com/office/drawing/2014/main" id="{3B2D221C-16F9-4D5C-97DB-A2B7147D60CB}"/>
+                <a16:creationId xmlns:a16="http://schemas.microsoft.com/office/drawing/2014/main" id="{3F547F24-63BE-4B34-B0E5-015806769A00}"/>
               </a:ext>
             </a:extLst>
           </p:cNvPr>
@@ -14505,7 +14505,7 @@
           <p:cNvPr id="9" name="">
             <a:extLst xmlns:a="http://schemas.openxmlformats.org/drawingml/2006/main">
               <a:ext uri="{FF2B5EF4-FFF2-40B4-BE49-F238E27FC236}">
-                <a16:creationId xmlns:a16="http://schemas.microsoft.com/office/drawing/2014/main" id="{8B27DE26-5E83-450C-AE64-006CF5FC6CB8}"/>
+                <a16:creationId xmlns:a16="http://schemas.microsoft.com/office/drawing/2014/main" id="{393A1421-B0FA-439A-B097-F0F41647FCE7}"/>
               </a:ext>
             </a:extLst>
           </p:cNvPr>
@@ -14563,7 +14563,7 @@
           <p:cNvPr id="10" name="">
             <a:extLst xmlns:a="http://schemas.openxmlformats.org/drawingml/2006/main">
               <a:ext uri="{FF2B5EF4-FFF2-40B4-BE49-F238E27FC236}">
-                <a16:creationId xmlns:a16="http://schemas.microsoft.com/office/drawing/2014/main" id="{1A4E8039-3EE5-48FA-973E-B3B84CD402CE}"/>
+                <a16:creationId xmlns:a16="http://schemas.microsoft.com/office/drawing/2014/main" id="{0EE292F9-932B-4BA6-8253-0132C1CDA609}"/>
               </a:ext>
             </a:extLst>
           </p:cNvPr>
@@ -14619,7 +14619,7 @@
     </p:spTree>
     <p:extLst>
       <p:ext uri="{BB962C8B-B14F-4D97-AF65-F5344CB8AC3E}">
-        <p14:creationId xmlns:p14="http://schemas.microsoft.com/office/powerpoint/2010/main" val="55484736"/>
+        <p14:creationId xmlns:p14="http://schemas.microsoft.com/office/powerpoint/2010/main" val="1589203903"/>
       </p:ext>
     </p:extLst>
   </p:cSld>
@@ -14650,7 +14650,7 @@
           <p:cNvPr id="1" name="">
             <a:extLst xmlns:a="http://schemas.openxmlformats.org/drawingml/2006/main">
               <a:ext uri="{FF2B5EF4-FFF2-40B4-BE49-F238E27FC236}">
-                <a16:creationId xmlns:a16="http://schemas.microsoft.com/office/drawing/2014/main" id="{5F06C90C-0A93-45CC-963E-AA0CE77D83C8}"/>
+                <a16:creationId xmlns:a16="http://schemas.microsoft.com/office/drawing/2014/main" id="{FC1DFFD8-DC19-4DFD-B761-677E0F5967B5}"/>
               </a:ext>
             </a:extLst>
           </p:cNvPr>
@@ -14689,7 +14689,7 @@
           <p:nvPr/>
         </p:nvPicPr>
         <p:blipFill>
-          <a:blip xmlns:r="http://schemas.openxmlformats.org/officeDocument/2006/relationships" xmlns:a="http://schemas.openxmlformats.org/drawingml/2006/main" r:embed="R8f9f3c03af734c4b"/>
+          <a:blip xmlns:r="http://schemas.openxmlformats.org/officeDocument/2006/relationships" xmlns:a="http://schemas.openxmlformats.org/drawingml/2006/main" r:embed="R44fbfeab5ea44c5b"/>
           <a:stretch xmlns:a="http://schemas.openxmlformats.org/drawingml/2006/main"/>
         </p:blipFill>
         <p:spPr>
@@ -14707,7 +14707,7 @@
           <p:cNvPr id="3" name="">
             <a:extLst xmlns:a="http://schemas.openxmlformats.org/drawingml/2006/main">
               <a:ext uri="{FF2B5EF4-FFF2-40B4-BE49-F238E27FC236}">
-                <a16:creationId xmlns:a16="http://schemas.microsoft.com/office/drawing/2014/main" id="{2C8E0935-1070-4F9E-95A7-E7ABDDF2AA19}"/>
+                <a16:creationId xmlns:a16="http://schemas.microsoft.com/office/drawing/2014/main" id="{91FF847E-C1D8-426A-9AF9-39D047116685}"/>
               </a:ext>
             </a:extLst>
           </p:cNvPr>
@@ -14745,14 +14745,14 @@
             <a:pPr algn="r">
               <a:defRPr sz="825" b="1">
                 <a:solidFill>
-                  <a:srgbClr val="0E1B3E"/>
+                  <a:srgbClr val="070F26"/>
                 </a:solidFill>
               </a:defRPr>
             </a:pPr>
             <a:r>
               <a:rPr sz="825" b="1">
                 <a:solidFill>
-                  <a:srgbClr val="0E1B3E"/>
+                  <a:srgbClr val="070F26"/>
                 </a:solidFill>
               </a:rPr>
               <a:t>NTT DATA UNIVERSITY</a:t>
@@ -14765,7 +14765,7 @@
           <p:cNvPr id="4" name="">
             <a:extLst xmlns:a="http://schemas.openxmlformats.org/drawingml/2006/main">
               <a:ext uri="{FF2B5EF4-FFF2-40B4-BE49-F238E27FC236}">
-                <a16:creationId xmlns:a16="http://schemas.microsoft.com/office/drawing/2014/main" id="{A75A4FFD-5E05-4469-9316-B7AC3AF80E70}"/>
+                <a16:creationId xmlns:a16="http://schemas.microsoft.com/office/drawing/2014/main" id="{2C3CB41C-3A46-472A-A389-84112C16CEFF}"/>
               </a:ext>
             </a:extLst>
           </p:cNvPr>
@@ -14823,7 +14823,7 @@
           <p:cNvPr id="5" name="">
             <a:extLst xmlns:a="http://schemas.openxmlformats.org/drawingml/2006/main">
               <a:ext uri="{FF2B5EF4-FFF2-40B4-BE49-F238E27FC236}">
-                <a16:creationId xmlns:a16="http://schemas.microsoft.com/office/drawing/2014/main" id="{934E7DB9-84F0-4523-A211-B8450C5D3BD8}"/>
+                <a16:creationId xmlns:a16="http://schemas.microsoft.com/office/drawing/2014/main" id="{96F90B44-C06E-48D9-8819-A8F704FA55AA}"/>
               </a:ext>
             </a:extLst>
           </p:cNvPr>
@@ -14881,7 +14881,7 @@
           <p:cNvPr id="6" name="">
             <a:extLst xmlns:a="http://schemas.openxmlformats.org/drawingml/2006/main">
               <a:ext uri="{FF2B5EF4-FFF2-40B4-BE49-F238E27FC236}">
-                <a16:creationId xmlns:a16="http://schemas.microsoft.com/office/drawing/2014/main" id="{A9E75CE4-68EB-4C47-9DB4-E6D2361F2C14}"/>
+                <a16:creationId xmlns:a16="http://schemas.microsoft.com/office/drawing/2014/main" id="{7C5C9AC0-7C65-471A-BB9E-92F5F9B4E020}"/>
               </a:ext>
             </a:extLst>
           </p:cNvPr>
@@ -14919,14 +14919,14 @@
             <a:pPr algn="r">
               <a:defRPr sz="675" b="1">
                 <a:solidFill>
-                  <a:srgbClr val="0E1B3E"/>
+                  <a:srgbClr val="070F26"/>
                 </a:solidFill>
               </a:defRPr>
             </a:pPr>
             <a:r>
               <a:rPr sz="675" b="1">
                 <a:solidFill>
-                  <a:srgbClr val="0E1B3E"/>
+                  <a:srgbClr val="070F26"/>
                 </a:solidFill>
               </a:rPr>
               <a:t>NTT DATA UNIVERSITY</a:t>
@@ -14939,7 +14939,7 @@
           <p:cNvPr id="7" name="">
             <a:extLst xmlns:a="http://schemas.openxmlformats.org/drawingml/2006/main">
               <a:ext uri="{FF2B5EF4-FFF2-40B4-BE49-F238E27FC236}">
-                <a16:creationId xmlns:a16="http://schemas.microsoft.com/office/drawing/2014/main" id="{2D883489-F57F-462A-80E7-DF0F108F59FB}"/>
+                <a16:creationId xmlns:a16="http://schemas.microsoft.com/office/drawing/2014/main" id="{CBB8BCC4-6C21-458E-B46D-620D72431684}"/>
               </a:ext>
             </a:extLst>
           </p:cNvPr>
@@ -14997,7 +14997,7 @@
           <p:cNvPr id="8" name="">
             <a:extLst xmlns:a="http://schemas.openxmlformats.org/drawingml/2006/main">
               <a:ext uri="{FF2B5EF4-FFF2-40B4-BE49-F238E27FC236}">
-                <a16:creationId xmlns:a16="http://schemas.microsoft.com/office/drawing/2014/main" id="{0A57152F-0E25-497F-8364-85E8687E0E90}"/>
+                <a16:creationId xmlns:a16="http://schemas.microsoft.com/office/drawing/2014/main" id="{276C38A9-ED63-451F-A164-E4F715A40E64}"/>
               </a:ext>
             </a:extLst>
           </p:cNvPr>
@@ -15035,14 +15035,14 @@
             <a:pPr algn="l">
               <a:defRPr sz="2400" b="0">
                 <a:solidFill>
-                  <a:srgbClr val="0E1B3E"/>
+                  <a:srgbClr val="070F26"/>
                 </a:solidFill>
               </a:defRPr>
             </a:pPr>
             <a:r>
               <a:rPr sz="2400" b="0">
                 <a:solidFill>
-                  <a:srgbClr val="0E1B3E"/>
+                  <a:srgbClr val="070F26"/>
                 </a:solidFill>
               </a:rPr>
               <a:t>WHERE vs HAVING</a:t>
@@ -15055,7 +15055,7 @@
           <p:cNvPr id="9" name="">
             <a:extLst xmlns:a="http://schemas.openxmlformats.org/drawingml/2006/main">
               <a:ext uri="{FF2B5EF4-FFF2-40B4-BE49-F238E27FC236}">
-                <a16:creationId xmlns:a16="http://schemas.microsoft.com/office/drawing/2014/main" id="{3B702BE9-8239-403E-9687-8CD7342F90E4}"/>
+                <a16:creationId xmlns:a16="http://schemas.microsoft.com/office/drawing/2014/main" id="{BF7ED50A-38DA-4FAC-8CAD-6FB4380E7D1B}"/>
               </a:ext>
             </a:extLst>
           </p:cNvPr>
@@ -15113,7 +15113,7 @@
           <p:cNvPr id="10" name="">
             <a:extLst xmlns:a="http://schemas.openxmlformats.org/drawingml/2006/main">
               <a:ext uri="{FF2B5EF4-FFF2-40B4-BE49-F238E27FC236}">
-                <a16:creationId xmlns:a16="http://schemas.microsoft.com/office/drawing/2014/main" id="{DA56468C-346A-412C-B373-6B209FB121E2}"/>
+                <a16:creationId xmlns:a16="http://schemas.microsoft.com/office/drawing/2014/main" id="{AD8B8DD3-1CCC-41DA-AE8A-199BC10AEC2C}"/>
               </a:ext>
             </a:extLst>
           </p:cNvPr>
@@ -15146,7 +15146,7 @@
           <p:cNvPr id="11" name="">
             <a:extLst xmlns:a="http://schemas.openxmlformats.org/drawingml/2006/main">
               <a:ext uri="{FF2B5EF4-FFF2-40B4-BE49-F238E27FC236}">
-                <a16:creationId xmlns:a16="http://schemas.microsoft.com/office/drawing/2014/main" id="{8116DFD7-83D1-4B02-92C2-1D37E28A0114}"/>
+                <a16:creationId xmlns:a16="http://schemas.microsoft.com/office/drawing/2014/main" id="{BDA2B4F6-85CB-427A-91C3-D5DC1D4410B3}"/>
               </a:ext>
             </a:extLst>
           </p:cNvPr>
@@ -15181,7 +15181,7 @@
           <p:cNvPr id="12" name="">
             <a:extLst xmlns:a="http://schemas.openxmlformats.org/drawingml/2006/main">
               <a:ext uri="{FF2B5EF4-FFF2-40B4-BE49-F238E27FC236}">
-                <a16:creationId xmlns:a16="http://schemas.microsoft.com/office/drawing/2014/main" id="{CACB2F5D-6D01-44A3-AA9F-DDF2F5837B0F}"/>
+                <a16:creationId xmlns:a16="http://schemas.microsoft.com/office/drawing/2014/main" id="{9EF99D0E-2E4A-4F17-94B5-12C99163A245}"/>
               </a:ext>
             </a:extLst>
           </p:cNvPr>
@@ -15239,7 +15239,7 @@
           <p:cNvPr id="13" name="">
             <a:extLst xmlns:a="http://schemas.openxmlformats.org/drawingml/2006/main">
               <a:ext uri="{FF2B5EF4-FFF2-40B4-BE49-F238E27FC236}">
-                <a16:creationId xmlns:a16="http://schemas.microsoft.com/office/drawing/2014/main" id="{A97BB5FF-B422-4CFE-A296-80CF1B4BF7DE}"/>
+                <a16:creationId xmlns:a16="http://schemas.microsoft.com/office/drawing/2014/main" id="{F510C585-4A00-471D-882D-A1858D1AFE9A}"/>
               </a:ext>
             </a:extLst>
           </p:cNvPr>
@@ -15399,7 +15399,7 @@
           <p:cNvPr id="14" name="">
             <a:extLst xmlns:a="http://schemas.openxmlformats.org/drawingml/2006/main">
               <a:ext uri="{FF2B5EF4-FFF2-40B4-BE49-F238E27FC236}">
-                <a16:creationId xmlns:a16="http://schemas.microsoft.com/office/drawing/2014/main" id="{DAFFD02C-78DE-429A-89ED-69C9A57CF355}"/>
+                <a16:creationId xmlns:a16="http://schemas.microsoft.com/office/drawing/2014/main" id="{CCDEFAD9-E44F-42B7-8407-7C718DC91E71}"/>
               </a:ext>
             </a:extLst>
           </p:cNvPr>
@@ -15432,7 +15432,7 @@
           <p:cNvPr id="15" name="">
             <a:extLst xmlns:a="http://schemas.openxmlformats.org/drawingml/2006/main">
               <a:ext uri="{FF2B5EF4-FFF2-40B4-BE49-F238E27FC236}">
-                <a16:creationId xmlns:a16="http://schemas.microsoft.com/office/drawing/2014/main" id="{4D4766EC-505F-428F-AF82-746DA92E2DEF}"/>
+                <a16:creationId xmlns:a16="http://schemas.microsoft.com/office/drawing/2014/main" id="{C5842DC3-6456-44F4-BFBF-2F55764394D7}"/>
               </a:ext>
             </a:extLst>
           </p:cNvPr>
@@ -15467,7 +15467,7 @@
           <p:cNvPr id="16" name="">
             <a:extLst xmlns:a="http://schemas.openxmlformats.org/drawingml/2006/main">
               <a:ext uri="{FF2B5EF4-FFF2-40B4-BE49-F238E27FC236}">
-                <a16:creationId xmlns:a16="http://schemas.microsoft.com/office/drawing/2014/main" id="{7C4C846B-BF0C-402A-BAEE-1696B75D4643}"/>
+                <a16:creationId xmlns:a16="http://schemas.microsoft.com/office/drawing/2014/main" id="{510F96FD-1DE8-43BB-8F8E-9D26228EB395}"/>
               </a:ext>
             </a:extLst>
           </p:cNvPr>
@@ -15525,7 +15525,7 @@
           <p:cNvPr id="17" name="">
             <a:extLst xmlns:a="http://schemas.openxmlformats.org/drawingml/2006/main">
               <a:ext uri="{FF2B5EF4-FFF2-40B4-BE49-F238E27FC236}">
-                <a16:creationId xmlns:a16="http://schemas.microsoft.com/office/drawing/2014/main" id="{488E70BD-28CB-466E-97E7-AA52E802BE61}"/>
+                <a16:creationId xmlns:a16="http://schemas.microsoft.com/office/drawing/2014/main" id="{7DC9D066-704A-43AB-BF94-EA2EC97485C7}"/>
               </a:ext>
             </a:extLst>
           </p:cNvPr>
@@ -15683,7 +15683,7 @@
     </p:spTree>
     <p:extLst>
       <p:ext uri="{BB962C8B-B14F-4D97-AF65-F5344CB8AC3E}">
-        <p14:creationId xmlns:p14="http://schemas.microsoft.com/office/powerpoint/2010/main" val="1661356892"/>
+        <p14:creationId xmlns:p14="http://schemas.microsoft.com/office/powerpoint/2010/main" val="441468585"/>
       </p:ext>
     </p:extLst>
   </p:cSld>
@@ -15714,7 +15714,7 @@
           <p:cNvPr id="1" name="">
             <a:extLst xmlns:a="http://schemas.openxmlformats.org/drawingml/2006/main">
               <a:ext uri="{FF2B5EF4-FFF2-40B4-BE49-F238E27FC236}">
-                <a16:creationId xmlns:a16="http://schemas.microsoft.com/office/drawing/2014/main" id="{829B5A18-356A-4B74-81AC-820AB0ECF87B}"/>
+                <a16:creationId xmlns:a16="http://schemas.microsoft.com/office/drawing/2014/main" id="{9AB95779-2B85-42D7-B89F-A1F306E38BA6}"/>
               </a:ext>
             </a:extLst>
           </p:cNvPr>
@@ -15753,7 +15753,7 @@
           <p:nvPr/>
         </p:nvPicPr>
         <p:blipFill>
-          <a:blip xmlns:r="http://schemas.openxmlformats.org/officeDocument/2006/relationships" xmlns:a="http://schemas.openxmlformats.org/drawingml/2006/main" r:embed="Rb8b4e46ccaa74655"/>
+          <a:blip xmlns:r="http://schemas.openxmlformats.org/officeDocument/2006/relationships" xmlns:a="http://schemas.openxmlformats.org/drawingml/2006/main" r:embed="R1a1fc6605d61476d"/>
           <a:stretch xmlns:a="http://schemas.openxmlformats.org/drawingml/2006/main"/>
         </p:blipFill>
         <p:spPr>
@@ -15771,7 +15771,7 @@
           <p:cNvPr id="3" name="">
             <a:extLst xmlns:a="http://schemas.openxmlformats.org/drawingml/2006/main">
               <a:ext uri="{FF2B5EF4-FFF2-40B4-BE49-F238E27FC236}">
-                <a16:creationId xmlns:a16="http://schemas.microsoft.com/office/drawing/2014/main" id="{A2890FB4-3439-4F75-A708-D4EF4C6B54B9}"/>
+                <a16:creationId xmlns:a16="http://schemas.microsoft.com/office/drawing/2014/main" id="{882F9CF0-1768-4699-9C8C-8C512502245C}"/>
               </a:ext>
             </a:extLst>
           </p:cNvPr>
@@ -15809,14 +15809,14 @@
             <a:pPr algn="r">
               <a:defRPr sz="825" b="1">
                 <a:solidFill>
-                  <a:srgbClr val="0E1B3E"/>
+                  <a:srgbClr val="070F26"/>
                 </a:solidFill>
               </a:defRPr>
             </a:pPr>
             <a:r>
               <a:rPr sz="825" b="1">
                 <a:solidFill>
-                  <a:srgbClr val="0E1B3E"/>
+                  <a:srgbClr val="070F26"/>
                 </a:solidFill>
               </a:rPr>
               <a:t>NTT DATA UNIVERSITY</a:t>
@@ -15829,7 +15829,7 @@
           <p:cNvPr id="4" name="">
             <a:extLst xmlns:a="http://schemas.openxmlformats.org/drawingml/2006/main">
               <a:ext uri="{FF2B5EF4-FFF2-40B4-BE49-F238E27FC236}">
-                <a16:creationId xmlns:a16="http://schemas.microsoft.com/office/drawing/2014/main" id="{E481A162-D15F-4BAE-9F47-FD0B6F63E30B}"/>
+                <a16:creationId xmlns:a16="http://schemas.microsoft.com/office/drawing/2014/main" id="{B22B726B-8B9B-4DB8-8AAE-2C13D3796FB9}"/>
               </a:ext>
             </a:extLst>
           </p:cNvPr>
@@ -15887,7 +15887,7 @@
           <p:cNvPr id="5" name="">
             <a:extLst xmlns:a="http://schemas.openxmlformats.org/drawingml/2006/main">
               <a:ext uri="{FF2B5EF4-FFF2-40B4-BE49-F238E27FC236}">
-                <a16:creationId xmlns:a16="http://schemas.microsoft.com/office/drawing/2014/main" id="{667089DB-0B59-404C-9505-389EB109B6C4}"/>
+                <a16:creationId xmlns:a16="http://schemas.microsoft.com/office/drawing/2014/main" id="{6D74C137-CFB8-46E7-A281-A983A8C5EAF6}"/>
               </a:ext>
             </a:extLst>
           </p:cNvPr>
@@ -15945,7 +15945,7 @@
           <p:cNvPr id="6" name="">
             <a:extLst xmlns:a="http://schemas.openxmlformats.org/drawingml/2006/main">
               <a:ext uri="{FF2B5EF4-FFF2-40B4-BE49-F238E27FC236}">
-                <a16:creationId xmlns:a16="http://schemas.microsoft.com/office/drawing/2014/main" id="{8871266C-013D-4E0D-BB3B-3E47FEB3BB34}"/>
+                <a16:creationId xmlns:a16="http://schemas.microsoft.com/office/drawing/2014/main" id="{12BA4C74-0997-4B3F-B70B-60B8752070E0}"/>
               </a:ext>
             </a:extLst>
           </p:cNvPr>
@@ -15983,14 +15983,14 @@
             <a:pPr algn="r">
               <a:defRPr sz="675" b="1">
                 <a:solidFill>
-                  <a:srgbClr val="0E1B3E"/>
+                  <a:srgbClr val="070F26"/>
                 </a:solidFill>
               </a:defRPr>
             </a:pPr>
             <a:r>
               <a:rPr sz="675" b="1">
                 <a:solidFill>
-                  <a:srgbClr val="0E1B3E"/>
+                  <a:srgbClr val="070F26"/>
                 </a:solidFill>
               </a:rPr>
               <a:t>NTT DATA UNIVERSITY</a:t>
@@ -16003,7 +16003,7 @@
           <p:cNvPr id="7" name="">
             <a:extLst xmlns:a="http://schemas.openxmlformats.org/drawingml/2006/main">
               <a:ext uri="{FF2B5EF4-FFF2-40B4-BE49-F238E27FC236}">
-                <a16:creationId xmlns:a16="http://schemas.microsoft.com/office/drawing/2014/main" id="{6EDF6C4C-40DD-4F6F-AD91-59E86C1AC11C}"/>
+                <a16:creationId xmlns:a16="http://schemas.microsoft.com/office/drawing/2014/main" id="{AF60F5E1-D709-4430-808B-546095C9613E}"/>
               </a:ext>
             </a:extLst>
           </p:cNvPr>
@@ -16061,7 +16061,7 @@
           <p:cNvPr id="8" name="">
             <a:extLst xmlns:a="http://schemas.openxmlformats.org/drawingml/2006/main">
               <a:ext uri="{FF2B5EF4-FFF2-40B4-BE49-F238E27FC236}">
-                <a16:creationId xmlns:a16="http://schemas.microsoft.com/office/drawing/2014/main" id="{A8251821-7710-4038-AEA5-AD09F5828D5F}"/>
+                <a16:creationId xmlns:a16="http://schemas.microsoft.com/office/drawing/2014/main" id="{01349F1E-BBD7-418F-97FA-796E04EACBF6}"/>
               </a:ext>
             </a:extLst>
           </p:cNvPr>
@@ -16099,14 +16099,14 @@
             <a:pPr algn="l">
               <a:defRPr sz="2400" b="0">
                 <a:solidFill>
-                  <a:srgbClr val="0E1B3E"/>
+                  <a:srgbClr val="070F26"/>
                 </a:solidFill>
               </a:defRPr>
             </a:pPr>
             <a:r>
               <a:rPr sz="2400" b="0">
                 <a:solidFill>
-                  <a:srgbClr val="0E1B3E"/>
+                  <a:srgbClr val="070F26"/>
                 </a:solidFill>
               </a:rPr>
               <a:t>CTE vs Subquery</a:t>
@@ -16119,7 +16119,7 @@
           <p:cNvPr id="9" name="">
             <a:extLst xmlns:a="http://schemas.openxmlformats.org/drawingml/2006/main">
               <a:ext uri="{FF2B5EF4-FFF2-40B4-BE49-F238E27FC236}">
-                <a16:creationId xmlns:a16="http://schemas.microsoft.com/office/drawing/2014/main" id="{6BE992FE-9E94-4A58-97B1-99FF6816FB33}"/>
+                <a16:creationId xmlns:a16="http://schemas.microsoft.com/office/drawing/2014/main" id="{540027F9-242A-42EE-BCA5-58521CA2D2B3}"/>
               </a:ext>
             </a:extLst>
           </p:cNvPr>
@@ -16177,7 +16177,7 @@
           <p:cNvPr id="10" name="">
             <a:extLst xmlns:a="http://schemas.openxmlformats.org/drawingml/2006/main">
               <a:ext uri="{FF2B5EF4-FFF2-40B4-BE49-F238E27FC236}">
-                <a16:creationId xmlns:a16="http://schemas.microsoft.com/office/drawing/2014/main" id="{92CEDA15-94F6-49D4-8F58-FCF4EA091D1B}"/>
+                <a16:creationId xmlns:a16="http://schemas.microsoft.com/office/drawing/2014/main" id="{BA6ABCD0-6972-4CD5-9307-290799DAC6D9}"/>
               </a:ext>
             </a:extLst>
           </p:cNvPr>
@@ -16210,7 +16210,7 @@
           <p:cNvPr id="11" name="">
             <a:extLst xmlns:a="http://schemas.openxmlformats.org/drawingml/2006/main">
               <a:ext uri="{FF2B5EF4-FFF2-40B4-BE49-F238E27FC236}">
-                <a16:creationId xmlns:a16="http://schemas.microsoft.com/office/drawing/2014/main" id="{C0BC501F-398A-42FE-865A-C1B02E0026D1}"/>
+                <a16:creationId xmlns:a16="http://schemas.microsoft.com/office/drawing/2014/main" id="{39BABC5D-70D2-45E6-8C14-DA2456C208A9}"/>
               </a:ext>
             </a:extLst>
           </p:cNvPr>
@@ -16245,7 +16245,7 @@
           <p:cNvPr id="12" name="">
             <a:extLst xmlns:a="http://schemas.openxmlformats.org/drawingml/2006/main">
               <a:ext uri="{FF2B5EF4-FFF2-40B4-BE49-F238E27FC236}">
-                <a16:creationId xmlns:a16="http://schemas.microsoft.com/office/drawing/2014/main" id="{F3B22BC9-D6E9-44F9-907E-054BB2DA141E}"/>
+                <a16:creationId xmlns:a16="http://schemas.microsoft.com/office/drawing/2014/main" id="{27A253D8-1CAB-432A-A898-F5B423047A03}"/>
               </a:ext>
             </a:extLst>
           </p:cNvPr>
@@ -16303,7 +16303,7 @@
           <p:cNvPr id="13" name="">
             <a:extLst xmlns:a="http://schemas.openxmlformats.org/drawingml/2006/main">
               <a:ext uri="{FF2B5EF4-FFF2-40B4-BE49-F238E27FC236}">
-                <a16:creationId xmlns:a16="http://schemas.microsoft.com/office/drawing/2014/main" id="{B4AAAF4C-2C58-4A95-878F-FE0288D01D3D}"/>
+                <a16:creationId xmlns:a16="http://schemas.microsoft.com/office/drawing/2014/main" id="{1946AE18-DB51-4FF4-9866-BCDE0D5A6ABE}"/>
               </a:ext>
             </a:extLst>
           </p:cNvPr>
@@ -16463,7 +16463,7 @@
           <p:cNvPr id="14" name="">
             <a:extLst xmlns:a="http://schemas.openxmlformats.org/drawingml/2006/main">
               <a:ext uri="{FF2B5EF4-FFF2-40B4-BE49-F238E27FC236}">
-                <a16:creationId xmlns:a16="http://schemas.microsoft.com/office/drawing/2014/main" id="{7234874D-E93A-41F5-A5F8-2BA3C06113B9}"/>
+                <a16:creationId xmlns:a16="http://schemas.microsoft.com/office/drawing/2014/main" id="{CDC78EC8-3169-4C53-AF07-F5929AC60F55}"/>
               </a:ext>
             </a:extLst>
           </p:cNvPr>
@@ -16496,7 +16496,7 @@
           <p:cNvPr id="15" name="">
             <a:extLst xmlns:a="http://schemas.openxmlformats.org/drawingml/2006/main">
               <a:ext uri="{FF2B5EF4-FFF2-40B4-BE49-F238E27FC236}">
-                <a16:creationId xmlns:a16="http://schemas.microsoft.com/office/drawing/2014/main" id="{E5953962-5091-4C33-B7D9-4A1682B81ABD}"/>
+                <a16:creationId xmlns:a16="http://schemas.microsoft.com/office/drawing/2014/main" id="{61D9001D-2FBC-4CCA-B0DB-3D1A4B6373AB}"/>
               </a:ext>
             </a:extLst>
           </p:cNvPr>
@@ -16531,7 +16531,7 @@
           <p:cNvPr id="16" name="">
             <a:extLst xmlns:a="http://schemas.openxmlformats.org/drawingml/2006/main">
               <a:ext uri="{FF2B5EF4-FFF2-40B4-BE49-F238E27FC236}">
-                <a16:creationId xmlns:a16="http://schemas.microsoft.com/office/drawing/2014/main" id="{868C3DD6-9D9A-47B4-AFC0-34645D624792}"/>
+                <a16:creationId xmlns:a16="http://schemas.microsoft.com/office/drawing/2014/main" id="{60ADD201-74C5-4117-BEA5-A59797D6E84F}"/>
               </a:ext>
             </a:extLst>
           </p:cNvPr>
@@ -16589,7 +16589,7 @@
           <p:cNvPr id="17" name="">
             <a:extLst xmlns:a="http://schemas.openxmlformats.org/drawingml/2006/main">
               <a:ext uri="{FF2B5EF4-FFF2-40B4-BE49-F238E27FC236}">
-                <a16:creationId xmlns:a16="http://schemas.microsoft.com/office/drawing/2014/main" id="{D0E0C25C-1A52-4C63-A990-3F9AF43F85AA}"/>
+                <a16:creationId xmlns:a16="http://schemas.microsoft.com/office/drawing/2014/main" id="{4C45ECB9-316E-44AE-8D4D-47BB2ED0AEAD}"/>
               </a:ext>
             </a:extLst>
           </p:cNvPr>
@@ -16798,7 +16798,7 @@
     </p:spTree>
     <p:extLst>
       <p:ext uri="{BB962C8B-B14F-4D97-AF65-F5344CB8AC3E}">
-        <p14:creationId xmlns:p14="http://schemas.microsoft.com/office/powerpoint/2010/main" val="431517939"/>
+        <p14:creationId xmlns:p14="http://schemas.microsoft.com/office/powerpoint/2010/main" val="337309089"/>
       </p:ext>
     </p:extLst>
   </p:cSld>
@@ -16829,7 +16829,7 @@
           <p:cNvPr id="1" name="">
             <a:extLst xmlns:a="http://schemas.openxmlformats.org/drawingml/2006/main">
               <a:ext uri="{FF2B5EF4-FFF2-40B4-BE49-F238E27FC236}">
-                <a16:creationId xmlns:a16="http://schemas.microsoft.com/office/drawing/2014/main" id="{DB77D876-4907-477F-9D24-F9EF148A75A2}"/>
+                <a16:creationId xmlns:a16="http://schemas.microsoft.com/office/drawing/2014/main" id="{34A3C383-60A8-4C2E-9614-4E8FF0692CC6}"/>
               </a:ext>
             </a:extLst>
           </p:cNvPr>
@@ -16868,7 +16868,7 @@
           <p:nvPr/>
         </p:nvPicPr>
         <p:blipFill>
-          <a:blip xmlns:r="http://schemas.openxmlformats.org/officeDocument/2006/relationships" xmlns:a="http://schemas.openxmlformats.org/drawingml/2006/main" r:embed="Rdd0fe1b035c2429a"/>
+          <a:blip xmlns:r="http://schemas.openxmlformats.org/officeDocument/2006/relationships" xmlns:a="http://schemas.openxmlformats.org/drawingml/2006/main" r:embed="R2c721e2dc0ab4542"/>
           <a:stretch xmlns:a="http://schemas.openxmlformats.org/drawingml/2006/main"/>
         </p:blipFill>
         <p:spPr>
@@ -16886,7 +16886,7 @@
           <p:cNvPr id="3" name="">
             <a:extLst xmlns:a="http://schemas.openxmlformats.org/drawingml/2006/main">
               <a:ext uri="{FF2B5EF4-FFF2-40B4-BE49-F238E27FC236}">
-                <a16:creationId xmlns:a16="http://schemas.microsoft.com/office/drawing/2014/main" id="{41AF09FE-2854-4E26-BB9D-637750A3704B}"/>
+                <a16:creationId xmlns:a16="http://schemas.microsoft.com/office/drawing/2014/main" id="{D588F52D-2284-4152-8A6F-6745402E035D}"/>
               </a:ext>
             </a:extLst>
           </p:cNvPr>
@@ -16924,14 +16924,14 @@
             <a:pPr algn="r">
               <a:defRPr sz="825" b="1">
                 <a:solidFill>
-                  <a:srgbClr val="0E1B3E"/>
+                  <a:srgbClr val="070F26"/>
                 </a:solidFill>
               </a:defRPr>
             </a:pPr>
             <a:r>
               <a:rPr sz="825" b="1">
                 <a:solidFill>
-                  <a:srgbClr val="0E1B3E"/>
+                  <a:srgbClr val="070F26"/>
                 </a:solidFill>
               </a:rPr>
               <a:t>NTT DATA UNIVERSITY</a:t>
@@ -16944,7 +16944,7 @@
           <p:cNvPr id="4" name="">
             <a:extLst xmlns:a="http://schemas.openxmlformats.org/drawingml/2006/main">
               <a:ext uri="{FF2B5EF4-FFF2-40B4-BE49-F238E27FC236}">
-                <a16:creationId xmlns:a16="http://schemas.microsoft.com/office/drawing/2014/main" id="{DAD569D0-2EC0-4DA5-A3FD-E4E9DC285075}"/>
+                <a16:creationId xmlns:a16="http://schemas.microsoft.com/office/drawing/2014/main" id="{94130C3B-C8D9-4212-8508-3EB073A8E3C6}"/>
               </a:ext>
             </a:extLst>
           </p:cNvPr>
@@ -17002,7 +17002,7 @@
           <p:cNvPr id="5" name="">
             <a:extLst xmlns:a="http://schemas.openxmlformats.org/drawingml/2006/main">
               <a:ext uri="{FF2B5EF4-FFF2-40B4-BE49-F238E27FC236}">
-                <a16:creationId xmlns:a16="http://schemas.microsoft.com/office/drawing/2014/main" id="{918D659C-FFD5-46FA-8FD0-68AFFB848C59}"/>
+                <a16:creationId xmlns:a16="http://schemas.microsoft.com/office/drawing/2014/main" id="{5D0072F6-8D55-4979-89E1-D1E3B4042C5D}"/>
               </a:ext>
             </a:extLst>
           </p:cNvPr>
@@ -17060,7 +17060,7 @@
           <p:cNvPr id="6" name="">
             <a:extLst xmlns:a="http://schemas.openxmlformats.org/drawingml/2006/main">
               <a:ext uri="{FF2B5EF4-FFF2-40B4-BE49-F238E27FC236}">
-                <a16:creationId xmlns:a16="http://schemas.microsoft.com/office/drawing/2014/main" id="{14DF70E9-5096-4E28-8DE1-2465BFE5EE25}"/>
+                <a16:creationId xmlns:a16="http://schemas.microsoft.com/office/drawing/2014/main" id="{449CFB38-A798-43E1-B97D-8A15E383B0BD}"/>
               </a:ext>
             </a:extLst>
           </p:cNvPr>
@@ -17098,14 +17098,14 @@
             <a:pPr algn="r">
               <a:defRPr sz="675" b="1">
                 <a:solidFill>
-                  <a:srgbClr val="0E1B3E"/>
+                  <a:srgbClr val="070F26"/>
                 </a:solidFill>
               </a:defRPr>
             </a:pPr>
             <a:r>
               <a:rPr sz="675" b="1">
                 <a:solidFill>
-                  <a:srgbClr val="0E1B3E"/>
+                  <a:srgbClr val="070F26"/>
                 </a:solidFill>
               </a:rPr>
               <a:t>NTT DATA UNIVERSITY</a:t>
@@ -17118,7 +17118,7 @@
           <p:cNvPr id="7" name="">
             <a:extLst xmlns:a="http://schemas.openxmlformats.org/drawingml/2006/main">
               <a:ext uri="{FF2B5EF4-FFF2-40B4-BE49-F238E27FC236}">
-                <a16:creationId xmlns:a16="http://schemas.microsoft.com/office/drawing/2014/main" id="{44E83731-F48B-4CDA-8835-877BC86B23A4}"/>
+                <a16:creationId xmlns:a16="http://schemas.microsoft.com/office/drawing/2014/main" id="{BFC13EC4-773A-4FBF-A7C4-2C4BE4F54651}"/>
               </a:ext>
             </a:extLst>
           </p:cNvPr>
@@ -17176,7 +17176,7 @@
           <p:cNvPr id="8" name="">
             <a:extLst xmlns:a="http://schemas.openxmlformats.org/drawingml/2006/main">
               <a:ext uri="{FF2B5EF4-FFF2-40B4-BE49-F238E27FC236}">
-                <a16:creationId xmlns:a16="http://schemas.microsoft.com/office/drawing/2014/main" id="{8FCA8A6B-9998-44D5-A6FC-4013018401CA}"/>
+                <a16:creationId xmlns:a16="http://schemas.microsoft.com/office/drawing/2014/main" id="{356DDDA8-317E-49F8-8E90-8D0D15D0DF7B}"/>
               </a:ext>
             </a:extLst>
           </p:cNvPr>
@@ -17214,14 +17214,14 @@
             <a:pPr algn="l">
               <a:defRPr sz="2400" b="0">
                 <a:solidFill>
-                  <a:srgbClr val="0E1B3E"/>
+                  <a:srgbClr val="070F26"/>
                 </a:solidFill>
               </a:defRPr>
             </a:pPr>
             <a:r>
               <a:rPr sz="2400" b="0">
                 <a:solidFill>
-                  <a:srgbClr val="0E1B3E"/>
+                  <a:srgbClr val="070F26"/>
                 </a:solidFill>
               </a:rPr>
               <a:t>LEFT JOIN — Encontrar o que não existe</a:t>
@@ -17234,7 +17234,7 @@
           <p:cNvPr id="9" name="">
             <a:extLst xmlns:a="http://schemas.openxmlformats.org/drawingml/2006/main">
               <a:ext uri="{FF2B5EF4-FFF2-40B4-BE49-F238E27FC236}">
-                <a16:creationId xmlns:a16="http://schemas.microsoft.com/office/drawing/2014/main" id="{9BDC8458-5888-4FB7-8878-ECF28AC671AE}"/>
+                <a16:creationId xmlns:a16="http://schemas.microsoft.com/office/drawing/2014/main" id="{BDEF5F36-3932-471B-A4D6-C75CDA7A2B23}"/>
               </a:ext>
             </a:extLst>
           </p:cNvPr>
@@ -17292,7 +17292,7 @@
           <p:cNvPr id="10" name="">
             <a:extLst xmlns:a="http://schemas.openxmlformats.org/drawingml/2006/main">
               <a:ext uri="{FF2B5EF4-FFF2-40B4-BE49-F238E27FC236}">
-                <a16:creationId xmlns:a16="http://schemas.microsoft.com/office/drawing/2014/main" id="{615B879E-1380-4A37-BBEC-4372537F67F9}"/>
+                <a16:creationId xmlns:a16="http://schemas.microsoft.com/office/drawing/2014/main" id="{CF5E8C43-2F53-4539-9E4A-2AFF18B4046C}"/>
               </a:ext>
             </a:extLst>
           </p:cNvPr>
@@ -17325,7 +17325,7 @@
           <p:cNvPr id="11" name="">
             <a:extLst xmlns:a="http://schemas.openxmlformats.org/drawingml/2006/main">
               <a:ext uri="{FF2B5EF4-FFF2-40B4-BE49-F238E27FC236}">
-                <a16:creationId xmlns:a16="http://schemas.microsoft.com/office/drawing/2014/main" id="{9DC9DE3D-A2B2-4E6C-9FEA-8AF39812D44E}"/>
+                <a16:creationId xmlns:a16="http://schemas.microsoft.com/office/drawing/2014/main" id="{79AB561B-6119-44BD-9767-C1FAC35F35AC}"/>
               </a:ext>
             </a:extLst>
           </p:cNvPr>
@@ -17360,7 +17360,7 @@
           <p:cNvPr id="12" name="">
             <a:extLst xmlns:a="http://schemas.openxmlformats.org/drawingml/2006/main">
               <a:ext uri="{FF2B5EF4-FFF2-40B4-BE49-F238E27FC236}">
-                <a16:creationId xmlns:a16="http://schemas.microsoft.com/office/drawing/2014/main" id="{EF9FD016-7471-4F2B-87D1-788E55C31EEE}"/>
+                <a16:creationId xmlns:a16="http://schemas.microsoft.com/office/drawing/2014/main" id="{11FCBF70-E68F-4F4A-B787-DEE5A9BA8081}"/>
               </a:ext>
             </a:extLst>
           </p:cNvPr>
@@ -17418,7 +17418,7 @@
           <p:cNvPr id="13" name="">
             <a:extLst xmlns:a="http://schemas.openxmlformats.org/drawingml/2006/main">
               <a:ext uri="{FF2B5EF4-FFF2-40B4-BE49-F238E27FC236}">
-                <a16:creationId xmlns:a16="http://schemas.microsoft.com/office/drawing/2014/main" id="{0234A7CD-8BCE-476D-89A1-1B7AE719D570}"/>
+                <a16:creationId xmlns:a16="http://schemas.microsoft.com/office/drawing/2014/main" id="{E5BA6B25-4D5C-4307-A138-59499B933D5E}"/>
               </a:ext>
             </a:extLst>
           </p:cNvPr>
@@ -17583,7 +17583,7 @@
           <p:cNvPr id="14" name="">
             <a:extLst xmlns:a="http://schemas.openxmlformats.org/drawingml/2006/main">
               <a:ext uri="{FF2B5EF4-FFF2-40B4-BE49-F238E27FC236}">
-                <a16:creationId xmlns:a16="http://schemas.microsoft.com/office/drawing/2014/main" id="{9658DFA4-1A7A-4B96-B494-AA2292680838}"/>
+                <a16:creationId xmlns:a16="http://schemas.microsoft.com/office/drawing/2014/main" id="{DB15214A-86AB-4597-923B-A8E350D26BBB}"/>
               </a:ext>
             </a:extLst>
           </p:cNvPr>
@@ -17616,7 +17616,7 @@
           <p:cNvPr id="15" name="">
             <a:extLst xmlns:a="http://schemas.openxmlformats.org/drawingml/2006/main">
               <a:ext uri="{FF2B5EF4-FFF2-40B4-BE49-F238E27FC236}">
-                <a16:creationId xmlns:a16="http://schemas.microsoft.com/office/drawing/2014/main" id="{59714CA0-B170-4277-9D85-0C17C052CE50}"/>
+                <a16:creationId xmlns:a16="http://schemas.microsoft.com/office/drawing/2014/main" id="{949DF298-C023-4127-8FFA-CEF7E4D6F0C0}"/>
               </a:ext>
             </a:extLst>
           </p:cNvPr>
@@ -17651,7 +17651,7 @@
           <p:cNvPr id="16" name="">
             <a:extLst xmlns:a="http://schemas.openxmlformats.org/drawingml/2006/main">
               <a:ext uri="{FF2B5EF4-FFF2-40B4-BE49-F238E27FC236}">
-                <a16:creationId xmlns:a16="http://schemas.microsoft.com/office/drawing/2014/main" id="{B6C19B64-2C7B-4202-935C-A5A7F869105F}"/>
+                <a16:creationId xmlns:a16="http://schemas.microsoft.com/office/drawing/2014/main" id="{0D3D4E07-216F-4178-9A91-194FD4EDB337}"/>
               </a:ext>
             </a:extLst>
           </p:cNvPr>
@@ -17709,7 +17709,7 @@
           <p:cNvPr id="17" name="">
             <a:extLst xmlns:a="http://schemas.openxmlformats.org/drawingml/2006/main">
               <a:ext uri="{FF2B5EF4-FFF2-40B4-BE49-F238E27FC236}">
-                <a16:creationId xmlns:a16="http://schemas.microsoft.com/office/drawing/2014/main" id="{830997FA-9087-445F-9388-AC09F1DB419F}"/>
+                <a16:creationId xmlns:a16="http://schemas.microsoft.com/office/drawing/2014/main" id="{4CB63A46-1A31-48F6-AA65-7E9EFE8CE754}"/>
               </a:ext>
             </a:extLst>
           </p:cNvPr>
@@ -17877,7 +17877,7 @@
     </p:spTree>
     <p:extLst>
       <p:ext uri="{BB962C8B-B14F-4D97-AF65-F5344CB8AC3E}">
-        <p14:creationId xmlns:p14="http://schemas.microsoft.com/office/powerpoint/2010/main" val="1263975523"/>
+        <p14:creationId xmlns:p14="http://schemas.microsoft.com/office/powerpoint/2010/main" val="231478022"/>
       </p:ext>
     </p:extLst>
   </p:cSld>
@@ -17908,7 +17908,7 @@
           <p:cNvPr id="1" name="">
             <a:extLst xmlns:a="http://schemas.openxmlformats.org/drawingml/2006/main">
               <a:ext uri="{FF2B5EF4-FFF2-40B4-BE49-F238E27FC236}">
-                <a16:creationId xmlns:a16="http://schemas.microsoft.com/office/drawing/2014/main" id="{5E3891F6-4CEA-4AD3-A54D-A6F5FCAB2A35}"/>
+                <a16:creationId xmlns:a16="http://schemas.microsoft.com/office/drawing/2014/main" id="{CEE4B404-77AC-4DA2-99CF-14DDB3DA5B8A}"/>
               </a:ext>
             </a:extLst>
           </p:cNvPr>
@@ -17947,7 +17947,7 @@
           <p:nvPr/>
         </p:nvPicPr>
         <p:blipFill>
-          <a:blip xmlns:r="http://schemas.openxmlformats.org/officeDocument/2006/relationships" xmlns:a="http://schemas.openxmlformats.org/drawingml/2006/main" r:embed="R4237140acb0742bb"/>
+          <a:blip xmlns:r="http://schemas.openxmlformats.org/officeDocument/2006/relationships" xmlns:a="http://schemas.openxmlformats.org/drawingml/2006/main" r:embed="R2300dedcbfba49ca"/>
           <a:stretch xmlns:a="http://schemas.openxmlformats.org/drawingml/2006/main"/>
         </p:blipFill>
         <p:spPr>
@@ -17965,7 +17965,7 @@
           <p:cNvPr id="3" name="">
             <a:extLst xmlns:a="http://schemas.openxmlformats.org/drawingml/2006/main">
               <a:ext uri="{FF2B5EF4-FFF2-40B4-BE49-F238E27FC236}">
-                <a16:creationId xmlns:a16="http://schemas.microsoft.com/office/drawing/2014/main" id="{4544CBC3-9FF0-44F9-9130-85D59BFB4D7A}"/>
+                <a16:creationId xmlns:a16="http://schemas.microsoft.com/office/drawing/2014/main" id="{84E8BCB2-4A11-481A-B3C2-5DA3BE41512C}"/>
               </a:ext>
             </a:extLst>
           </p:cNvPr>
@@ -18003,14 +18003,14 @@
             <a:pPr algn="r">
               <a:defRPr sz="825" b="1">
                 <a:solidFill>
-                  <a:srgbClr val="0E1B3E"/>
+                  <a:srgbClr val="070F26"/>
                 </a:solidFill>
               </a:defRPr>
             </a:pPr>
             <a:r>
               <a:rPr sz="825" b="1">
                 <a:solidFill>
-                  <a:srgbClr val="0E1B3E"/>
+                  <a:srgbClr val="070F26"/>
                 </a:solidFill>
               </a:rPr>
               <a:t>NTT DATA UNIVERSITY</a:t>
@@ -18023,7 +18023,7 @@
           <p:cNvPr id="4" name="">
             <a:extLst xmlns:a="http://schemas.openxmlformats.org/drawingml/2006/main">
               <a:ext uri="{FF2B5EF4-FFF2-40B4-BE49-F238E27FC236}">
-                <a16:creationId xmlns:a16="http://schemas.microsoft.com/office/drawing/2014/main" id="{956B334A-E3ED-4656-A470-BC68AA432B16}"/>
+                <a16:creationId xmlns:a16="http://schemas.microsoft.com/office/drawing/2014/main" id="{6F58CF50-DAB3-4830-A82B-61D68EB50ED2}"/>
               </a:ext>
             </a:extLst>
           </p:cNvPr>
@@ -18081,7 +18081,7 @@
           <p:cNvPr id="5" name="">
             <a:extLst xmlns:a="http://schemas.openxmlformats.org/drawingml/2006/main">
               <a:ext uri="{FF2B5EF4-FFF2-40B4-BE49-F238E27FC236}">
-                <a16:creationId xmlns:a16="http://schemas.microsoft.com/office/drawing/2014/main" id="{43BD1CD0-E697-4356-8683-4F598357FD4F}"/>
+                <a16:creationId xmlns:a16="http://schemas.microsoft.com/office/drawing/2014/main" id="{E68C2E9F-4D77-4CFD-BD24-BC2C10E91D53}"/>
               </a:ext>
             </a:extLst>
           </p:cNvPr>
@@ -18139,7 +18139,7 @@
           <p:cNvPr id="6" name="">
             <a:extLst xmlns:a="http://schemas.openxmlformats.org/drawingml/2006/main">
               <a:ext uri="{FF2B5EF4-FFF2-40B4-BE49-F238E27FC236}">
-                <a16:creationId xmlns:a16="http://schemas.microsoft.com/office/drawing/2014/main" id="{50B3F1E6-CE05-474E-9998-BDD1149E7479}"/>
+                <a16:creationId xmlns:a16="http://schemas.microsoft.com/office/drawing/2014/main" id="{59C32927-2F10-45EA-9BFC-F5A04655AA8C}"/>
               </a:ext>
             </a:extLst>
           </p:cNvPr>
@@ -18177,14 +18177,14 @@
             <a:pPr algn="r">
               <a:defRPr sz="675" b="1">
                 <a:solidFill>
-                  <a:srgbClr val="0E1B3E"/>
+                  <a:srgbClr val="070F26"/>
                 </a:solidFill>
               </a:defRPr>
             </a:pPr>
             <a:r>
               <a:rPr sz="675" b="1">
                 <a:solidFill>
-                  <a:srgbClr val="0E1B3E"/>
+                  <a:srgbClr val="070F26"/>
                 </a:solidFill>
               </a:rPr>
               <a:t>NTT DATA UNIVERSITY</a:t>
@@ -18197,7 +18197,7 @@
           <p:cNvPr id="7" name="">
             <a:extLst xmlns:a="http://schemas.openxmlformats.org/drawingml/2006/main">
               <a:ext uri="{FF2B5EF4-FFF2-40B4-BE49-F238E27FC236}">
-                <a16:creationId xmlns:a16="http://schemas.microsoft.com/office/drawing/2014/main" id="{C91A754B-EA5D-441E-B1FD-A03FCF90C512}"/>
+                <a16:creationId xmlns:a16="http://schemas.microsoft.com/office/drawing/2014/main" id="{3829D60D-F429-4CA7-A653-1FEE2423FF25}"/>
               </a:ext>
             </a:extLst>
           </p:cNvPr>
@@ -18255,7 +18255,7 @@
           <p:cNvPr id="8" name="">
             <a:extLst xmlns:a="http://schemas.openxmlformats.org/drawingml/2006/main">
               <a:ext uri="{FF2B5EF4-FFF2-40B4-BE49-F238E27FC236}">
-                <a16:creationId xmlns:a16="http://schemas.microsoft.com/office/drawing/2014/main" id="{916A8609-1114-4DF3-A97C-C36DC6634B72}"/>
+                <a16:creationId xmlns:a16="http://schemas.microsoft.com/office/drawing/2014/main" id="{439863F7-DAA7-431C-9DA0-5011951CC163}"/>
               </a:ext>
             </a:extLst>
           </p:cNvPr>
@@ -18293,14 +18293,14 @@
             <a:pPr algn="l">
               <a:defRPr sz="2400" b="0">
                 <a:solidFill>
-                  <a:srgbClr val="0E1B3E"/>
+                  <a:srgbClr val="070F26"/>
                 </a:solidFill>
               </a:defRPr>
             </a:pPr>
             <a:r>
               <a:rPr sz="2400" b="0">
                 <a:solidFill>
-                  <a:srgbClr val="0E1B3E"/>
+                  <a:srgbClr val="070F26"/>
                 </a:solidFill>
               </a:rPr>
               <a:t>Datas no SQLite — strftime</a:t>
@@ -18313,7 +18313,7 @@
           <p:cNvPr id="9" name="">
             <a:extLst xmlns:a="http://schemas.openxmlformats.org/drawingml/2006/main">
               <a:ext uri="{FF2B5EF4-FFF2-40B4-BE49-F238E27FC236}">
-                <a16:creationId xmlns:a16="http://schemas.microsoft.com/office/drawing/2014/main" id="{0C7D9ECD-7DB7-4E89-A273-E5592E11B64A}"/>
+                <a16:creationId xmlns:a16="http://schemas.microsoft.com/office/drawing/2014/main" id="{50112D7B-5A39-4271-BD56-2B91AE74436A}"/>
               </a:ext>
             </a:extLst>
           </p:cNvPr>
@@ -18371,7 +18371,7 @@
           <p:cNvPr id="10" name="">
             <a:extLst xmlns:a="http://schemas.openxmlformats.org/drawingml/2006/main">
               <a:ext uri="{FF2B5EF4-FFF2-40B4-BE49-F238E27FC236}">
-                <a16:creationId xmlns:a16="http://schemas.microsoft.com/office/drawing/2014/main" id="{D51BE7AD-BCF6-41FE-98F2-69230FCB45DA}"/>
+                <a16:creationId xmlns:a16="http://schemas.microsoft.com/office/drawing/2014/main" id="{A96D1F24-02DD-43A9-B607-74F98EFA5D0F}"/>
               </a:ext>
             </a:extLst>
           </p:cNvPr>
@@ -18404,7 +18404,7 @@
           <p:cNvPr id="11" name="">
             <a:extLst xmlns:a="http://schemas.openxmlformats.org/drawingml/2006/main">
               <a:ext uri="{FF2B5EF4-FFF2-40B4-BE49-F238E27FC236}">
-                <a16:creationId xmlns:a16="http://schemas.microsoft.com/office/drawing/2014/main" id="{CF53E975-5409-4B95-8151-7F6DA96FDE23}"/>
+                <a16:creationId xmlns:a16="http://schemas.microsoft.com/office/drawing/2014/main" id="{64C0C318-427D-402F-8F29-3AE88F645C6C}"/>
               </a:ext>
             </a:extLst>
           </p:cNvPr>
@@ -18439,7 +18439,7 @@
           <p:cNvPr id="12" name="">
             <a:extLst xmlns:a="http://schemas.openxmlformats.org/drawingml/2006/main">
               <a:ext uri="{FF2B5EF4-FFF2-40B4-BE49-F238E27FC236}">
-                <a16:creationId xmlns:a16="http://schemas.microsoft.com/office/drawing/2014/main" id="{6F0C317C-5237-4C9B-8717-B6F947C3828D}"/>
+                <a16:creationId xmlns:a16="http://schemas.microsoft.com/office/drawing/2014/main" id="{603F1EF7-2315-40C7-8E1E-24442066965C}"/>
               </a:ext>
             </a:extLst>
           </p:cNvPr>
@@ -18497,7 +18497,7 @@
           <p:cNvPr id="13" name="">
             <a:extLst xmlns:a="http://schemas.openxmlformats.org/drawingml/2006/main">
               <a:ext uri="{FF2B5EF4-FFF2-40B4-BE49-F238E27FC236}">
-                <a16:creationId xmlns:a16="http://schemas.microsoft.com/office/drawing/2014/main" id="{4CD5F500-E713-45D5-9190-3C8A81583E0D}"/>
+                <a16:creationId xmlns:a16="http://schemas.microsoft.com/office/drawing/2014/main" id="{BE9831B1-3C68-402B-AA3E-144434A5F725}"/>
               </a:ext>
             </a:extLst>
           </p:cNvPr>
@@ -18640,7 +18640,7 @@
           <p:cNvPr id="14" name="">
             <a:extLst xmlns:a="http://schemas.openxmlformats.org/drawingml/2006/main">
               <a:ext uri="{FF2B5EF4-FFF2-40B4-BE49-F238E27FC236}">
-                <a16:creationId xmlns:a16="http://schemas.microsoft.com/office/drawing/2014/main" id="{9EE3A655-A80D-4883-9942-32C06EA7F55D}"/>
+                <a16:creationId xmlns:a16="http://schemas.microsoft.com/office/drawing/2014/main" id="{41E433DF-AD82-4D4D-ABAA-83DC09AF33E8}"/>
               </a:ext>
             </a:extLst>
           </p:cNvPr>
@@ -18673,7 +18673,7 @@
           <p:cNvPr id="15" name="">
             <a:extLst xmlns:a="http://schemas.openxmlformats.org/drawingml/2006/main">
               <a:ext uri="{FF2B5EF4-FFF2-40B4-BE49-F238E27FC236}">
-                <a16:creationId xmlns:a16="http://schemas.microsoft.com/office/drawing/2014/main" id="{FB97C24A-EE48-4F0F-8BDC-0C35ACC0BFD6}"/>
+                <a16:creationId xmlns:a16="http://schemas.microsoft.com/office/drawing/2014/main" id="{75EE305C-CE39-4F56-AEF1-7206B1651A8A}"/>
               </a:ext>
             </a:extLst>
           </p:cNvPr>
@@ -18708,7 +18708,7 @@
           <p:cNvPr id="16" name="">
             <a:extLst xmlns:a="http://schemas.openxmlformats.org/drawingml/2006/main">
               <a:ext uri="{FF2B5EF4-FFF2-40B4-BE49-F238E27FC236}">
-                <a16:creationId xmlns:a16="http://schemas.microsoft.com/office/drawing/2014/main" id="{7C2D980E-DC05-4045-BAD4-CD9C685406BB}"/>
+                <a16:creationId xmlns:a16="http://schemas.microsoft.com/office/drawing/2014/main" id="{41DCA5FE-AE16-49B7-9FD8-9256B3D447E5}"/>
               </a:ext>
             </a:extLst>
           </p:cNvPr>
@@ -18766,7 +18766,7 @@
           <p:cNvPr id="17" name="">
             <a:extLst xmlns:a="http://schemas.openxmlformats.org/drawingml/2006/main">
               <a:ext uri="{FF2B5EF4-FFF2-40B4-BE49-F238E27FC236}">
-                <a16:creationId xmlns:a16="http://schemas.microsoft.com/office/drawing/2014/main" id="{B9D9FBF1-22D1-4A49-8401-9CA9FFE957BD}"/>
+                <a16:creationId xmlns:a16="http://schemas.microsoft.com/office/drawing/2014/main" id="{67B1DB57-C127-46C6-8191-053FCEE8085F}"/>
               </a:ext>
             </a:extLst>
           </p:cNvPr>
@@ -18951,7 +18951,7 @@
     </p:spTree>
     <p:extLst>
       <p:ext uri="{BB962C8B-B14F-4D97-AF65-F5344CB8AC3E}">
-        <p14:creationId xmlns:p14="http://schemas.microsoft.com/office/powerpoint/2010/main" val="2144141145"/>
+        <p14:creationId xmlns:p14="http://schemas.microsoft.com/office/powerpoint/2010/main" val="663234172"/>
       </p:ext>
     </p:extLst>
   </p:cSld>

</xml_diff>